<commit_message>
Prezentace: nový slide 16 Automatizace a integrace s macOS
Přidán slide mezi Klíčové aplikační funkce (15) a Děkuji (17)
dokumentující nedávno doplněnou funkcionalitu:

1. Shortcuts.app jako job — parametrizovaný RunSpiceHarvesterIntent,
   čeká na dokončení, vrací cestu k results.csv
2. Plánované běhy přes Automation tab (Time of Day)
3. Multi-window architektura — primary + scratch (Cmd+Shift+N)
4. Save / Load Project — .spiceharvester.json snapshot (Cmd+O / Cmd+Shift+S)
5. Otevřít nedávné — security-scoped bookmarks + cross-window sync
6. AppIntents · Siri · Spotlight integration
7. Pipeline menu bar — Cmd+R/. + Cmd+1/2/3 mode shortcuts
8. Health watcher + manuální server recheck

Visual layout naklonovaný ze slide 15 (8 cards grid 4×2). Page numbery
bumped X / 15 → X / 16 ve všech předchozích content slidech.
</commit_message>
<xml_diff>
--- a/docs/SpiceHarvester_Prezentace.pptx
+++ b/docs/SpiceHarvester_Prezentace.pptx
@@ -23,6 +23,7 @@
     <p:sldId id="268" r:id="rId14"/>
     <p:sldId id="269" r:id="rId15"/>
     <p:sldId id="270" r:id="rId16"/>
+    <p:sldId id="275" r:id="rId23"/>
     <p:sldId id="274" r:id="rId17"/>
   </p:sldIdLst>
   <p:sldSz cx="12192000" cy="6858000"/>
@@ -4100,7 +4101,7 @@
                 </a:solidFill>
                 <a:latin typeface="Calibri"/>
               </a:rPr>
-              <a:t>10 / 15</a:t>
+              <a:t>10 / 16</a:t>
             </a:r>
           </a:p>
         </p:txBody>
@@ -6143,7 +6144,7 @@
                 </a:solidFill>
                 <a:latin typeface="Calibri"/>
               </a:rPr>
-              <a:t>11 / 15</a:t>
+              <a:t>11 / 16</a:t>
             </a:r>
           </a:p>
         </p:txBody>
@@ -8953,7 +8954,7 @@
                 </a:solidFill>
                 <a:latin typeface="Calibri"/>
               </a:rPr>
-              <a:t>13 / 15</a:t>
+              <a:t>13 / 16</a:t>
             </a:r>
           </a:p>
         </p:txBody>
@@ -12019,7 +12020,7 @@
                 </a:solidFill>
                 <a:latin typeface="Calibri"/>
               </a:rPr>
-              <a:t>14 / 15</a:t>
+              <a:t>14 / 16</a:t>
             </a:r>
           </a:p>
         </p:txBody>
@@ -14042,7 +14043,7 @@
                 </a:solidFill>
                 <a:latin typeface="Calibri"/>
               </a:rPr>
-              <a:t>15 / 15</a:t>
+              <a:t>15 / 16</a:t>
             </a:r>
           </a:p>
         </p:txBody>
@@ -16147,6 +16148,2252 @@
         <p14:creationId xmlns:p14="http://schemas.microsoft.com/office/powerpoint/2010/main" val="1413184550"/>
       </p:ext>
     </p:extLst>
+  </p:cSld>
+  <p:clrMapOvr>
+    <a:masterClrMapping/>
+  </p:clrMapOvr>
+</p:sld>
+</file>
+
+<file path=ppt/slides/slide17.xml><?xml version="1.0" encoding="utf-8"?>
+<p:sld xmlns:a="http://schemas.openxmlformats.org/drawingml/2006/main" xmlns:p="http://schemas.openxmlformats.org/presentationml/2006/main" xmlns:r="http://schemas.openxmlformats.org/officeDocument/2006/relationships">
+  <p:cSld>
+    <p:spTree>
+      <p:nvGrpSpPr>
+        <p:cNvPr id="1" name=""/>
+        <p:cNvGrpSpPr/>
+        <p:nvPr/>
+      </p:nvGrpSpPr>
+      <p:grpSpPr/>
+      <p:sp>
+        <p:nvSpPr>
+          <p:cNvPr id="2" name="Rectangle 1"/>
+          <p:cNvSpPr/>
+          <p:nvPr/>
+        </p:nvSpPr>
+        <p:spPr>
+          <a:xfrm>
+            <a:off x="0" y="0"/>
+            <a:ext cx="12191695" cy="146304"/>
+          </a:xfrm>
+          <a:prstGeom prst="rect">
+            <a:avLst/>
+          </a:prstGeom>
+          <a:solidFill>
+            <a:srgbClr val="065A82"/>
+          </a:solidFill>
+          <a:ln>
+            <a:noFill/>
+          </a:ln>
+          <a:effectLst/>
+        </p:spPr>
+        <p:style>
+          <a:lnRef idx="1">
+            <a:schemeClr val="accent1"/>
+          </a:lnRef>
+          <a:fillRef idx="3">
+            <a:schemeClr val="accent1"/>
+          </a:fillRef>
+          <a:effectRef idx="2">
+            <a:schemeClr val="accent1"/>
+          </a:effectRef>
+          <a:fontRef idx="minor">
+            <a:schemeClr val="lt1"/>
+          </a:fontRef>
+        </p:style>
+        <p:txBody>
+          <a:bodyPr rtlCol="0" anchor="ctr"/>
+          <a:lstStyle/>
+          <a:p>
+            <a:pPr algn="ctr"/>
+            <a:endParaRPr/>
+          </a:p>
+        </p:txBody>
+      </p:sp>
+      <p:sp>
+        <p:nvSpPr>
+          <p:cNvPr id="3" name="Rectangle 2"/>
+          <p:cNvSpPr/>
+          <p:nvPr/>
+        </p:nvSpPr>
+        <p:spPr>
+          <a:xfrm>
+            <a:off x="0" y="146304"/>
+            <a:ext cx="164592" cy="6711696"/>
+          </a:xfrm>
+          <a:prstGeom prst="rect">
+            <a:avLst/>
+          </a:prstGeom>
+          <a:solidFill>
+            <a:srgbClr val="F5B041"/>
+          </a:solidFill>
+          <a:ln>
+            <a:noFill/>
+          </a:ln>
+          <a:effectLst/>
+        </p:spPr>
+        <p:style>
+          <a:lnRef idx="1">
+            <a:schemeClr val="accent1"/>
+          </a:lnRef>
+          <a:fillRef idx="3">
+            <a:schemeClr val="accent1"/>
+          </a:fillRef>
+          <a:effectRef idx="2">
+            <a:schemeClr val="accent1"/>
+          </a:effectRef>
+          <a:fontRef idx="minor">
+            <a:schemeClr val="lt1"/>
+          </a:fontRef>
+        </p:style>
+        <p:txBody>
+          <a:bodyPr rtlCol="0" anchor="ctr"/>
+          <a:lstStyle/>
+          <a:p>
+            <a:pPr algn="ctr"/>
+            <a:endParaRPr/>
+          </a:p>
+        </p:txBody>
+      </p:sp>
+      <p:sp>
+        <p:nvSpPr>
+          <p:cNvPr id="4" name="TextBox 3"/>
+          <p:cNvSpPr txBox="1"/>
+          <p:nvPr/>
+        </p:nvSpPr>
+        <p:spPr>
+          <a:xfrm>
+            <a:off x="502920" y="365760"/>
+            <a:ext cx="10058400" cy="461665"/>
+          </a:xfrm>
+          <a:prstGeom prst="rect">
+            <a:avLst/>
+          </a:prstGeom>
+          <a:noFill/>
+        </p:spPr>
+        <p:txBody>
+          <a:bodyPr wrap="square" lIns="0" tIns="0" rIns="0" bIns="0" anchor="t">
+            <a:spAutoFit/>
+          </a:bodyPr>
+          <a:lstStyle/>
+          <a:p>
+            <a:pPr algn="l"/>
+            <a:r>
+              <a:rPr sz="3000" b="1" i="0" dirty="0" err="1">
+                <a:solidFill>
+                  <a:srgbClr val="21295C"/>
+                </a:solidFill>
+                <a:latin typeface="Calibri"/>
+              </a:rPr>
+              <a:t>Automatizace a integrace s macOS</a:t>
+            </a:r>
+            <a:endParaRPr sz="3000" b="1" i="0" dirty="0">
+              <a:solidFill>
+                <a:srgbClr val="21295C"/>
+              </a:solidFill>
+              <a:latin typeface="Calibri"/>
+            </a:endParaRPr>
+          </a:p>
+        </p:txBody>
+      </p:sp>
+      <p:sp>
+        <p:nvSpPr>
+          <p:cNvPr id="5" name="TextBox 4"/>
+          <p:cNvSpPr txBox="1"/>
+          <p:nvPr/>
+        </p:nvSpPr>
+        <p:spPr>
+          <a:xfrm>
+            <a:off x="502920" y="960120"/>
+            <a:ext cx="10058400" cy="365760"/>
+          </a:xfrm>
+          <a:prstGeom prst="rect">
+            <a:avLst/>
+          </a:prstGeom>
+          <a:noFill/>
+        </p:spPr>
+        <p:txBody>
+          <a:bodyPr wrap="square" lIns="0" tIns="0" rIns="0" bIns="0" anchor="t">
+            <a:spAutoFit/>
+          </a:bodyPr>
+          <a:lstStyle/>
+          <a:p>
+            <a:pPr algn="l"/>
+            <a:r>
+              <a:rPr sz="1400" b="0" i="1">
+                <a:solidFill>
+                  <a:srgbClr val="1C7293"/>
+                </a:solidFill>
+                <a:latin typeface="Calibri"/>
+              </a:rPr>
+              <a:t>Job-ready Shortcuts, multi-window, projekty, native menu</a:t>
+            </a:r>
+          </a:p>
+        </p:txBody>
+      </p:sp>
+      <p:sp>
+        <p:nvSpPr>
+          <p:cNvPr id="6" name="TextBox 5"/>
+          <p:cNvSpPr txBox="1"/>
+          <p:nvPr/>
+        </p:nvSpPr>
+        <p:spPr>
+          <a:xfrm>
+            <a:off x="10789920" y="6446520"/>
+            <a:ext cx="1280160" cy="320040"/>
+          </a:xfrm>
+          <a:prstGeom prst="rect">
+            <a:avLst/>
+          </a:prstGeom>
+          <a:noFill/>
+        </p:spPr>
+        <p:txBody>
+          <a:bodyPr wrap="square" lIns="0" tIns="0" rIns="0" bIns="0" anchor="t">
+            <a:spAutoFit/>
+          </a:bodyPr>
+          <a:lstStyle/>
+          <a:p>
+            <a:pPr algn="r"/>
+            <a:r>
+              <a:rPr sz="1000" b="0" i="0">
+                <a:solidFill>
+                  <a:srgbClr val="5C6B82"/>
+                </a:solidFill>
+                <a:latin typeface="Calibri"/>
+              </a:rPr>
+              <a:t>16 / 16</a:t>
+            </a:r>
+          </a:p>
+        </p:txBody>
+      </p:sp>
+      <p:sp>
+        <p:nvSpPr>
+          <p:cNvPr id="7" name="TextBox 6"/>
+          <p:cNvSpPr txBox="1"/>
+          <p:nvPr/>
+        </p:nvSpPr>
+        <p:spPr>
+          <a:xfrm>
+            <a:off x="502920" y="6446520"/>
+            <a:ext cx="5486400" cy="320040"/>
+          </a:xfrm>
+          <a:prstGeom prst="rect">
+            <a:avLst/>
+          </a:prstGeom>
+          <a:noFill/>
+        </p:spPr>
+        <p:txBody>
+          <a:bodyPr wrap="square" lIns="0" tIns="0" rIns="0" bIns="0" anchor="t">
+            <a:spAutoFit/>
+          </a:bodyPr>
+          <a:lstStyle/>
+          <a:p>
+            <a:pPr algn="l"/>
+            <a:r>
+              <a:rPr sz="1000" b="0" i="0">
+                <a:solidFill>
+                  <a:srgbClr val="5C6B82"/>
+                </a:solidFill>
+                <a:latin typeface="Calibri"/>
+              </a:rPr>
+              <a:t>SpiceHarvester · Lokální dávkové vytěžování PDF přes LLM</a:t>
+            </a:r>
+          </a:p>
+        </p:txBody>
+      </p:sp>
+      <p:sp>
+        <p:nvSpPr>
+          <p:cNvPr id="8" name="Rectangle 7"/>
+          <p:cNvSpPr/>
+          <p:nvPr/>
+        </p:nvSpPr>
+        <p:spPr>
+          <a:xfrm>
+            <a:off x="502920" y="1463040"/>
+            <a:ext cx="5650992" cy="1078992"/>
+          </a:xfrm>
+          <a:prstGeom prst="rect">
+            <a:avLst/>
+          </a:prstGeom>
+          <a:solidFill>
+            <a:srgbClr val="FFFFFF"/>
+          </a:solidFill>
+          <a:ln w="6350">
+            <a:solidFill>
+              <a:srgbClr val="D8E0EA"/>
+            </a:solidFill>
+          </a:ln>
+          <a:effectLst/>
+        </p:spPr>
+        <p:style>
+          <a:lnRef idx="1">
+            <a:schemeClr val="accent1"/>
+          </a:lnRef>
+          <a:fillRef idx="3">
+            <a:schemeClr val="accent1"/>
+          </a:fillRef>
+          <a:effectRef idx="2">
+            <a:schemeClr val="accent1"/>
+          </a:effectRef>
+          <a:fontRef idx="minor">
+            <a:schemeClr val="lt1"/>
+          </a:fontRef>
+        </p:style>
+        <p:txBody>
+          <a:bodyPr rtlCol="0" anchor="ctr"/>
+          <a:lstStyle/>
+          <a:p>
+            <a:pPr algn="ctr"/>
+            <a:endParaRPr/>
+          </a:p>
+        </p:txBody>
+      </p:sp>
+      <p:sp>
+        <p:nvSpPr>
+          <p:cNvPr id="9" name="Rectangle 8"/>
+          <p:cNvSpPr/>
+          <p:nvPr/>
+        </p:nvSpPr>
+        <p:spPr>
+          <a:xfrm>
+            <a:off x="502920" y="1463040"/>
+            <a:ext cx="73152" cy="1078992"/>
+          </a:xfrm>
+          <a:prstGeom prst="rect">
+            <a:avLst/>
+          </a:prstGeom>
+          <a:solidFill>
+            <a:srgbClr val="1C7293"/>
+          </a:solidFill>
+          <a:ln>
+            <a:noFill/>
+          </a:ln>
+          <a:effectLst/>
+        </p:spPr>
+        <p:style>
+          <a:lnRef idx="1">
+            <a:schemeClr val="accent1"/>
+          </a:lnRef>
+          <a:fillRef idx="3">
+            <a:schemeClr val="accent1"/>
+          </a:fillRef>
+          <a:effectRef idx="2">
+            <a:schemeClr val="accent1"/>
+          </a:effectRef>
+          <a:fontRef idx="minor">
+            <a:schemeClr val="lt1"/>
+          </a:fontRef>
+        </p:style>
+        <p:txBody>
+          <a:bodyPr rtlCol="0" anchor="ctr"/>
+          <a:lstStyle/>
+          <a:p>
+            <a:pPr algn="ctr"/>
+            <a:endParaRPr/>
+          </a:p>
+        </p:txBody>
+      </p:sp>
+      <p:sp>
+        <p:nvSpPr>
+          <p:cNvPr id="10" name="Oval 9"/>
+          <p:cNvSpPr/>
+          <p:nvPr/>
+        </p:nvSpPr>
+        <p:spPr>
+          <a:xfrm>
+            <a:off x="822960" y="1773936"/>
+            <a:ext cx="457200" cy="457200"/>
+          </a:xfrm>
+          <a:prstGeom prst="ellipse">
+            <a:avLst/>
+          </a:prstGeom>
+          <a:solidFill>
+            <a:srgbClr val="065A82"/>
+          </a:solidFill>
+          <a:ln>
+            <a:noFill/>
+          </a:ln>
+          <a:effectLst/>
+        </p:spPr>
+        <p:style>
+          <a:lnRef idx="1">
+            <a:schemeClr val="accent1"/>
+          </a:lnRef>
+          <a:fillRef idx="3">
+            <a:schemeClr val="accent1"/>
+          </a:fillRef>
+          <a:effectRef idx="2">
+            <a:schemeClr val="accent1"/>
+          </a:effectRef>
+          <a:fontRef idx="minor">
+            <a:schemeClr val="lt1"/>
+          </a:fontRef>
+        </p:style>
+        <p:txBody>
+          <a:bodyPr rtlCol="0" anchor="ctr"/>
+          <a:lstStyle/>
+          <a:p>
+            <a:pPr algn="ctr"/>
+            <a:endParaRPr/>
+          </a:p>
+        </p:txBody>
+      </p:sp>
+      <p:sp>
+        <p:nvSpPr>
+          <p:cNvPr id="11" name="TextBox 10"/>
+          <p:cNvSpPr txBox="1"/>
+          <p:nvPr/>
+        </p:nvSpPr>
+        <p:spPr>
+          <a:xfrm>
+            <a:off x="822960" y="1819656"/>
+            <a:ext cx="457200" cy="365760"/>
+          </a:xfrm>
+          <a:prstGeom prst="rect">
+            <a:avLst/>
+          </a:prstGeom>
+          <a:noFill/>
+        </p:spPr>
+        <p:txBody>
+          <a:bodyPr wrap="square" lIns="0" tIns="0" rIns="0" bIns="0" anchor="ctr">
+            <a:spAutoFit/>
+          </a:bodyPr>
+          <a:lstStyle/>
+          <a:p>
+            <a:pPr algn="ctr"/>
+            <a:r>
+              <a:rPr sz="1500" b="1" i="0">
+                <a:solidFill>
+                  <a:srgbClr val="FFFFFF"/>
+                </a:solidFill>
+                <a:latin typeface="Calibri"/>
+              </a:rPr>
+              <a:t>1</a:t>
+            </a:r>
+          </a:p>
+        </p:txBody>
+      </p:sp>
+      <p:sp>
+        <p:nvSpPr>
+          <p:cNvPr id="12" name="TextBox 11"/>
+          <p:cNvSpPr txBox="1"/>
+          <p:nvPr/>
+        </p:nvSpPr>
+        <p:spPr>
+          <a:xfrm>
+            <a:off x="1463040" y="1609344"/>
+            <a:ext cx="4553712" cy="329184"/>
+          </a:xfrm>
+          <a:prstGeom prst="rect">
+            <a:avLst/>
+          </a:prstGeom>
+          <a:noFill/>
+        </p:spPr>
+        <p:txBody>
+          <a:bodyPr wrap="square" lIns="0" tIns="0" rIns="0" bIns="0" anchor="t">
+            <a:spAutoFit/>
+          </a:bodyPr>
+          <a:lstStyle/>
+          <a:p>
+            <a:pPr algn="l"/>
+            <a:r>
+              <a:rPr sz="1400" b="1" i="0">
+                <a:solidFill>
+                  <a:srgbClr val="21295C"/>
+                </a:solidFill>
+                <a:latin typeface="Calibri"/>
+              </a:rPr>
+              <a:t>Shortcuts.app jako job</a:t>
+            </a:r>
+          </a:p>
+        </p:txBody>
+      </p:sp>
+      <p:sp>
+        <p:nvSpPr>
+          <p:cNvPr id="13" name="TextBox 12"/>
+          <p:cNvSpPr txBox="1"/>
+          <p:nvPr/>
+        </p:nvSpPr>
+        <p:spPr>
+          <a:xfrm>
+            <a:off x="1463040" y="1938528"/>
+            <a:ext cx="4553712" cy="566928"/>
+          </a:xfrm>
+          <a:prstGeom prst="rect">
+            <a:avLst/>
+          </a:prstGeom>
+          <a:noFill/>
+        </p:spPr>
+        <p:txBody>
+          <a:bodyPr wrap="square" lIns="0" tIns="0" rIns="0" bIns="0">
+            <a:spAutoFit/>
+          </a:bodyPr>
+          <a:lstStyle/>
+          <a:p>
+            <a:pPr algn="l">
+              <a:lnSpc>
+                <a:spcPct val="125000"/>
+              </a:lnSpc>
+              <a:spcAft>
+                <a:spcPts val="400"/>
+              </a:spcAft>
+            </a:pPr>
+            <a:r>
+              <a:rPr sz="1100" b="0" i="0">
+                <a:solidFill>
+                  <a:srgbClr val="5C6B82"/>
+                </a:solidFill>
+                <a:latin typeface="Calibri"/>
+              </a:rPr>
+              <a:t>Akce Spustit extrakci s volitelnými parametry Režim a Název promptu. perform() ČEKÁ na dokončení a vrátí cestu k results.csv pro řetězení dalších kroků.</a:t>
+            </a:r>
+          </a:p>
+        </p:txBody>
+      </p:sp>
+      <p:sp>
+        <p:nvSpPr>
+          <p:cNvPr id="14" name="Rectangle 13"/>
+          <p:cNvSpPr/>
+          <p:nvPr/>
+        </p:nvSpPr>
+        <p:spPr>
+          <a:xfrm>
+            <a:off x="6291072" y="1463040"/>
+            <a:ext cx="5650992" cy="1078992"/>
+          </a:xfrm>
+          <a:prstGeom prst="rect">
+            <a:avLst/>
+          </a:prstGeom>
+          <a:solidFill>
+            <a:srgbClr val="FFFFFF"/>
+          </a:solidFill>
+          <a:ln w="6350">
+            <a:solidFill>
+              <a:srgbClr val="D8E0EA"/>
+            </a:solidFill>
+          </a:ln>
+          <a:effectLst/>
+        </p:spPr>
+        <p:style>
+          <a:lnRef idx="1">
+            <a:schemeClr val="accent1"/>
+          </a:lnRef>
+          <a:fillRef idx="3">
+            <a:schemeClr val="accent1"/>
+          </a:fillRef>
+          <a:effectRef idx="2">
+            <a:schemeClr val="accent1"/>
+          </a:effectRef>
+          <a:fontRef idx="minor">
+            <a:schemeClr val="lt1"/>
+          </a:fontRef>
+        </p:style>
+        <p:txBody>
+          <a:bodyPr rtlCol="0" anchor="ctr"/>
+          <a:lstStyle/>
+          <a:p>
+            <a:pPr algn="ctr"/>
+            <a:endParaRPr/>
+          </a:p>
+        </p:txBody>
+      </p:sp>
+      <p:sp>
+        <p:nvSpPr>
+          <p:cNvPr id="15" name="Rectangle 14"/>
+          <p:cNvSpPr/>
+          <p:nvPr/>
+        </p:nvSpPr>
+        <p:spPr>
+          <a:xfrm>
+            <a:off x="6291072" y="1463040"/>
+            <a:ext cx="73152" cy="1078992"/>
+          </a:xfrm>
+          <a:prstGeom prst="rect">
+            <a:avLst/>
+          </a:prstGeom>
+          <a:solidFill>
+            <a:srgbClr val="1C7293"/>
+          </a:solidFill>
+          <a:ln>
+            <a:noFill/>
+          </a:ln>
+          <a:effectLst/>
+        </p:spPr>
+        <p:style>
+          <a:lnRef idx="1">
+            <a:schemeClr val="accent1"/>
+          </a:lnRef>
+          <a:fillRef idx="3">
+            <a:schemeClr val="accent1"/>
+          </a:fillRef>
+          <a:effectRef idx="2">
+            <a:schemeClr val="accent1"/>
+          </a:effectRef>
+          <a:fontRef idx="minor">
+            <a:schemeClr val="lt1"/>
+          </a:fontRef>
+        </p:style>
+        <p:txBody>
+          <a:bodyPr rtlCol="0" anchor="ctr"/>
+          <a:lstStyle/>
+          <a:p>
+            <a:pPr algn="ctr"/>
+            <a:endParaRPr/>
+          </a:p>
+        </p:txBody>
+      </p:sp>
+      <p:sp>
+        <p:nvSpPr>
+          <p:cNvPr id="16" name="Oval 15"/>
+          <p:cNvSpPr/>
+          <p:nvPr/>
+        </p:nvSpPr>
+        <p:spPr>
+          <a:xfrm>
+            <a:off x="6611112" y="1773936"/>
+            <a:ext cx="457200" cy="457200"/>
+          </a:xfrm>
+          <a:prstGeom prst="ellipse">
+            <a:avLst/>
+          </a:prstGeom>
+          <a:solidFill>
+            <a:srgbClr val="065A82"/>
+          </a:solidFill>
+          <a:ln>
+            <a:noFill/>
+          </a:ln>
+          <a:effectLst/>
+        </p:spPr>
+        <p:style>
+          <a:lnRef idx="1">
+            <a:schemeClr val="accent1"/>
+          </a:lnRef>
+          <a:fillRef idx="3">
+            <a:schemeClr val="accent1"/>
+          </a:fillRef>
+          <a:effectRef idx="2">
+            <a:schemeClr val="accent1"/>
+          </a:effectRef>
+          <a:fontRef idx="minor">
+            <a:schemeClr val="lt1"/>
+          </a:fontRef>
+        </p:style>
+        <p:txBody>
+          <a:bodyPr rtlCol="0" anchor="ctr"/>
+          <a:lstStyle/>
+          <a:p>
+            <a:pPr algn="ctr"/>
+            <a:endParaRPr/>
+          </a:p>
+        </p:txBody>
+      </p:sp>
+      <p:sp>
+        <p:nvSpPr>
+          <p:cNvPr id="17" name="TextBox 16"/>
+          <p:cNvSpPr txBox="1"/>
+          <p:nvPr/>
+        </p:nvSpPr>
+        <p:spPr>
+          <a:xfrm>
+            <a:off x="6611112" y="1819656"/>
+            <a:ext cx="457200" cy="365760"/>
+          </a:xfrm>
+          <a:prstGeom prst="rect">
+            <a:avLst/>
+          </a:prstGeom>
+          <a:noFill/>
+        </p:spPr>
+        <p:txBody>
+          <a:bodyPr wrap="square" lIns="0" tIns="0" rIns="0" bIns="0" anchor="ctr">
+            <a:spAutoFit/>
+          </a:bodyPr>
+          <a:lstStyle/>
+          <a:p>
+            <a:pPr algn="ctr"/>
+            <a:r>
+              <a:rPr sz="1500" b="1" i="0">
+                <a:solidFill>
+                  <a:srgbClr val="FFFFFF"/>
+                </a:solidFill>
+                <a:latin typeface="Calibri"/>
+              </a:rPr>
+              <a:t>2</a:t>
+            </a:r>
+          </a:p>
+        </p:txBody>
+      </p:sp>
+      <p:sp>
+        <p:nvSpPr>
+          <p:cNvPr id="18" name="TextBox 17"/>
+          <p:cNvSpPr txBox="1"/>
+          <p:nvPr/>
+        </p:nvSpPr>
+        <p:spPr>
+          <a:xfrm>
+            <a:off x="7251192" y="1609344"/>
+            <a:ext cx="4553712" cy="329184"/>
+          </a:xfrm>
+          <a:prstGeom prst="rect">
+            <a:avLst/>
+          </a:prstGeom>
+          <a:noFill/>
+        </p:spPr>
+        <p:txBody>
+          <a:bodyPr wrap="square" lIns="0" tIns="0" rIns="0" bIns="0" anchor="t">
+            <a:spAutoFit/>
+          </a:bodyPr>
+          <a:lstStyle/>
+          <a:p>
+            <a:pPr algn="l"/>
+            <a:r>
+              <a:rPr sz="1400" b="1" i="0">
+                <a:solidFill>
+                  <a:srgbClr val="21295C"/>
+                </a:solidFill>
+                <a:latin typeface="Calibri"/>
+              </a:rPr>
+              <a:t>Plánované běhy (cron-like)</a:t>
+            </a:r>
+          </a:p>
+        </p:txBody>
+      </p:sp>
+      <p:sp>
+        <p:nvSpPr>
+          <p:cNvPr id="19" name="TextBox 18"/>
+          <p:cNvSpPr txBox="1"/>
+          <p:nvPr/>
+        </p:nvSpPr>
+        <p:spPr>
+          <a:xfrm>
+            <a:off x="7251192" y="1938528"/>
+            <a:ext cx="4553712" cy="566928"/>
+          </a:xfrm>
+          <a:prstGeom prst="rect">
+            <a:avLst/>
+          </a:prstGeom>
+          <a:noFill/>
+        </p:spPr>
+        <p:txBody>
+          <a:bodyPr wrap="square" lIns="0" tIns="0" rIns="0" bIns="0">
+            <a:spAutoFit/>
+          </a:bodyPr>
+          <a:lstStyle/>
+          <a:p>
+            <a:pPr algn="l">
+              <a:lnSpc>
+                <a:spcPct val="125000"/>
+              </a:lnSpc>
+              <a:spcAft>
+                <a:spcPts val="400"/>
+              </a:spcAft>
+            </a:pPr>
+            <a:r>
+              <a:rPr sz="1100" b="0" i="0">
+                <a:solidFill>
+                  <a:srgbClr val="5C6B82"/>
+                </a:solidFill>
+                <a:latin typeface="Calibri"/>
+              </a:rPr>
+              <a:t>Zkratky.app → Automatizace → Time of Day. Denní extrakce v 8:00, navazující akce: poslat CSV na mail, push do gitu, notify na Slack. Bez Ask Before Running tichý běh.</a:t>
+            </a:r>
+          </a:p>
+        </p:txBody>
+      </p:sp>
+      <p:sp>
+        <p:nvSpPr>
+          <p:cNvPr id="20" name="Rectangle 19"/>
+          <p:cNvSpPr/>
+          <p:nvPr/>
+        </p:nvSpPr>
+        <p:spPr>
+          <a:xfrm>
+            <a:off x="502920" y="2633472"/>
+            <a:ext cx="5650992" cy="1078992"/>
+          </a:xfrm>
+          <a:prstGeom prst="rect">
+            <a:avLst/>
+          </a:prstGeom>
+          <a:solidFill>
+            <a:srgbClr val="FFFFFF"/>
+          </a:solidFill>
+          <a:ln w="6350">
+            <a:solidFill>
+              <a:srgbClr val="D8E0EA"/>
+            </a:solidFill>
+          </a:ln>
+          <a:effectLst/>
+        </p:spPr>
+        <p:style>
+          <a:lnRef idx="1">
+            <a:schemeClr val="accent1"/>
+          </a:lnRef>
+          <a:fillRef idx="3">
+            <a:schemeClr val="accent1"/>
+          </a:fillRef>
+          <a:effectRef idx="2">
+            <a:schemeClr val="accent1"/>
+          </a:effectRef>
+          <a:fontRef idx="minor">
+            <a:schemeClr val="lt1"/>
+          </a:fontRef>
+        </p:style>
+        <p:txBody>
+          <a:bodyPr rtlCol="0" anchor="ctr"/>
+          <a:lstStyle/>
+          <a:p>
+            <a:pPr algn="ctr"/>
+            <a:endParaRPr/>
+          </a:p>
+        </p:txBody>
+      </p:sp>
+      <p:sp>
+        <p:nvSpPr>
+          <p:cNvPr id="21" name="Rectangle 20"/>
+          <p:cNvSpPr/>
+          <p:nvPr/>
+        </p:nvSpPr>
+        <p:spPr>
+          <a:xfrm>
+            <a:off x="502920" y="2633472"/>
+            <a:ext cx="73152" cy="1078992"/>
+          </a:xfrm>
+          <a:prstGeom prst="rect">
+            <a:avLst/>
+          </a:prstGeom>
+          <a:solidFill>
+            <a:srgbClr val="1C7293"/>
+          </a:solidFill>
+          <a:ln>
+            <a:noFill/>
+          </a:ln>
+          <a:effectLst/>
+        </p:spPr>
+        <p:style>
+          <a:lnRef idx="1">
+            <a:schemeClr val="accent1"/>
+          </a:lnRef>
+          <a:fillRef idx="3">
+            <a:schemeClr val="accent1"/>
+          </a:fillRef>
+          <a:effectRef idx="2">
+            <a:schemeClr val="accent1"/>
+          </a:effectRef>
+          <a:fontRef idx="minor">
+            <a:schemeClr val="lt1"/>
+          </a:fontRef>
+        </p:style>
+        <p:txBody>
+          <a:bodyPr rtlCol="0" anchor="ctr"/>
+          <a:lstStyle/>
+          <a:p>
+            <a:pPr algn="ctr"/>
+            <a:endParaRPr/>
+          </a:p>
+        </p:txBody>
+      </p:sp>
+      <p:sp>
+        <p:nvSpPr>
+          <p:cNvPr id="22" name="Oval 21"/>
+          <p:cNvSpPr/>
+          <p:nvPr/>
+        </p:nvSpPr>
+        <p:spPr>
+          <a:xfrm>
+            <a:off x="822960" y="2944368"/>
+            <a:ext cx="457200" cy="457200"/>
+          </a:xfrm>
+          <a:prstGeom prst="ellipse">
+            <a:avLst/>
+          </a:prstGeom>
+          <a:solidFill>
+            <a:srgbClr val="065A82"/>
+          </a:solidFill>
+          <a:ln>
+            <a:noFill/>
+          </a:ln>
+          <a:effectLst/>
+        </p:spPr>
+        <p:style>
+          <a:lnRef idx="1">
+            <a:schemeClr val="accent1"/>
+          </a:lnRef>
+          <a:fillRef idx="3">
+            <a:schemeClr val="accent1"/>
+          </a:fillRef>
+          <a:effectRef idx="2">
+            <a:schemeClr val="accent1"/>
+          </a:effectRef>
+          <a:fontRef idx="minor">
+            <a:schemeClr val="lt1"/>
+          </a:fontRef>
+        </p:style>
+        <p:txBody>
+          <a:bodyPr rtlCol="0" anchor="ctr"/>
+          <a:lstStyle/>
+          <a:p>
+            <a:pPr algn="ctr"/>
+            <a:endParaRPr/>
+          </a:p>
+        </p:txBody>
+      </p:sp>
+      <p:sp>
+        <p:nvSpPr>
+          <p:cNvPr id="23" name="TextBox 22"/>
+          <p:cNvSpPr txBox="1"/>
+          <p:nvPr/>
+        </p:nvSpPr>
+        <p:spPr>
+          <a:xfrm>
+            <a:off x="822960" y="2990088"/>
+            <a:ext cx="457200" cy="365760"/>
+          </a:xfrm>
+          <a:prstGeom prst="rect">
+            <a:avLst/>
+          </a:prstGeom>
+          <a:noFill/>
+        </p:spPr>
+        <p:txBody>
+          <a:bodyPr wrap="square" lIns="0" tIns="0" rIns="0" bIns="0" anchor="ctr">
+            <a:spAutoFit/>
+          </a:bodyPr>
+          <a:lstStyle/>
+          <a:p>
+            <a:pPr algn="ctr"/>
+            <a:r>
+              <a:rPr sz="1500" b="1" i="0">
+                <a:solidFill>
+                  <a:srgbClr val="FFFFFF"/>
+                </a:solidFill>
+                <a:latin typeface="Calibri"/>
+              </a:rPr>
+              <a:t>3</a:t>
+            </a:r>
+          </a:p>
+        </p:txBody>
+      </p:sp>
+      <p:sp>
+        <p:nvSpPr>
+          <p:cNvPr id="24" name="TextBox 23"/>
+          <p:cNvSpPr txBox="1"/>
+          <p:nvPr/>
+        </p:nvSpPr>
+        <p:spPr>
+          <a:xfrm>
+            <a:off x="1463040" y="2779776"/>
+            <a:ext cx="4553712" cy="329184"/>
+          </a:xfrm>
+          <a:prstGeom prst="rect">
+            <a:avLst/>
+          </a:prstGeom>
+          <a:noFill/>
+        </p:spPr>
+        <p:txBody>
+          <a:bodyPr wrap="square" lIns="0" tIns="0" rIns="0" bIns="0" anchor="t">
+            <a:spAutoFit/>
+          </a:bodyPr>
+          <a:lstStyle/>
+          <a:p>
+            <a:pPr algn="l"/>
+            <a:r>
+              <a:rPr sz="1400" b="1" i="0">
+                <a:solidFill>
+                  <a:srgbClr val="21295C"/>
+                </a:solidFill>
+                <a:latin typeface="Calibri"/>
+              </a:rPr>
+              <a:t>Multi-window architektura</a:t>
+            </a:r>
+          </a:p>
+        </p:txBody>
+      </p:sp>
+      <p:sp>
+        <p:nvSpPr>
+          <p:cNvPr id="25" name="TextBox 24"/>
+          <p:cNvSpPr txBox="1"/>
+          <p:nvPr/>
+        </p:nvSpPr>
+        <p:spPr>
+          <a:xfrm>
+            <a:off x="1463040" y="3108960"/>
+            <a:ext cx="4553712" cy="566928"/>
+          </a:xfrm>
+          <a:prstGeom prst="rect">
+            <a:avLst/>
+          </a:prstGeom>
+          <a:noFill/>
+        </p:spPr>
+        <p:txBody>
+          <a:bodyPr wrap="square" lIns="0" tIns="0" rIns="0" bIns="0">
+            <a:spAutoFit/>
+          </a:bodyPr>
+          <a:lstStyle/>
+          <a:p>
+            <a:pPr algn="l">
+              <a:lnSpc>
+                <a:spcPct val="125000"/>
+              </a:lnSpc>
+              <a:spcAft>
+                <a:spcPts val="400"/>
+              </a:spcAft>
+            </a:pPr>
+            <a:r>
+              <a:rPr sz="1100" b="0" i="0">
+                <a:solidFill>
+                  <a:srgbClr val="5C6B82"/>
+                </a:solidFill>
+                <a:latin typeface="Calibri"/>
+              </a:rPr>
+              <a:t>Primary okno persistuje config; scratch okna (Cmd+Shift+N) mají izolovaný stav. Per-window PersistenceMode chrání primary's UserDefaults před experimenty.</a:t>
+            </a:r>
+          </a:p>
+        </p:txBody>
+      </p:sp>
+      <p:sp>
+        <p:nvSpPr>
+          <p:cNvPr id="26" name="Rectangle 25"/>
+          <p:cNvSpPr/>
+          <p:nvPr/>
+        </p:nvSpPr>
+        <p:spPr>
+          <a:xfrm>
+            <a:off x="6291072" y="2633472"/>
+            <a:ext cx="5650992" cy="1078992"/>
+          </a:xfrm>
+          <a:prstGeom prst="rect">
+            <a:avLst/>
+          </a:prstGeom>
+          <a:solidFill>
+            <a:srgbClr val="FFFFFF"/>
+          </a:solidFill>
+          <a:ln w="6350">
+            <a:solidFill>
+              <a:srgbClr val="D8E0EA"/>
+            </a:solidFill>
+          </a:ln>
+          <a:effectLst/>
+        </p:spPr>
+        <p:style>
+          <a:lnRef idx="1">
+            <a:schemeClr val="accent1"/>
+          </a:lnRef>
+          <a:fillRef idx="3">
+            <a:schemeClr val="accent1"/>
+          </a:fillRef>
+          <a:effectRef idx="2">
+            <a:schemeClr val="accent1"/>
+          </a:effectRef>
+          <a:fontRef idx="minor">
+            <a:schemeClr val="lt1"/>
+          </a:fontRef>
+        </p:style>
+        <p:txBody>
+          <a:bodyPr rtlCol="0" anchor="ctr"/>
+          <a:lstStyle/>
+          <a:p>
+            <a:pPr algn="ctr"/>
+            <a:endParaRPr/>
+          </a:p>
+        </p:txBody>
+      </p:sp>
+      <p:sp>
+        <p:nvSpPr>
+          <p:cNvPr id="27" name="Rectangle 26"/>
+          <p:cNvSpPr/>
+          <p:nvPr/>
+        </p:nvSpPr>
+        <p:spPr>
+          <a:xfrm>
+            <a:off x="6291072" y="2633472"/>
+            <a:ext cx="73152" cy="1078992"/>
+          </a:xfrm>
+          <a:prstGeom prst="rect">
+            <a:avLst/>
+          </a:prstGeom>
+          <a:solidFill>
+            <a:srgbClr val="1C7293"/>
+          </a:solidFill>
+          <a:ln>
+            <a:noFill/>
+          </a:ln>
+          <a:effectLst/>
+        </p:spPr>
+        <p:style>
+          <a:lnRef idx="1">
+            <a:schemeClr val="accent1"/>
+          </a:lnRef>
+          <a:fillRef idx="3">
+            <a:schemeClr val="accent1"/>
+          </a:fillRef>
+          <a:effectRef idx="2">
+            <a:schemeClr val="accent1"/>
+          </a:effectRef>
+          <a:fontRef idx="minor">
+            <a:schemeClr val="lt1"/>
+          </a:fontRef>
+        </p:style>
+        <p:txBody>
+          <a:bodyPr rtlCol="0" anchor="ctr"/>
+          <a:lstStyle/>
+          <a:p>
+            <a:pPr algn="ctr"/>
+            <a:endParaRPr/>
+          </a:p>
+        </p:txBody>
+      </p:sp>
+      <p:sp>
+        <p:nvSpPr>
+          <p:cNvPr id="28" name="Oval 27"/>
+          <p:cNvSpPr/>
+          <p:nvPr/>
+        </p:nvSpPr>
+        <p:spPr>
+          <a:xfrm>
+            <a:off x="6611112" y="2944368"/>
+            <a:ext cx="457200" cy="457200"/>
+          </a:xfrm>
+          <a:prstGeom prst="ellipse">
+            <a:avLst/>
+          </a:prstGeom>
+          <a:solidFill>
+            <a:srgbClr val="065A82"/>
+          </a:solidFill>
+          <a:ln>
+            <a:noFill/>
+          </a:ln>
+          <a:effectLst/>
+        </p:spPr>
+        <p:style>
+          <a:lnRef idx="1">
+            <a:schemeClr val="accent1"/>
+          </a:lnRef>
+          <a:fillRef idx="3">
+            <a:schemeClr val="accent1"/>
+          </a:fillRef>
+          <a:effectRef idx="2">
+            <a:schemeClr val="accent1"/>
+          </a:effectRef>
+          <a:fontRef idx="minor">
+            <a:schemeClr val="lt1"/>
+          </a:fontRef>
+        </p:style>
+        <p:txBody>
+          <a:bodyPr rtlCol="0" anchor="ctr"/>
+          <a:lstStyle/>
+          <a:p>
+            <a:pPr algn="ctr"/>
+            <a:endParaRPr/>
+          </a:p>
+        </p:txBody>
+      </p:sp>
+      <p:sp>
+        <p:nvSpPr>
+          <p:cNvPr id="29" name="TextBox 28"/>
+          <p:cNvSpPr txBox="1"/>
+          <p:nvPr/>
+        </p:nvSpPr>
+        <p:spPr>
+          <a:xfrm>
+            <a:off x="6611112" y="2990088"/>
+            <a:ext cx="457200" cy="365760"/>
+          </a:xfrm>
+          <a:prstGeom prst="rect">
+            <a:avLst/>
+          </a:prstGeom>
+          <a:noFill/>
+        </p:spPr>
+        <p:txBody>
+          <a:bodyPr wrap="square" lIns="0" tIns="0" rIns="0" bIns="0" anchor="ctr">
+            <a:spAutoFit/>
+          </a:bodyPr>
+          <a:lstStyle/>
+          <a:p>
+            <a:pPr algn="ctr"/>
+            <a:r>
+              <a:rPr sz="1500" b="1" i="0">
+                <a:solidFill>
+                  <a:srgbClr val="FFFFFF"/>
+                </a:solidFill>
+                <a:latin typeface="Calibri"/>
+              </a:rPr>
+              <a:t>4</a:t>
+            </a:r>
+          </a:p>
+        </p:txBody>
+      </p:sp>
+      <p:sp>
+        <p:nvSpPr>
+          <p:cNvPr id="30" name="TextBox 29"/>
+          <p:cNvSpPr txBox="1"/>
+          <p:nvPr/>
+        </p:nvSpPr>
+        <p:spPr>
+          <a:xfrm>
+            <a:off x="7251192" y="2779776"/>
+            <a:ext cx="4553712" cy="329184"/>
+          </a:xfrm>
+          <a:prstGeom prst="rect">
+            <a:avLst/>
+          </a:prstGeom>
+          <a:noFill/>
+        </p:spPr>
+        <p:txBody>
+          <a:bodyPr wrap="square" lIns="0" tIns="0" rIns="0" bIns="0" anchor="t">
+            <a:spAutoFit/>
+          </a:bodyPr>
+          <a:lstStyle/>
+          <a:p>
+            <a:pPr algn="l"/>
+            <a:r>
+              <a:rPr sz="1400" b="1" i="0">
+                <a:solidFill>
+                  <a:srgbClr val="21295C"/>
+                </a:solidFill>
+                <a:latin typeface="Calibri"/>
+              </a:rPr>
+              <a:t>Save / Load Project</a:t>
+            </a:r>
+          </a:p>
+        </p:txBody>
+      </p:sp>
+      <p:sp>
+        <p:nvSpPr>
+          <p:cNvPr id="31" name="TextBox 30"/>
+          <p:cNvSpPr txBox="1"/>
+          <p:nvPr/>
+        </p:nvSpPr>
+        <p:spPr>
+          <a:xfrm>
+            <a:off x="7251192" y="3108960"/>
+            <a:ext cx="4553712" cy="566928"/>
+          </a:xfrm>
+          <a:prstGeom prst="rect">
+            <a:avLst/>
+          </a:prstGeom>
+          <a:noFill/>
+        </p:spPr>
+        <p:txBody>
+          <a:bodyPr wrap="square" lIns="0" tIns="0" rIns="0" bIns="0">
+            <a:spAutoFit/>
+          </a:bodyPr>
+          <a:lstStyle/>
+          <a:p>
+            <a:pPr algn="l">
+              <a:lnSpc>
+                <a:spcPct val="125000"/>
+              </a:lnSpc>
+              <a:spcAft>
+                <a:spcPts val="400"/>
+              </a:spcAft>
+            </a:pPr>
+            <a:r>
+              <a:rPr sz="1100" b="0" i="0">
+                <a:solidFill>
+                  <a:srgbClr val="5C6B82"/>
+                </a:solidFill>
+                <a:latin typeface="Calibri"/>
+              </a:rPr>
+              <a:t>.spiceharvester.json snapshot: folders + model + prompt + režim. Cmd+Shift+S uloží, Cmd+O načte. Server registry zůstává globální (mezi projekty se nemíchá).</a:t>
+            </a:r>
+          </a:p>
+        </p:txBody>
+      </p:sp>
+      <p:sp>
+        <p:nvSpPr>
+          <p:cNvPr id="32" name="Rectangle 31"/>
+          <p:cNvSpPr/>
+          <p:nvPr/>
+        </p:nvSpPr>
+        <p:spPr>
+          <a:xfrm>
+            <a:off x="502920" y="3803904"/>
+            <a:ext cx="5650992" cy="1078992"/>
+          </a:xfrm>
+          <a:prstGeom prst="rect">
+            <a:avLst/>
+          </a:prstGeom>
+          <a:solidFill>
+            <a:srgbClr val="FFFFFF"/>
+          </a:solidFill>
+          <a:ln w="6350">
+            <a:solidFill>
+              <a:srgbClr val="D8E0EA"/>
+            </a:solidFill>
+          </a:ln>
+          <a:effectLst/>
+        </p:spPr>
+        <p:style>
+          <a:lnRef idx="1">
+            <a:schemeClr val="accent1"/>
+          </a:lnRef>
+          <a:fillRef idx="3">
+            <a:schemeClr val="accent1"/>
+          </a:fillRef>
+          <a:effectRef idx="2">
+            <a:schemeClr val="accent1"/>
+          </a:effectRef>
+          <a:fontRef idx="minor">
+            <a:schemeClr val="lt1"/>
+          </a:fontRef>
+        </p:style>
+        <p:txBody>
+          <a:bodyPr rtlCol="0" anchor="ctr"/>
+          <a:lstStyle/>
+          <a:p>
+            <a:pPr algn="ctr"/>
+            <a:endParaRPr/>
+          </a:p>
+        </p:txBody>
+      </p:sp>
+      <p:sp>
+        <p:nvSpPr>
+          <p:cNvPr id="33" name="Rectangle 32"/>
+          <p:cNvSpPr/>
+          <p:nvPr/>
+        </p:nvSpPr>
+        <p:spPr>
+          <a:xfrm>
+            <a:off x="502920" y="3803904"/>
+            <a:ext cx="73152" cy="1078992"/>
+          </a:xfrm>
+          <a:prstGeom prst="rect">
+            <a:avLst/>
+          </a:prstGeom>
+          <a:solidFill>
+            <a:srgbClr val="1C7293"/>
+          </a:solidFill>
+          <a:ln>
+            <a:noFill/>
+          </a:ln>
+          <a:effectLst/>
+        </p:spPr>
+        <p:style>
+          <a:lnRef idx="1">
+            <a:schemeClr val="accent1"/>
+          </a:lnRef>
+          <a:fillRef idx="3">
+            <a:schemeClr val="accent1"/>
+          </a:fillRef>
+          <a:effectRef idx="2">
+            <a:schemeClr val="accent1"/>
+          </a:effectRef>
+          <a:fontRef idx="minor">
+            <a:schemeClr val="lt1"/>
+          </a:fontRef>
+        </p:style>
+        <p:txBody>
+          <a:bodyPr rtlCol="0" anchor="ctr"/>
+          <a:lstStyle/>
+          <a:p>
+            <a:pPr algn="ctr"/>
+            <a:endParaRPr/>
+          </a:p>
+        </p:txBody>
+      </p:sp>
+      <p:sp>
+        <p:nvSpPr>
+          <p:cNvPr id="34" name="Oval 33"/>
+          <p:cNvSpPr/>
+          <p:nvPr/>
+        </p:nvSpPr>
+        <p:spPr>
+          <a:xfrm>
+            <a:off x="822960" y="4114800"/>
+            <a:ext cx="457200" cy="457200"/>
+          </a:xfrm>
+          <a:prstGeom prst="ellipse">
+            <a:avLst/>
+          </a:prstGeom>
+          <a:solidFill>
+            <a:srgbClr val="065A82"/>
+          </a:solidFill>
+          <a:ln>
+            <a:noFill/>
+          </a:ln>
+          <a:effectLst/>
+        </p:spPr>
+        <p:style>
+          <a:lnRef idx="1">
+            <a:schemeClr val="accent1"/>
+          </a:lnRef>
+          <a:fillRef idx="3">
+            <a:schemeClr val="accent1"/>
+          </a:fillRef>
+          <a:effectRef idx="2">
+            <a:schemeClr val="accent1"/>
+          </a:effectRef>
+          <a:fontRef idx="minor">
+            <a:schemeClr val="lt1"/>
+          </a:fontRef>
+        </p:style>
+        <p:txBody>
+          <a:bodyPr rtlCol="0" anchor="ctr"/>
+          <a:lstStyle/>
+          <a:p>
+            <a:pPr algn="ctr"/>
+            <a:endParaRPr/>
+          </a:p>
+        </p:txBody>
+      </p:sp>
+      <p:sp>
+        <p:nvSpPr>
+          <p:cNvPr id="35" name="TextBox 34"/>
+          <p:cNvSpPr txBox="1"/>
+          <p:nvPr/>
+        </p:nvSpPr>
+        <p:spPr>
+          <a:xfrm>
+            <a:off x="822960" y="4160520"/>
+            <a:ext cx="457200" cy="365760"/>
+          </a:xfrm>
+          <a:prstGeom prst="rect">
+            <a:avLst/>
+          </a:prstGeom>
+          <a:noFill/>
+        </p:spPr>
+        <p:txBody>
+          <a:bodyPr wrap="square" lIns="0" tIns="0" rIns="0" bIns="0" anchor="ctr">
+            <a:spAutoFit/>
+          </a:bodyPr>
+          <a:lstStyle/>
+          <a:p>
+            <a:pPr algn="ctr"/>
+            <a:r>
+              <a:rPr sz="1500" b="1" i="0">
+                <a:solidFill>
+                  <a:srgbClr val="FFFFFF"/>
+                </a:solidFill>
+                <a:latin typeface="Calibri"/>
+              </a:rPr>
+              <a:t>5</a:t>
+            </a:r>
+          </a:p>
+        </p:txBody>
+      </p:sp>
+      <p:sp>
+        <p:nvSpPr>
+          <p:cNvPr id="36" name="TextBox 35"/>
+          <p:cNvSpPr txBox="1"/>
+          <p:nvPr/>
+        </p:nvSpPr>
+        <p:spPr>
+          <a:xfrm>
+            <a:off x="1463040" y="3950208"/>
+            <a:ext cx="4553712" cy="329184"/>
+          </a:xfrm>
+          <a:prstGeom prst="rect">
+            <a:avLst/>
+          </a:prstGeom>
+          <a:noFill/>
+        </p:spPr>
+        <p:txBody>
+          <a:bodyPr wrap="square" lIns="0" tIns="0" rIns="0" bIns="0" anchor="t">
+            <a:spAutoFit/>
+          </a:bodyPr>
+          <a:lstStyle/>
+          <a:p>
+            <a:pPr algn="l"/>
+            <a:r>
+              <a:rPr sz="1400" b="1" i="0">
+                <a:solidFill>
+                  <a:srgbClr val="21295C"/>
+                </a:solidFill>
+                <a:latin typeface="Calibri"/>
+              </a:rPr>
+              <a:t>Otevřít nedávné · sandbox-aware</a:t>
+            </a:r>
+          </a:p>
+        </p:txBody>
+      </p:sp>
+      <p:sp>
+        <p:nvSpPr>
+          <p:cNvPr id="37" name="TextBox 36"/>
+          <p:cNvSpPr txBox="1"/>
+          <p:nvPr/>
+        </p:nvSpPr>
+        <p:spPr>
+          <a:xfrm>
+            <a:off x="1463040" y="4279392"/>
+            <a:ext cx="4553712" cy="566928"/>
+          </a:xfrm>
+          <a:prstGeom prst="rect">
+            <a:avLst/>
+          </a:prstGeom>
+          <a:noFill/>
+        </p:spPr>
+        <p:txBody>
+          <a:bodyPr wrap="square" lIns="0" tIns="0" rIns="0" bIns="0">
+            <a:spAutoFit/>
+          </a:bodyPr>
+          <a:lstStyle/>
+          <a:p>
+            <a:pPr algn="l">
+              <a:lnSpc>
+                <a:spcPct val="125000"/>
+              </a:lnSpc>
+              <a:spcAft>
+                <a:spcPts val="400"/>
+              </a:spcAft>
+            </a:pPr>
+            <a:r>
+              <a:rPr sz="1100" b="0" i="0">
+                <a:solidFill>
+                  <a:srgbClr val="5C6B82"/>
+                </a:solidFill>
+                <a:latin typeface="Calibri"/>
+              </a:rPr>
+              <a:t>Posledních 8 projektů s persistentními security-scoped bookmarky — přežijí restart aplikace. Cross-window sync přes NotificationCenter.</a:t>
+            </a:r>
+          </a:p>
+        </p:txBody>
+      </p:sp>
+      <p:sp>
+        <p:nvSpPr>
+          <p:cNvPr id="38" name="Rectangle 37"/>
+          <p:cNvSpPr/>
+          <p:nvPr/>
+        </p:nvSpPr>
+        <p:spPr>
+          <a:xfrm>
+            <a:off x="6291072" y="3803904"/>
+            <a:ext cx="5650992" cy="1078992"/>
+          </a:xfrm>
+          <a:prstGeom prst="rect">
+            <a:avLst/>
+          </a:prstGeom>
+          <a:solidFill>
+            <a:srgbClr val="FFFFFF"/>
+          </a:solidFill>
+          <a:ln w="6350">
+            <a:solidFill>
+              <a:srgbClr val="D8E0EA"/>
+            </a:solidFill>
+          </a:ln>
+          <a:effectLst/>
+        </p:spPr>
+        <p:style>
+          <a:lnRef idx="1">
+            <a:schemeClr val="accent1"/>
+          </a:lnRef>
+          <a:fillRef idx="3">
+            <a:schemeClr val="accent1"/>
+          </a:fillRef>
+          <a:effectRef idx="2">
+            <a:schemeClr val="accent1"/>
+          </a:effectRef>
+          <a:fontRef idx="minor">
+            <a:schemeClr val="lt1"/>
+          </a:fontRef>
+        </p:style>
+        <p:txBody>
+          <a:bodyPr rtlCol="0" anchor="ctr"/>
+          <a:lstStyle/>
+          <a:p>
+            <a:pPr algn="ctr"/>
+            <a:endParaRPr/>
+          </a:p>
+        </p:txBody>
+      </p:sp>
+      <p:sp>
+        <p:nvSpPr>
+          <p:cNvPr id="39" name="Rectangle 38"/>
+          <p:cNvSpPr/>
+          <p:nvPr/>
+        </p:nvSpPr>
+        <p:spPr>
+          <a:xfrm>
+            <a:off x="6291072" y="3803904"/>
+            <a:ext cx="73152" cy="1078992"/>
+          </a:xfrm>
+          <a:prstGeom prst="rect">
+            <a:avLst/>
+          </a:prstGeom>
+          <a:solidFill>
+            <a:srgbClr val="1C7293"/>
+          </a:solidFill>
+          <a:ln>
+            <a:noFill/>
+          </a:ln>
+          <a:effectLst/>
+        </p:spPr>
+        <p:style>
+          <a:lnRef idx="1">
+            <a:schemeClr val="accent1"/>
+          </a:lnRef>
+          <a:fillRef idx="3">
+            <a:schemeClr val="accent1"/>
+          </a:fillRef>
+          <a:effectRef idx="2">
+            <a:schemeClr val="accent1"/>
+          </a:effectRef>
+          <a:fontRef idx="minor">
+            <a:schemeClr val="lt1"/>
+          </a:fontRef>
+        </p:style>
+        <p:txBody>
+          <a:bodyPr rtlCol="0" anchor="ctr"/>
+          <a:lstStyle/>
+          <a:p>
+            <a:pPr algn="ctr"/>
+            <a:endParaRPr/>
+          </a:p>
+        </p:txBody>
+      </p:sp>
+      <p:sp>
+        <p:nvSpPr>
+          <p:cNvPr id="40" name="Oval 39"/>
+          <p:cNvSpPr/>
+          <p:nvPr/>
+        </p:nvSpPr>
+        <p:spPr>
+          <a:xfrm>
+            <a:off x="6611112" y="4114800"/>
+            <a:ext cx="457200" cy="457200"/>
+          </a:xfrm>
+          <a:prstGeom prst="ellipse">
+            <a:avLst/>
+          </a:prstGeom>
+          <a:solidFill>
+            <a:srgbClr val="065A82"/>
+          </a:solidFill>
+          <a:ln>
+            <a:noFill/>
+          </a:ln>
+          <a:effectLst/>
+        </p:spPr>
+        <p:style>
+          <a:lnRef idx="1">
+            <a:schemeClr val="accent1"/>
+          </a:lnRef>
+          <a:fillRef idx="3">
+            <a:schemeClr val="accent1"/>
+          </a:fillRef>
+          <a:effectRef idx="2">
+            <a:schemeClr val="accent1"/>
+          </a:effectRef>
+          <a:fontRef idx="minor">
+            <a:schemeClr val="lt1"/>
+          </a:fontRef>
+        </p:style>
+        <p:txBody>
+          <a:bodyPr rtlCol="0" anchor="ctr"/>
+          <a:lstStyle/>
+          <a:p>
+            <a:pPr algn="ctr"/>
+            <a:endParaRPr/>
+          </a:p>
+        </p:txBody>
+      </p:sp>
+      <p:sp>
+        <p:nvSpPr>
+          <p:cNvPr id="41" name="TextBox 40"/>
+          <p:cNvSpPr txBox="1"/>
+          <p:nvPr/>
+        </p:nvSpPr>
+        <p:spPr>
+          <a:xfrm>
+            <a:off x="6611112" y="4160520"/>
+            <a:ext cx="457200" cy="365760"/>
+          </a:xfrm>
+          <a:prstGeom prst="rect">
+            <a:avLst/>
+          </a:prstGeom>
+          <a:noFill/>
+        </p:spPr>
+        <p:txBody>
+          <a:bodyPr wrap="square" lIns="0" tIns="0" rIns="0" bIns="0" anchor="ctr">
+            <a:spAutoFit/>
+          </a:bodyPr>
+          <a:lstStyle/>
+          <a:p>
+            <a:pPr algn="ctr"/>
+            <a:r>
+              <a:rPr sz="1500" b="1" i="0">
+                <a:solidFill>
+                  <a:srgbClr val="FFFFFF"/>
+                </a:solidFill>
+                <a:latin typeface="Calibri"/>
+              </a:rPr>
+              <a:t>6</a:t>
+            </a:r>
+          </a:p>
+        </p:txBody>
+      </p:sp>
+      <p:sp>
+        <p:nvSpPr>
+          <p:cNvPr id="42" name="TextBox 41"/>
+          <p:cNvSpPr txBox="1"/>
+          <p:nvPr/>
+        </p:nvSpPr>
+        <p:spPr>
+          <a:xfrm>
+            <a:off x="7251192" y="3950208"/>
+            <a:ext cx="4553712" cy="329184"/>
+          </a:xfrm>
+          <a:prstGeom prst="rect">
+            <a:avLst/>
+          </a:prstGeom>
+          <a:noFill/>
+        </p:spPr>
+        <p:txBody>
+          <a:bodyPr wrap="square" lIns="0" tIns="0" rIns="0" bIns="0" anchor="t">
+            <a:spAutoFit/>
+          </a:bodyPr>
+          <a:lstStyle/>
+          <a:p>
+            <a:pPr algn="l"/>
+            <a:r>
+              <a:rPr sz="1400" b="1" i="0">
+                <a:solidFill>
+                  <a:srgbClr val="21295C"/>
+                </a:solidFill>
+                <a:latin typeface="Calibri"/>
+              </a:rPr>
+              <a:t>AppIntents · Siri · Spotlight</a:t>
+            </a:r>
+          </a:p>
+        </p:txBody>
+      </p:sp>
+      <p:sp>
+        <p:nvSpPr>
+          <p:cNvPr id="43" name="TextBox 42"/>
+          <p:cNvSpPr txBox="1"/>
+          <p:nvPr/>
+        </p:nvSpPr>
+        <p:spPr>
+          <a:xfrm>
+            <a:off x="7251192" y="4279392"/>
+            <a:ext cx="4553712" cy="566928"/>
+          </a:xfrm>
+          <a:prstGeom prst="rect">
+            <a:avLst/>
+          </a:prstGeom>
+          <a:noFill/>
+        </p:spPr>
+        <p:txBody>
+          <a:bodyPr wrap="square" lIns="0" tIns="0" rIns="0" bIns="0">
+            <a:spAutoFit/>
+          </a:bodyPr>
+          <a:lstStyle/>
+          <a:p>
+            <a:pPr algn="l">
+              <a:lnSpc>
+                <a:spcPct val="125000"/>
+              </a:lnSpc>
+              <a:spcAft>
+                <a:spcPts val="400"/>
+              </a:spcAft>
+            </a:pPr>
+            <a:r>
+              <a:rPr sz="1100" b="0" i="0">
+                <a:solidFill>
+                  <a:srgbClr val="5C6B82"/>
+                </a:solidFill>
+                <a:latin typeface="Calibri"/>
+              </a:rPr>
+              <a:t>Frází Spusť Spice Harvester / Run Spice Harvester. macOS 14+ vystavuje akce v gallery i Spotlight nabídkách. Strukturovaný ReturnsValue + ProvidesDialog.</a:t>
+            </a:r>
+          </a:p>
+        </p:txBody>
+      </p:sp>
+      <p:sp>
+        <p:nvSpPr>
+          <p:cNvPr id="44" name="Rectangle 43"/>
+          <p:cNvSpPr/>
+          <p:nvPr/>
+        </p:nvSpPr>
+        <p:spPr>
+          <a:xfrm>
+            <a:off x="502920" y="4974336"/>
+            <a:ext cx="5650992" cy="1078992"/>
+          </a:xfrm>
+          <a:prstGeom prst="rect">
+            <a:avLst/>
+          </a:prstGeom>
+          <a:solidFill>
+            <a:srgbClr val="FFFFFF"/>
+          </a:solidFill>
+          <a:ln w="6350">
+            <a:solidFill>
+              <a:srgbClr val="D8E0EA"/>
+            </a:solidFill>
+          </a:ln>
+          <a:effectLst/>
+        </p:spPr>
+        <p:style>
+          <a:lnRef idx="1">
+            <a:schemeClr val="accent1"/>
+          </a:lnRef>
+          <a:fillRef idx="3">
+            <a:schemeClr val="accent1"/>
+          </a:fillRef>
+          <a:effectRef idx="2">
+            <a:schemeClr val="accent1"/>
+          </a:effectRef>
+          <a:fontRef idx="minor">
+            <a:schemeClr val="lt1"/>
+          </a:fontRef>
+        </p:style>
+        <p:txBody>
+          <a:bodyPr rtlCol="0" anchor="ctr"/>
+          <a:lstStyle/>
+          <a:p>
+            <a:pPr algn="ctr"/>
+            <a:endParaRPr/>
+          </a:p>
+        </p:txBody>
+      </p:sp>
+      <p:sp>
+        <p:nvSpPr>
+          <p:cNvPr id="45" name="Rectangle 44"/>
+          <p:cNvSpPr/>
+          <p:nvPr/>
+        </p:nvSpPr>
+        <p:spPr>
+          <a:xfrm>
+            <a:off x="502920" y="4974336"/>
+            <a:ext cx="73152" cy="1078992"/>
+          </a:xfrm>
+          <a:prstGeom prst="rect">
+            <a:avLst/>
+          </a:prstGeom>
+          <a:solidFill>
+            <a:srgbClr val="1C7293"/>
+          </a:solidFill>
+          <a:ln>
+            <a:noFill/>
+          </a:ln>
+          <a:effectLst/>
+        </p:spPr>
+        <p:style>
+          <a:lnRef idx="1">
+            <a:schemeClr val="accent1"/>
+          </a:lnRef>
+          <a:fillRef idx="3">
+            <a:schemeClr val="accent1"/>
+          </a:fillRef>
+          <a:effectRef idx="2">
+            <a:schemeClr val="accent1"/>
+          </a:effectRef>
+          <a:fontRef idx="minor">
+            <a:schemeClr val="lt1"/>
+          </a:fontRef>
+        </p:style>
+        <p:txBody>
+          <a:bodyPr rtlCol="0" anchor="ctr"/>
+          <a:lstStyle/>
+          <a:p>
+            <a:pPr algn="ctr"/>
+            <a:endParaRPr/>
+          </a:p>
+        </p:txBody>
+      </p:sp>
+      <p:sp>
+        <p:nvSpPr>
+          <p:cNvPr id="46" name="Oval 45"/>
+          <p:cNvSpPr/>
+          <p:nvPr/>
+        </p:nvSpPr>
+        <p:spPr>
+          <a:xfrm>
+            <a:off x="822960" y="5285232"/>
+            <a:ext cx="457200" cy="457200"/>
+          </a:xfrm>
+          <a:prstGeom prst="ellipse">
+            <a:avLst/>
+          </a:prstGeom>
+          <a:solidFill>
+            <a:srgbClr val="065A82"/>
+          </a:solidFill>
+          <a:ln>
+            <a:noFill/>
+          </a:ln>
+          <a:effectLst/>
+        </p:spPr>
+        <p:style>
+          <a:lnRef idx="1">
+            <a:schemeClr val="accent1"/>
+          </a:lnRef>
+          <a:fillRef idx="3">
+            <a:schemeClr val="accent1"/>
+          </a:fillRef>
+          <a:effectRef idx="2">
+            <a:schemeClr val="accent1"/>
+          </a:effectRef>
+          <a:fontRef idx="minor">
+            <a:schemeClr val="lt1"/>
+          </a:fontRef>
+        </p:style>
+        <p:txBody>
+          <a:bodyPr rtlCol="0" anchor="ctr"/>
+          <a:lstStyle/>
+          <a:p>
+            <a:pPr algn="ctr"/>
+            <a:endParaRPr/>
+          </a:p>
+        </p:txBody>
+      </p:sp>
+      <p:sp>
+        <p:nvSpPr>
+          <p:cNvPr id="47" name="TextBox 46"/>
+          <p:cNvSpPr txBox="1"/>
+          <p:nvPr/>
+        </p:nvSpPr>
+        <p:spPr>
+          <a:xfrm>
+            <a:off x="822960" y="5330952"/>
+            <a:ext cx="457200" cy="365760"/>
+          </a:xfrm>
+          <a:prstGeom prst="rect">
+            <a:avLst/>
+          </a:prstGeom>
+          <a:noFill/>
+        </p:spPr>
+        <p:txBody>
+          <a:bodyPr wrap="square" lIns="0" tIns="0" rIns="0" bIns="0" anchor="ctr">
+            <a:spAutoFit/>
+          </a:bodyPr>
+          <a:lstStyle/>
+          <a:p>
+            <a:pPr algn="ctr"/>
+            <a:r>
+              <a:rPr sz="1500" b="1" i="0">
+                <a:solidFill>
+                  <a:srgbClr val="FFFFFF"/>
+                </a:solidFill>
+                <a:latin typeface="Calibri"/>
+              </a:rPr>
+              <a:t>7</a:t>
+            </a:r>
+          </a:p>
+        </p:txBody>
+      </p:sp>
+      <p:sp>
+        <p:nvSpPr>
+          <p:cNvPr id="48" name="TextBox 47"/>
+          <p:cNvSpPr txBox="1"/>
+          <p:nvPr/>
+        </p:nvSpPr>
+        <p:spPr>
+          <a:xfrm>
+            <a:off x="1463040" y="5120640"/>
+            <a:ext cx="4553712" cy="329184"/>
+          </a:xfrm>
+          <a:prstGeom prst="rect">
+            <a:avLst/>
+          </a:prstGeom>
+          <a:noFill/>
+        </p:spPr>
+        <p:txBody>
+          <a:bodyPr wrap="square" lIns="0" tIns="0" rIns="0" bIns="0" anchor="t">
+            <a:spAutoFit/>
+          </a:bodyPr>
+          <a:lstStyle/>
+          <a:p>
+            <a:pPr algn="l"/>
+            <a:r>
+              <a:rPr sz="1400" b="1" i="0">
+                <a:solidFill>
+                  <a:srgbClr val="21295C"/>
+                </a:solidFill>
+                <a:latin typeface="Calibri"/>
+              </a:rPr>
+              <a:t>Pipeline menu bar</a:t>
+            </a:r>
+          </a:p>
+        </p:txBody>
+      </p:sp>
+      <p:sp>
+        <p:nvSpPr>
+          <p:cNvPr id="49" name="TextBox 48"/>
+          <p:cNvSpPr txBox="1"/>
+          <p:nvPr/>
+        </p:nvSpPr>
+        <p:spPr>
+          <a:xfrm>
+            <a:off x="1463040" y="5449824"/>
+            <a:ext cx="4553712" cy="566928"/>
+          </a:xfrm>
+          <a:prstGeom prst="rect">
+            <a:avLst/>
+          </a:prstGeom>
+          <a:noFill/>
+        </p:spPr>
+        <p:txBody>
+          <a:bodyPr wrap="square" lIns="0" tIns="0" rIns="0" bIns="0">
+            <a:spAutoFit/>
+          </a:bodyPr>
+          <a:lstStyle/>
+          <a:p>
+            <a:pPr algn="l">
+              <a:lnSpc>
+                <a:spcPct val="125000"/>
+              </a:lnSpc>
+              <a:spcAft>
+                <a:spcPts val="400"/>
+              </a:spcAft>
+            </a:pPr>
+            <a:r>
+              <a:rPr sz="1100" b="0" i="0">
+                <a:solidFill>
+                  <a:srgbClr val="5C6B82"/>
+                </a:solidFill>
+                <a:latin typeface="Calibri"/>
+              </a:rPr>
+              <a:t>Top-level CommandMenu Pipeline: Spustit (Cmd+R), Přerušit (Cmd+.), režim FAST/SEARCH/CONSOLIDATE (Cmd+1/2/3). Konvence Xcode/Logic/Final Cut.</a:t>
+            </a:r>
+          </a:p>
+        </p:txBody>
+      </p:sp>
+      <p:sp>
+        <p:nvSpPr>
+          <p:cNvPr id="50" name="Rectangle 49"/>
+          <p:cNvSpPr/>
+          <p:nvPr/>
+        </p:nvSpPr>
+        <p:spPr>
+          <a:xfrm>
+            <a:off x="6291072" y="4974336"/>
+            <a:ext cx="5650992" cy="1078992"/>
+          </a:xfrm>
+          <a:prstGeom prst="rect">
+            <a:avLst/>
+          </a:prstGeom>
+          <a:solidFill>
+            <a:srgbClr val="FFFFFF"/>
+          </a:solidFill>
+          <a:ln w="6350">
+            <a:solidFill>
+              <a:srgbClr val="D8E0EA"/>
+            </a:solidFill>
+          </a:ln>
+          <a:effectLst/>
+        </p:spPr>
+        <p:style>
+          <a:lnRef idx="1">
+            <a:schemeClr val="accent1"/>
+          </a:lnRef>
+          <a:fillRef idx="3">
+            <a:schemeClr val="accent1"/>
+          </a:fillRef>
+          <a:effectRef idx="2">
+            <a:schemeClr val="accent1"/>
+          </a:effectRef>
+          <a:fontRef idx="minor">
+            <a:schemeClr val="lt1"/>
+          </a:fontRef>
+        </p:style>
+        <p:txBody>
+          <a:bodyPr rtlCol="0" anchor="ctr"/>
+          <a:lstStyle/>
+          <a:p>
+            <a:pPr algn="ctr"/>
+            <a:endParaRPr/>
+          </a:p>
+        </p:txBody>
+      </p:sp>
+      <p:sp>
+        <p:nvSpPr>
+          <p:cNvPr id="51" name="Rectangle 50"/>
+          <p:cNvSpPr/>
+          <p:nvPr/>
+        </p:nvSpPr>
+        <p:spPr>
+          <a:xfrm>
+            <a:off x="6291072" y="4974336"/>
+            <a:ext cx="73152" cy="1078992"/>
+          </a:xfrm>
+          <a:prstGeom prst="rect">
+            <a:avLst/>
+          </a:prstGeom>
+          <a:solidFill>
+            <a:srgbClr val="1C7293"/>
+          </a:solidFill>
+          <a:ln>
+            <a:noFill/>
+          </a:ln>
+          <a:effectLst/>
+        </p:spPr>
+        <p:style>
+          <a:lnRef idx="1">
+            <a:schemeClr val="accent1"/>
+          </a:lnRef>
+          <a:fillRef idx="3">
+            <a:schemeClr val="accent1"/>
+          </a:fillRef>
+          <a:effectRef idx="2">
+            <a:schemeClr val="accent1"/>
+          </a:effectRef>
+          <a:fontRef idx="minor">
+            <a:schemeClr val="lt1"/>
+          </a:fontRef>
+        </p:style>
+        <p:txBody>
+          <a:bodyPr rtlCol="0" anchor="ctr"/>
+          <a:lstStyle/>
+          <a:p>
+            <a:pPr algn="ctr"/>
+            <a:endParaRPr/>
+          </a:p>
+        </p:txBody>
+      </p:sp>
+      <p:sp>
+        <p:nvSpPr>
+          <p:cNvPr id="52" name="Oval 51"/>
+          <p:cNvSpPr/>
+          <p:nvPr/>
+        </p:nvSpPr>
+        <p:spPr>
+          <a:xfrm>
+            <a:off x="6611112" y="5285232"/>
+            <a:ext cx="457200" cy="457200"/>
+          </a:xfrm>
+          <a:prstGeom prst="ellipse">
+            <a:avLst/>
+          </a:prstGeom>
+          <a:solidFill>
+            <a:srgbClr val="065A82"/>
+          </a:solidFill>
+          <a:ln>
+            <a:noFill/>
+          </a:ln>
+          <a:effectLst/>
+        </p:spPr>
+        <p:style>
+          <a:lnRef idx="1">
+            <a:schemeClr val="accent1"/>
+          </a:lnRef>
+          <a:fillRef idx="3">
+            <a:schemeClr val="accent1"/>
+          </a:fillRef>
+          <a:effectRef idx="2">
+            <a:schemeClr val="accent1"/>
+          </a:effectRef>
+          <a:fontRef idx="minor">
+            <a:schemeClr val="lt1"/>
+          </a:fontRef>
+        </p:style>
+        <p:txBody>
+          <a:bodyPr rtlCol="0" anchor="ctr"/>
+          <a:lstStyle/>
+          <a:p>
+            <a:pPr algn="ctr"/>
+            <a:endParaRPr/>
+          </a:p>
+        </p:txBody>
+      </p:sp>
+      <p:sp>
+        <p:nvSpPr>
+          <p:cNvPr id="53" name="TextBox 52"/>
+          <p:cNvSpPr txBox="1"/>
+          <p:nvPr/>
+        </p:nvSpPr>
+        <p:spPr>
+          <a:xfrm>
+            <a:off x="6611112" y="5330952"/>
+            <a:ext cx="457200" cy="365760"/>
+          </a:xfrm>
+          <a:prstGeom prst="rect">
+            <a:avLst/>
+          </a:prstGeom>
+          <a:noFill/>
+        </p:spPr>
+        <p:txBody>
+          <a:bodyPr wrap="square" lIns="0" tIns="0" rIns="0" bIns="0" anchor="ctr">
+            <a:spAutoFit/>
+          </a:bodyPr>
+          <a:lstStyle/>
+          <a:p>
+            <a:pPr algn="ctr"/>
+            <a:r>
+              <a:rPr sz="1500" b="1" i="0">
+                <a:solidFill>
+                  <a:srgbClr val="FFFFFF"/>
+                </a:solidFill>
+                <a:latin typeface="Calibri"/>
+              </a:rPr>
+              <a:t>8</a:t>
+            </a:r>
+          </a:p>
+        </p:txBody>
+      </p:sp>
+      <p:sp>
+        <p:nvSpPr>
+          <p:cNvPr id="54" name="TextBox 53"/>
+          <p:cNvSpPr txBox="1"/>
+          <p:nvPr/>
+        </p:nvSpPr>
+        <p:spPr>
+          <a:xfrm>
+            <a:off x="7251192" y="5120640"/>
+            <a:ext cx="4553712" cy="329184"/>
+          </a:xfrm>
+          <a:prstGeom prst="rect">
+            <a:avLst/>
+          </a:prstGeom>
+          <a:noFill/>
+        </p:spPr>
+        <p:txBody>
+          <a:bodyPr wrap="square" lIns="0" tIns="0" rIns="0" bIns="0" anchor="t">
+            <a:spAutoFit/>
+          </a:bodyPr>
+          <a:lstStyle/>
+          <a:p>
+            <a:pPr algn="l"/>
+            <a:r>
+              <a:rPr sz="1400" b="1" i="0">
+                <a:solidFill>
+                  <a:srgbClr val="21295C"/>
+                </a:solidFill>
+                <a:latin typeface="Calibri"/>
+              </a:rPr>
+              <a:t>Health watcher + manuální recheck</a:t>
+            </a:r>
+          </a:p>
+        </p:txBody>
+      </p:sp>
+      <p:sp>
+        <p:nvSpPr>
+          <p:cNvPr id="55" name="TextBox 54"/>
+          <p:cNvSpPr txBox="1"/>
+          <p:nvPr/>
+        </p:nvSpPr>
+        <p:spPr>
+          <a:xfrm>
+            <a:off x="7251192" y="5449824"/>
+            <a:ext cx="4553712" cy="566928"/>
+          </a:xfrm>
+          <a:prstGeom prst="rect">
+            <a:avLst/>
+          </a:prstGeom>
+          <a:noFill/>
+        </p:spPr>
+        <p:txBody>
+          <a:bodyPr wrap="square" lIns="0" tIns="0" rIns="0" bIns="0">
+            <a:spAutoFit/>
+          </a:bodyPr>
+          <a:lstStyle/>
+          <a:p>
+            <a:pPr algn="l">
+              <a:lnSpc>
+                <a:spcPct val="125000"/>
+              </a:lnSpc>
+              <a:spcAft>
+                <a:spcPts val="400"/>
+              </a:spcAft>
+            </a:pPr>
+            <a:r>
+              <a:rPr sz="1100" b="0" i="0">
+                <a:solidFill>
+                  <a:srgbClr val="5C6B82"/>
+                </a:solidFill>
+                <a:latin typeface="Calibri"/>
+              </a:rPr>
+              <a:t>30 s ambient ping na /v1/models; status pill zčervená při disconnectu. Pipeline → Znovu ověřit zdraví serveru pro okamžitou kontrolu po restartu LM Studia.</a:t>
+            </a:r>
+          </a:p>
+        </p:txBody>
+      </p:sp>
+    </p:spTree>
   </p:cSld>
   <p:clrMapOvr>
     <a:masterClrMapping/>
@@ -16369,7 +18616,7 @@
                 </a:solidFill>
                 <a:latin typeface="Calibri"/>
               </a:rPr>
-              <a:t>2 / 15</a:t>
+              <a:t>2 / 16</a:t>
             </a:r>
           </a:p>
         </p:txBody>
@@ -18505,7 +20752,7 @@
                 </a:solidFill>
                 <a:latin typeface="Calibri"/>
               </a:rPr>
-              <a:t>3 / 15</a:t>
+              <a:t>3 / 16</a:t>
             </a:r>
           </a:p>
         </p:txBody>
@@ -20015,7 +22262,7 @@
                 </a:solidFill>
                 <a:latin typeface="Calibri"/>
               </a:rPr>
-              <a:t>4 / 15</a:t>
+              <a:t>4 / 16</a:t>
             </a:r>
           </a:p>
         </p:txBody>
@@ -20243,7 +22490,7 @@
                 </a:solidFill>
                 <a:latin typeface="Calibri"/>
               </a:rPr>
-              <a:t>5 / 15</a:t>
+              <a:t>5 / 16</a:t>
             </a:r>
           </a:p>
         </p:txBody>
@@ -22409,7 +24656,7 @@
                 </a:solidFill>
                 <a:latin typeface="Calibri"/>
               </a:rPr>
-              <a:t>6 / 15</a:t>
+              <a:t>6 / 16</a:t>
             </a:r>
           </a:p>
         </p:txBody>
@@ -25564,7 +27811,7 @@
                 </a:solidFill>
                 <a:latin typeface="Calibri"/>
               </a:rPr>
-              <a:t>7 / 15</a:t>
+              <a:t>7 / 16</a:t>
             </a:r>
           </a:p>
         </p:txBody>
@@ -27327,7 +29574,7 @@
                 </a:solidFill>
                 <a:latin typeface="Calibri"/>
               </a:rPr>
-              <a:t>8 / 15</a:t>
+              <a:t>8 / 16</a:t>
             </a:r>
           </a:p>
         </p:txBody>
@@ -28774,7 +31021,7 @@
                 </a:solidFill>
                 <a:latin typeface="Calibri"/>
               </a:rPr>
-              <a:t>9 / 15</a:t>
+              <a:t>9 / 16</a:t>
             </a:r>
           </a:p>
         </p:txBody>

</xml_diff>

<commit_message>
Prezentace: oprava leftover číslování slide 12
Slide TECHNOLOGIE A SHRNUTÍ měl staré číslování 10 / 10 (z doby kdy
měl být závěrečným slidem). Sjednoceno na 12 / 16 jako zbytek decku.
</commit_message>
<xml_diff>
--- a/docs/SpiceHarvester_Prezentace.pptx
+++ b/docs/SpiceHarvester_Prezentace.pptx
@@ -8771,7 +8771,7 @@
                 </a:solidFill>
                 <a:latin typeface="Calibri"/>
               </a:rPr>
-              <a:t>10 / 10</a:t>
+              <a:t>12 / 16</a:t>
             </a:r>
           </a:p>
         </p:txBody>
@@ -16084,6 +16084,2252 @@
 </file>
 
 <file path=ppt/slides/slide16.xml><?xml version="1.0" encoding="utf-8"?>
+<p:sld xmlns:a="http://schemas.openxmlformats.org/drawingml/2006/main" xmlns:p="http://schemas.openxmlformats.org/presentationml/2006/main" xmlns:r="http://schemas.openxmlformats.org/officeDocument/2006/relationships">
+  <p:cSld>
+    <p:spTree>
+      <p:nvGrpSpPr>
+        <p:cNvPr id="1" name=""/>
+        <p:cNvGrpSpPr/>
+        <p:nvPr/>
+      </p:nvGrpSpPr>
+      <p:grpSpPr/>
+      <p:sp>
+        <p:nvSpPr>
+          <p:cNvPr id="2" name="Rectangle 1"/>
+          <p:cNvSpPr/>
+          <p:nvPr/>
+        </p:nvSpPr>
+        <p:spPr>
+          <a:xfrm>
+            <a:off x="0" y="0"/>
+            <a:ext cx="12191695" cy="146304"/>
+          </a:xfrm>
+          <a:prstGeom prst="rect">
+            <a:avLst/>
+          </a:prstGeom>
+          <a:solidFill>
+            <a:srgbClr val="065A82"/>
+          </a:solidFill>
+          <a:ln>
+            <a:noFill/>
+          </a:ln>
+          <a:effectLst/>
+        </p:spPr>
+        <p:style>
+          <a:lnRef idx="1">
+            <a:schemeClr val="accent1"/>
+          </a:lnRef>
+          <a:fillRef idx="3">
+            <a:schemeClr val="accent1"/>
+          </a:fillRef>
+          <a:effectRef idx="2">
+            <a:schemeClr val="accent1"/>
+          </a:effectRef>
+          <a:fontRef idx="minor">
+            <a:schemeClr val="lt1"/>
+          </a:fontRef>
+        </p:style>
+        <p:txBody>
+          <a:bodyPr rtlCol="0" anchor="ctr"/>
+          <a:lstStyle/>
+          <a:p>
+            <a:pPr algn="ctr"/>
+            <a:endParaRPr/>
+          </a:p>
+        </p:txBody>
+      </p:sp>
+      <p:sp>
+        <p:nvSpPr>
+          <p:cNvPr id="3" name="Rectangle 2"/>
+          <p:cNvSpPr/>
+          <p:nvPr/>
+        </p:nvSpPr>
+        <p:spPr>
+          <a:xfrm>
+            <a:off x="0" y="146304"/>
+            <a:ext cx="164592" cy="6711696"/>
+          </a:xfrm>
+          <a:prstGeom prst="rect">
+            <a:avLst/>
+          </a:prstGeom>
+          <a:solidFill>
+            <a:srgbClr val="F5B041"/>
+          </a:solidFill>
+          <a:ln>
+            <a:noFill/>
+          </a:ln>
+          <a:effectLst/>
+        </p:spPr>
+        <p:style>
+          <a:lnRef idx="1">
+            <a:schemeClr val="accent1"/>
+          </a:lnRef>
+          <a:fillRef idx="3">
+            <a:schemeClr val="accent1"/>
+          </a:fillRef>
+          <a:effectRef idx="2">
+            <a:schemeClr val="accent1"/>
+          </a:effectRef>
+          <a:fontRef idx="minor">
+            <a:schemeClr val="lt1"/>
+          </a:fontRef>
+        </p:style>
+        <p:txBody>
+          <a:bodyPr rtlCol="0" anchor="ctr"/>
+          <a:lstStyle/>
+          <a:p>
+            <a:pPr algn="ctr"/>
+            <a:endParaRPr/>
+          </a:p>
+        </p:txBody>
+      </p:sp>
+      <p:sp>
+        <p:nvSpPr>
+          <p:cNvPr id="4" name="TextBox 3"/>
+          <p:cNvSpPr txBox="1"/>
+          <p:nvPr/>
+        </p:nvSpPr>
+        <p:spPr>
+          <a:xfrm>
+            <a:off x="502920" y="365760"/>
+            <a:ext cx="10058400" cy="461665"/>
+          </a:xfrm>
+          <a:prstGeom prst="rect">
+            <a:avLst/>
+          </a:prstGeom>
+          <a:noFill/>
+        </p:spPr>
+        <p:txBody>
+          <a:bodyPr wrap="square" lIns="0" tIns="0" rIns="0" bIns="0" anchor="t">
+            <a:spAutoFit/>
+          </a:bodyPr>
+          <a:lstStyle/>
+          <a:p>
+            <a:pPr algn="l"/>
+            <a:r>
+              <a:rPr sz="3000" b="1" i="0" dirty="0" err="1">
+                <a:solidFill>
+                  <a:srgbClr val="21295C"/>
+                </a:solidFill>
+                <a:latin typeface="Calibri"/>
+              </a:rPr>
+              <a:t>Automatizace a integrace s macOS</a:t>
+            </a:r>
+            <a:endParaRPr sz="3000" b="1" i="0" dirty="0">
+              <a:solidFill>
+                <a:srgbClr val="21295C"/>
+              </a:solidFill>
+              <a:latin typeface="Calibri"/>
+            </a:endParaRPr>
+          </a:p>
+        </p:txBody>
+      </p:sp>
+      <p:sp>
+        <p:nvSpPr>
+          <p:cNvPr id="5" name="TextBox 4"/>
+          <p:cNvSpPr txBox="1"/>
+          <p:nvPr/>
+        </p:nvSpPr>
+        <p:spPr>
+          <a:xfrm>
+            <a:off x="502920" y="960120"/>
+            <a:ext cx="10058400" cy="365760"/>
+          </a:xfrm>
+          <a:prstGeom prst="rect">
+            <a:avLst/>
+          </a:prstGeom>
+          <a:noFill/>
+        </p:spPr>
+        <p:txBody>
+          <a:bodyPr wrap="square" lIns="0" tIns="0" rIns="0" bIns="0" anchor="t">
+            <a:spAutoFit/>
+          </a:bodyPr>
+          <a:lstStyle/>
+          <a:p>
+            <a:pPr algn="l"/>
+            <a:r>
+              <a:rPr sz="1400" b="0" i="1">
+                <a:solidFill>
+                  <a:srgbClr val="1C7293"/>
+                </a:solidFill>
+                <a:latin typeface="Calibri"/>
+              </a:rPr>
+              <a:t>Job-ready Shortcuts, multi-window, projekty, native menu</a:t>
+            </a:r>
+          </a:p>
+        </p:txBody>
+      </p:sp>
+      <p:sp>
+        <p:nvSpPr>
+          <p:cNvPr id="6" name="TextBox 5"/>
+          <p:cNvSpPr txBox="1"/>
+          <p:nvPr/>
+        </p:nvSpPr>
+        <p:spPr>
+          <a:xfrm>
+            <a:off x="10789920" y="6446520"/>
+            <a:ext cx="1280160" cy="320040"/>
+          </a:xfrm>
+          <a:prstGeom prst="rect">
+            <a:avLst/>
+          </a:prstGeom>
+          <a:noFill/>
+        </p:spPr>
+        <p:txBody>
+          <a:bodyPr wrap="square" lIns="0" tIns="0" rIns="0" bIns="0" anchor="t">
+            <a:spAutoFit/>
+          </a:bodyPr>
+          <a:lstStyle/>
+          <a:p>
+            <a:pPr algn="r"/>
+            <a:r>
+              <a:rPr sz="1000" b="0" i="0">
+                <a:solidFill>
+                  <a:srgbClr val="5C6B82"/>
+                </a:solidFill>
+                <a:latin typeface="Calibri"/>
+              </a:rPr>
+              <a:t>16 / 16</a:t>
+            </a:r>
+          </a:p>
+        </p:txBody>
+      </p:sp>
+      <p:sp>
+        <p:nvSpPr>
+          <p:cNvPr id="7" name="TextBox 6"/>
+          <p:cNvSpPr txBox="1"/>
+          <p:nvPr/>
+        </p:nvSpPr>
+        <p:spPr>
+          <a:xfrm>
+            <a:off x="502920" y="6446520"/>
+            <a:ext cx="5486400" cy="320040"/>
+          </a:xfrm>
+          <a:prstGeom prst="rect">
+            <a:avLst/>
+          </a:prstGeom>
+          <a:noFill/>
+        </p:spPr>
+        <p:txBody>
+          <a:bodyPr wrap="square" lIns="0" tIns="0" rIns="0" bIns="0" anchor="t">
+            <a:spAutoFit/>
+          </a:bodyPr>
+          <a:lstStyle/>
+          <a:p>
+            <a:pPr algn="l"/>
+            <a:r>
+              <a:rPr sz="1000" b="0" i="0">
+                <a:solidFill>
+                  <a:srgbClr val="5C6B82"/>
+                </a:solidFill>
+                <a:latin typeface="Calibri"/>
+              </a:rPr>
+              <a:t>SpiceHarvester · Lokální dávkové vytěžování PDF přes LLM</a:t>
+            </a:r>
+          </a:p>
+        </p:txBody>
+      </p:sp>
+      <p:sp>
+        <p:nvSpPr>
+          <p:cNvPr id="8" name="Rectangle 7"/>
+          <p:cNvSpPr/>
+          <p:nvPr/>
+        </p:nvSpPr>
+        <p:spPr>
+          <a:xfrm>
+            <a:off x="502920" y="1463040"/>
+            <a:ext cx="5650992" cy="1078992"/>
+          </a:xfrm>
+          <a:prstGeom prst="rect">
+            <a:avLst/>
+          </a:prstGeom>
+          <a:solidFill>
+            <a:srgbClr val="FFFFFF"/>
+          </a:solidFill>
+          <a:ln w="6350">
+            <a:solidFill>
+              <a:srgbClr val="D8E0EA"/>
+            </a:solidFill>
+          </a:ln>
+          <a:effectLst/>
+        </p:spPr>
+        <p:style>
+          <a:lnRef idx="1">
+            <a:schemeClr val="accent1"/>
+          </a:lnRef>
+          <a:fillRef idx="3">
+            <a:schemeClr val="accent1"/>
+          </a:fillRef>
+          <a:effectRef idx="2">
+            <a:schemeClr val="accent1"/>
+          </a:effectRef>
+          <a:fontRef idx="minor">
+            <a:schemeClr val="lt1"/>
+          </a:fontRef>
+        </p:style>
+        <p:txBody>
+          <a:bodyPr rtlCol="0" anchor="ctr"/>
+          <a:lstStyle/>
+          <a:p>
+            <a:pPr algn="ctr"/>
+            <a:endParaRPr/>
+          </a:p>
+        </p:txBody>
+      </p:sp>
+      <p:sp>
+        <p:nvSpPr>
+          <p:cNvPr id="9" name="Rectangle 8"/>
+          <p:cNvSpPr/>
+          <p:nvPr/>
+        </p:nvSpPr>
+        <p:spPr>
+          <a:xfrm>
+            <a:off x="502920" y="1463040"/>
+            <a:ext cx="73152" cy="1078992"/>
+          </a:xfrm>
+          <a:prstGeom prst="rect">
+            <a:avLst/>
+          </a:prstGeom>
+          <a:solidFill>
+            <a:srgbClr val="1C7293"/>
+          </a:solidFill>
+          <a:ln>
+            <a:noFill/>
+          </a:ln>
+          <a:effectLst/>
+        </p:spPr>
+        <p:style>
+          <a:lnRef idx="1">
+            <a:schemeClr val="accent1"/>
+          </a:lnRef>
+          <a:fillRef idx="3">
+            <a:schemeClr val="accent1"/>
+          </a:fillRef>
+          <a:effectRef idx="2">
+            <a:schemeClr val="accent1"/>
+          </a:effectRef>
+          <a:fontRef idx="minor">
+            <a:schemeClr val="lt1"/>
+          </a:fontRef>
+        </p:style>
+        <p:txBody>
+          <a:bodyPr rtlCol="0" anchor="ctr"/>
+          <a:lstStyle/>
+          <a:p>
+            <a:pPr algn="ctr"/>
+            <a:endParaRPr/>
+          </a:p>
+        </p:txBody>
+      </p:sp>
+      <p:sp>
+        <p:nvSpPr>
+          <p:cNvPr id="10" name="Oval 9"/>
+          <p:cNvSpPr/>
+          <p:nvPr/>
+        </p:nvSpPr>
+        <p:spPr>
+          <a:xfrm>
+            <a:off x="822960" y="1773936"/>
+            <a:ext cx="457200" cy="457200"/>
+          </a:xfrm>
+          <a:prstGeom prst="ellipse">
+            <a:avLst/>
+          </a:prstGeom>
+          <a:solidFill>
+            <a:srgbClr val="065A82"/>
+          </a:solidFill>
+          <a:ln>
+            <a:noFill/>
+          </a:ln>
+          <a:effectLst/>
+        </p:spPr>
+        <p:style>
+          <a:lnRef idx="1">
+            <a:schemeClr val="accent1"/>
+          </a:lnRef>
+          <a:fillRef idx="3">
+            <a:schemeClr val="accent1"/>
+          </a:fillRef>
+          <a:effectRef idx="2">
+            <a:schemeClr val="accent1"/>
+          </a:effectRef>
+          <a:fontRef idx="minor">
+            <a:schemeClr val="lt1"/>
+          </a:fontRef>
+        </p:style>
+        <p:txBody>
+          <a:bodyPr rtlCol="0" anchor="ctr"/>
+          <a:lstStyle/>
+          <a:p>
+            <a:pPr algn="ctr"/>
+            <a:endParaRPr/>
+          </a:p>
+        </p:txBody>
+      </p:sp>
+      <p:sp>
+        <p:nvSpPr>
+          <p:cNvPr id="11" name="TextBox 10"/>
+          <p:cNvSpPr txBox="1"/>
+          <p:nvPr/>
+        </p:nvSpPr>
+        <p:spPr>
+          <a:xfrm>
+            <a:off x="822960" y="1819656"/>
+            <a:ext cx="457200" cy="365760"/>
+          </a:xfrm>
+          <a:prstGeom prst="rect">
+            <a:avLst/>
+          </a:prstGeom>
+          <a:noFill/>
+        </p:spPr>
+        <p:txBody>
+          <a:bodyPr wrap="square" lIns="0" tIns="0" rIns="0" bIns="0" anchor="ctr">
+            <a:spAutoFit/>
+          </a:bodyPr>
+          <a:lstStyle/>
+          <a:p>
+            <a:pPr algn="ctr"/>
+            <a:r>
+              <a:rPr sz="1500" b="1" i="0">
+                <a:solidFill>
+                  <a:srgbClr val="FFFFFF"/>
+                </a:solidFill>
+                <a:latin typeface="Calibri"/>
+              </a:rPr>
+              <a:t>1</a:t>
+            </a:r>
+          </a:p>
+        </p:txBody>
+      </p:sp>
+      <p:sp>
+        <p:nvSpPr>
+          <p:cNvPr id="12" name="TextBox 11"/>
+          <p:cNvSpPr txBox="1"/>
+          <p:nvPr/>
+        </p:nvSpPr>
+        <p:spPr>
+          <a:xfrm>
+            <a:off x="1463040" y="1609344"/>
+            <a:ext cx="4553712" cy="329184"/>
+          </a:xfrm>
+          <a:prstGeom prst="rect">
+            <a:avLst/>
+          </a:prstGeom>
+          <a:noFill/>
+        </p:spPr>
+        <p:txBody>
+          <a:bodyPr wrap="square" lIns="0" tIns="0" rIns="0" bIns="0" anchor="t">
+            <a:spAutoFit/>
+          </a:bodyPr>
+          <a:lstStyle/>
+          <a:p>
+            <a:pPr algn="l"/>
+            <a:r>
+              <a:rPr sz="1400" b="1" i="0">
+                <a:solidFill>
+                  <a:srgbClr val="21295C"/>
+                </a:solidFill>
+                <a:latin typeface="Calibri"/>
+              </a:rPr>
+              <a:t>Shortcuts.app jako job</a:t>
+            </a:r>
+          </a:p>
+        </p:txBody>
+      </p:sp>
+      <p:sp>
+        <p:nvSpPr>
+          <p:cNvPr id="13" name="TextBox 12"/>
+          <p:cNvSpPr txBox="1"/>
+          <p:nvPr/>
+        </p:nvSpPr>
+        <p:spPr>
+          <a:xfrm>
+            <a:off x="1463040" y="1938528"/>
+            <a:ext cx="4553712" cy="566928"/>
+          </a:xfrm>
+          <a:prstGeom prst="rect">
+            <a:avLst/>
+          </a:prstGeom>
+          <a:noFill/>
+        </p:spPr>
+        <p:txBody>
+          <a:bodyPr wrap="square" lIns="0" tIns="0" rIns="0" bIns="0">
+            <a:spAutoFit/>
+          </a:bodyPr>
+          <a:lstStyle/>
+          <a:p>
+            <a:pPr algn="l">
+              <a:lnSpc>
+                <a:spcPct val="125000"/>
+              </a:lnSpc>
+              <a:spcAft>
+                <a:spcPts val="400"/>
+              </a:spcAft>
+            </a:pPr>
+            <a:r>
+              <a:rPr sz="1100" b="0" i="0">
+                <a:solidFill>
+                  <a:srgbClr val="5C6B82"/>
+                </a:solidFill>
+                <a:latin typeface="Calibri"/>
+              </a:rPr>
+              <a:t>Akce Spustit extrakci s volitelnými parametry Režim a Název promptu. perform() ČEKÁ na dokončení a vrátí cestu k results.csv pro řetězení dalších kroků.</a:t>
+            </a:r>
+          </a:p>
+        </p:txBody>
+      </p:sp>
+      <p:sp>
+        <p:nvSpPr>
+          <p:cNvPr id="14" name="Rectangle 13"/>
+          <p:cNvSpPr/>
+          <p:nvPr/>
+        </p:nvSpPr>
+        <p:spPr>
+          <a:xfrm>
+            <a:off x="6291072" y="1463040"/>
+            <a:ext cx="5650992" cy="1078992"/>
+          </a:xfrm>
+          <a:prstGeom prst="rect">
+            <a:avLst/>
+          </a:prstGeom>
+          <a:solidFill>
+            <a:srgbClr val="FFFFFF"/>
+          </a:solidFill>
+          <a:ln w="6350">
+            <a:solidFill>
+              <a:srgbClr val="D8E0EA"/>
+            </a:solidFill>
+          </a:ln>
+          <a:effectLst/>
+        </p:spPr>
+        <p:style>
+          <a:lnRef idx="1">
+            <a:schemeClr val="accent1"/>
+          </a:lnRef>
+          <a:fillRef idx="3">
+            <a:schemeClr val="accent1"/>
+          </a:fillRef>
+          <a:effectRef idx="2">
+            <a:schemeClr val="accent1"/>
+          </a:effectRef>
+          <a:fontRef idx="minor">
+            <a:schemeClr val="lt1"/>
+          </a:fontRef>
+        </p:style>
+        <p:txBody>
+          <a:bodyPr rtlCol="0" anchor="ctr"/>
+          <a:lstStyle/>
+          <a:p>
+            <a:pPr algn="ctr"/>
+            <a:endParaRPr/>
+          </a:p>
+        </p:txBody>
+      </p:sp>
+      <p:sp>
+        <p:nvSpPr>
+          <p:cNvPr id="15" name="Rectangle 14"/>
+          <p:cNvSpPr/>
+          <p:nvPr/>
+        </p:nvSpPr>
+        <p:spPr>
+          <a:xfrm>
+            <a:off x="6291072" y="1463040"/>
+            <a:ext cx="73152" cy="1078992"/>
+          </a:xfrm>
+          <a:prstGeom prst="rect">
+            <a:avLst/>
+          </a:prstGeom>
+          <a:solidFill>
+            <a:srgbClr val="1C7293"/>
+          </a:solidFill>
+          <a:ln>
+            <a:noFill/>
+          </a:ln>
+          <a:effectLst/>
+        </p:spPr>
+        <p:style>
+          <a:lnRef idx="1">
+            <a:schemeClr val="accent1"/>
+          </a:lnRef>
+          <a:fillRef idx="3">
+            <a:schemeClr val="accent1"/>
+          </a:fillRef>
+          <a:effectRef idx="2">
+            <a:schemeClr val="accent1"/>
+          </a:effectRef>
+          <a:fontRef idx="minor">
+            <a:schemeClr val="lt1"/>
+          </a:fontRef>
+        </p:style>
+        <p:txBody>
+          <a:bodyPr rtlCol="0" anchor="ctr"/>
+          <a:lstStyle/>
+          <a:p>
+            <a:pPr algn="ctr"/>
+            <a:endParaRPr/>
+          </a:p>
+        </p:txBody>
+      </p:sp>
+      <p:sp>
+        <p:nvSpPr>
+          <p:cNvPr id="16" name="Oval 15"/>
+          <p:cNvSpPr/>
+          <p:nvPr/>
+        </p:nvSpPr>
+        <p:spPr>
+          <a:xfrm>
+            <a:off x="6611112" y="1773936"/>
+            <a:ext cx="457200" cy="457200"/>
+          </a:xfrm>
+          <a:prstGeom prst="ellipse">
+            <a:avLst/>
+          </a:prstGeom>
+          <a:solidFill>
+            <a:srgbClr val="065A82"/>
+          </a:solidFill>
+          <a:ln>
+            <a:noFill/>
+          </a:ln>
+          <a:effectLst/>
+        </p:spPr>
+        <p:style>
+          <a:lnRef idx="1">
+            <a:schemeClr val="accent1"/>
+          </a:lnRef>
+          <a:fillRef idx="3">
+            <a:schemeClr val="accent1"/>
+          </a:fillRef>
+          <a:effectRef idx="2">
+            <a:schemeClr val="accent1"/>
+          </a:effectRef>
+          <a:fontRef idx="minor">
+            <a:schemeClr val="lt1"/>
+          </a:fontRef>
+        </p:style>
+        <p:txBody>
+          <a:bodyPr rtlCol="0" anchor="ctr"/>
+          <a:lstStyle/>
+          <a:p>
+            <a:pPr algn="ctr"/>
+            <a:endParaRPr/>
+          </a:p>
+        </p:txBody>
+      </p:sp>
+      <p:sp>
+        <p:nvSpPr>
+          <p:cNvPr id="17" name="TextBox 16"/>
+          <p:cNvSpPr txBox="1"/>
+          <p:nvPr/>
+        </p:nvSpPr>
+        <p:spPr>
+          <a:xfrm>
+            <a:off x="6611112" y="1819656"/>
+            <a:ext cx="457200" cy="365760"/>
+          </a:xfrm>
+          <a:prstGeom prst="rect">
+            <a:avLst/>
+          </a:prstGeom>
+          <a:noFill/>
+        </p:spPr>
+        <p:txBody>
+          <a:bodyPr wrap="square" lIns="0" tIns="0" rIns="0" bIns="0" anchor="ctr">
+            <a:spAutoFit/>
+          </a:bodyPr>
+          <a:lstStyle/>
+          <a:p>
+            <a:pPr algn="ctr"/>
+            <a:r>
+              <a:rPr sz="1500" b="1" i="0">
+                <a:solidFill>
+                  <a:srgbClr val="FFFFFF"/>
+                </a:solidFill>
+                <a:latin typeface="Calibri"/>
+              </a:rPr>
+              <a:t>2</a:t>
+            </a:r>
+          </a:p>
+        </p:txBody>
+      </p:sp>
+      <p:sp>
+        <p:nvSpPr>
+          <p:cNvPr id="18" name="TextBox 17"/>
+          <p:cNvSpPr txBox="1"/>
+          <p:nvPr/>
+        </p:nvSpPr>
+        <p:spPr>
+          <a:xfrm>
+            <a:off x="7251192" y="1609344"/>
+            <a:ext cx="4553712" cy="329184"/>
+          </a:xfrm>
+          <a:prstGeom prst="rect">
+            <a:avLst/>
+          </a:prstGeom>
+          <a:noFill/>
+        </p:spPr>
+        <p:txBody>
+          <a:bodyPr wrap="square" lIns="0" tIns="0" rIns="0" bIns="0" anchor="t">
+            <a:spAutoFit/>
+          </a:bodyPr>
+          <a:lstStyle/>
+          <a:p>
+            <a:pPr algn="l"/>
+            <a:r>
+              <a:rPr sz="1400" b="1" i="0">
+                <a:solidFill>
+                  <a:srgbClr val="21295C"/>
+                </a:solidFill>
+                <a:latin typeface="Calibri"/>
+              </a:rPr>
+              <a:t>Plánované běhy (cron-like)</a:t>
+            </a:r>
+          </a:p>
+        </p:txBody>
+      </p:sp>
+      <p:sp>
+        <p:nvSpPr>
+          <p:cNvPr id="19" name="TextBox 18"/>
+          <p:cNvSpPr txBox="1"/>
+          <p:nvPr/>
+        </p:nvSpPr>
+        <p:spPr>
+          <a:xfrm>
+            <a:off x="7251192" y="1938528"/>
+            <a:ext cx="4553712" cy="566928"/>
+          </a:xfrm>
+          <a:prstGeom prst="rect">
+            <a:avLst/>
+          </a:prstGeom>
+          <a:noFill/>
+        </p:spPr>
+        <p:txBody>
+          <a:bodyPr wrap="square" lIns="0" tIns="0" rIns="0" bIns="0">
+            <a:spAutoFit/>
+          </a:bodyPr>
+          <a:lstStyle/>
+          <a:p>
+            <a:pPr algn="l">
+              <a:lnSpc>
+                <a:spcPct val="125000"/>
+              </a:lnSpc>
+              <a:spcAft>
+                <a:spcPts val="400"/>
+              </a:spcAft>
+            </a:pPr>
+            <a:r>
+              <a:rPr sz="1100" b="0" i="0">
+                <a:solidFill>
+                  <a:srgbClr val="5C6B82"/>
+                </a:solidFill>
+                <a:latin typeface="Calibri"/>
+              </a:rPr>
+              <a:t>Zkratky.app → Automatizace → Time of Day. Denní extrakce v 8:00, navazující akce: poslat CSV na mail, push do gitu, notify na Slack. Bez Ask Before Running tichý běh.</a:t>
+            </a:r>
+          </a:p>
+        </p:txBody>
+      </p:sp>
+      <p:sp>
+        <p:nvSpPr>
+          <p:cNvPr id="20" name="Rectangle 19"/>
+          <p:cNvSpPr/>
+          <p:nvPr/>
+        </p:nvSpPr>
+        <p:spPr>
+          <a:xfrm>
+            <a:off x="502920" y="2633472"/>
+            <a:ext cx="5650992" cy="1078992"/>
+          </a:xfrm>
+          <a:prstGeom prst="rect">
+            <a:avLst/>
+          </a:prstGeom>
+          <a:solidFill>
+            <a:srgbClr val="FFFFFF"/>
+          </a:solidFill>
+          <a:ln w="6350">
+            <a:solidFill>
+              <a:srgbClr val="D8E0EA"/>
+            </a:solidFill>
+          </a:ln>
+          <a:effectLst/>
+        </p:spPr>
+        <p:style>
+          <a:lnRef idx="1">
+            <a:schemeClr val="accent1"/>
+          </a:lnRef>
+          <a:fillRef idx="3">
+            <a:schemeClr val="accent1"/>
+          </a:fillRef>
+          <a:effectRef idx="2">
+            <a:schemeClr val="accent1"/>
+          </a:effectRef>
+          <a:fontRef idx="minor">
+            <a:schemeClr val="lt1"/>
+          </a:fontRef>
+        </p:style>
+        <p:txBody>
+          <a:bodyPr rtlCol="0" anchor="ctr"/>
+          <a:lstStyle/>
+          <a:p>
+            <a:pPr algn="ctr"/>
+            <a:endParaRPr/>
+          </a:p>
+        </p:txBody>
+      </p:sp>
+      <p:sp>
+        <p:nvSpPr>
+          <p:cNvPr id="21" name="Rectangle 20"/>
+          <p:cNvSpPr/>
+          <p:nvPr/>
+        </p:nvSpPr>
+        <p:spPr>
+          <a:xfrm>
+            <a:off x="502920" y="2633472"/>
+            <a:ext cx="73152" cy="1078992"/>
+          </a:xfrm>
+          <a:prstGeom prst="rect">
+            <a:avLst/>
+          </a:prstGeom>
+          <a:solidFill>
+            <a:srgbClr val="1C7293"/>
+          </a:solidFill>
+          <a:ln>
+            <a:noFill/>
+          </a:ln>
+          <a:effectLst/>
+        </p:spPr>
+        <p:style>
+          <a:lnRef idx="1">
+            <a:schemeClr val="accent1"/>
+          </a:lnRef>
+          <a:fillRef idx="3">
+            <a:schemeClr val="accent1"/>
+          </a:fillRef>
+          <a:effectRef idx="2">
+            <a:schemeClr val="accent1"/>
+          </a:effectRef>
+          <a:fontRef idx="minor">
+            <a:schemeClr val="lt1"/>
+          </a:fontRef>
+        </p:style>
+        <p:txBody>
+          <a:bodyPr rtlCol="0" anchor="ctr"/>
+          <a:lstStyle/>
+          <a:p>
+            <a:pPr algn="ctr"/>
+            <a:endParaRPr/>
+          </a:p>
+        </p:txBody>
+      </p:sp>
+      <p:sp>
+        <p:nvSpPr>
+          <p:cNvPr id="22" name="Oval 21"/>
+          <p:cNvSpPr/>
+          <p:nvPr/>
+        </p:nvSpPr>
+        <p:spPr>
+          <a:xfrm>
+            <a:off x="822960" y="2944368"/>
+            <a:ext cx="457200" cy="457200"/>
+          </a:xfrm>
+          <a:prstGeom prst="ellipse">
+            <a:avLst/>
+          </a:prstGeom>
+          <a:solidFill>
+            <a:srgbClr val="065A82"/>
+          </a:solidFill>
+          <a:ln>
+            <a:noFill/>
+          </a:ln>
+          <a:effectLst/>
+        </p:spPr>
+        <p:style>
+          <a:lnRef idx="1">
+            <a:schemeClr val="accent1"/>
+          </a:lnRef>
+          <a:fillRef idx="3">
+            <a:schemeClr val="accent1"/>
+          </a:fillRef>
+          <a:effectRef idx="2">
+            <a:schemeClr val="accent1"/>
+          </a:effectRef>
+          <a:fontRef idx="minor">
+            <a:schemeClr val="lt1"/>
+          </a:fontRef>
+        </p:style>
+        <p:txBody>
+          <a:bodyPr rtlCol="0" anchor="ctr"/>
+          <a:lstStyle/>
+          <a:p>
+            <a:pPr algn="ctr"/>
+            <a:endParaRPr/>
+          </a:p>
+        </p:txBody>
+      </p:sp>
+      <p:sp>
+        <p:nvSpPr>
+          <p:cNvPr id="23" name="TextBox 22"/>
+          <p:cNvSpPr txBox="1"/>
+          <p:nvPr/>
+        </p:nvSpPr>
+        <p:spPr>
+          <a:xfrm>
+            <a:off x="822960" y="2990088"/>
+            <a:ext cx="457200" cy="365760"/>
+          </a:xfrm>
+          <a:prstGeom prst="rect">
+            <a:avLst/>
+          </a:prstGeom>
+          <a:noFill/>
+        </p:spPr>
+        <p:txBody>
+          <a:bodyPr wrap="square" lIns="0" tIns="0" rIns="0" bIns="0" anchor="ctr">
+            <a:spAutoFit/>
+          </a:bodyPr>
+          <a:lstStyle/>
+          <a:p>
+            <a:pPr algn="ctr"/>
+            <a:r>
+              <a:rPr sz="1500" b="1" i="0">
+                <a:solidFill>
+                  <a:srgbClr val="FFFFFF"/>
+                </a:solidFill>
+                <a:latin typeface="Calibri"/>
+              </a:rPr>
+              <a:t>3</a:t>
+            </a:r>
+          </a:p>
+        </p:txBody>
+      </p:sp>
+      <p:sp>
+        <p:nvSpPr>
+          <p:cNvPr id="24" name="TextBox 23"/>
+          <p:cNvSpPr txBox="1"/>
+          <p:nvPr/>
+        </p:nvSpPr>
+        <p:spPr>
+          <a:xfrm>
+            <a:off x="1463040" y="2779776"/>
+            <a:ext cx="4553712" cy="329184"/>
+          </a:xfrm>
+          <a:prstGeom prst="rect">
+            <a:avLst/>
+          </a:prstGeom>
+          <a:noFill/>
+        </p:spPr>
+        <p:txBody>
+          <a:bodyPr wrap="square" lIns="0" tIns="0" rIns="0" bIns="0" anchor="t">
+            <a:spAutoFit/>
+          </a:bodyPr>
+          <a:lstStyle/>
+          <a:p>
+            <a:pPr algn="l"/>
+            <a:r>
+              <a:rPr sz="1400" b="1" i="0">
+                <a:solidFill>
+                  <a:srgbClr val="21295C"/>
+                </a:solidFill>
+                <a:latin typeface="Calibri"/>
+              </a:rPr>
+              <a:t>Multi-window architektura</a:t>
+            </a:r>
+          </a:p>
+        </p:txBody>
+      </p:sp>
+      <p:sp>
+        <p:nvSpPr>
+          <p:cNvPr id="25" name="TextBox 24"/>
+          <p:cNvSpPr txBox="1"/>
+          <p:nvPr/>
+        </p:nvSpPr>
+        <p:spPr>
+          <a:xfrm>
+            <a:off x="1463040" y="3108960"/>
+            <a:ext cx="4553712" cy="566928"/>
+          </a:xfrm>
+          <a:prstGeom prst="rect">
+            <a:avLst/>
+          </a:prstGeom>
+          <a:noFill/>
+        </p:spPr>
+        <p:txBody>
+          <a:bodyPr wrap="square" lIns="0" tIns="0" rIns="0" bIns="0">
+            <a:spAutoFit/>
+          </a:bodyPr>
+          <a:lstStyle/>
+          <a:p>
+            <a:pPr algn="l">
+              <a:lnSpc>
+                <a:spcPct val="125000"/>
+              </a:lnSpc>
+              <a:spcAft>
+                <a:spcPts val="400"/>
+              </a:spcAft>
+            </a:pPr>
+            <a:r>
+              <a:rPr sz="1100" b="0" i="0">
+                <a:solidFill>
+                  <a:srgbClr val="5C6B82"/>
+                </a:solidFill>
+                <a:latin typeface="Calibri"/>
+              </a:rPr>
+              <a:t>Primary okno persistuje config; scratch okna (Cmd+Shift+N) mají izolovaný stav. Per-window PersistenceMode chrání primary's UserDefaults před experimenty.</a:t>
+            </a:r>
+          </a:p>
+        </p:txBody>
+      </p:sp>
+      <p:sp>
+        <p:nvSpPr>
+          <p:cNvPr id="26" name="Rectangle 25"/>
+          <p:cNvSpPr/>
+          <p:nvPr/>
+        </p:nvSpPr>
+        <p:spPr>
+          <a:xfrm>
+            <a:off x="6291072" y="2633472"/>
+            <a:ext cx="5650992" cy="1078992"/>
+          </a:xfrm>
+          <a:prstGeom prst="rect">
+            <a:avLst/>
+          </a:prstGeom>
+          <a:solidFill>
+            <a:srgbClr val="FFFFFF"/>
+          </a:solidFill>
+          <a:ln w="6350">
+            <a:solidFill>
+              <a:srgbClr val="D8E0EA"/>
+            </a:solidFill>
+          </a:ln>
+          <a:effectLst/>
+        </p:spPr>
+        <p:style>
+          <a:lnRef idx="1">
+            <a:schemeClr val="accent1"/>
+          </a:lnRef>
+          <a:fillRef idx="3">
+            <a:schemeClr val="accent1"/>
+          </a:fillRef>
+          <a:effectRef idx="2">
+            <a:schemeClr val="accent1"/>
+          </a:effectRef>
+          <a:fontRef idx="minor">
+            <a:schemeClr val="lt1"/>
+          </a:fontRef>
+        </p:style>
+        <p:txBody>
+          <a:bodyPr rtlCol="0" anchor="ctr"/>
+          <a:lstStyle/>
+          <a:p>
+            <a:pPr algn="ctr"/>
+            <a:endParaRPr/>
+          </a:p>
+        </p:txBody>
+      </p:sp>
+      <p:sp>
+        <p:nvSpPr>
+          <p:cNvPr id="27" name="Rectangle 26"/>
+          <p:cNvSpPr/>
+          <p:nvPr/>
+        </p:nvSpPr>
+        <p:spPr>
+          <a:xfrm>
+            <a:off x="6291072" y="2633472"/>
+            <a:ext cx="73152" cy="1078992"/>
+          </a:xfrm>
+          <a:prstGeom prst="rect">
+            <a:avLst/>
+          </a:prstGeom>
+          <a:solidFill>
+            <a:srgbClr val="1C7293"/>
+          </a:solidFill>
+          <a:ln>
+            <a:noFill/>
+          </a:ln>
+          <a:effectLst/>
+        </p:spPr>
+        <p:style>
+          <a:lnRef idx="1">
+            <a:schemeClr val="accent1"/>
+          </a:lnRef>
+          <a:fillRef idx="3">
+            <a:schemeClr val="accent1"/>
+          </a:fillRef>
+          <a:effectRef idx="2">
+            <a:schemeClr val="accent1"/>
+          </a:effectRef>
+          <a:fontRef idx="minor">
+            <a:schemeClr val="lt1"/>
+          </a:fontRef>
+        </p:style>
+        <p:txBody>
+          <a:bodyPr rtlCol="0" anchor="ctr"/>
+          <a:lstStyle/>
+          <a:p>
+            <a:pPr algn="ctr"/>
+            <a:endParaRPr/>
+          </a:p>
+        </p:txBody>
+      </p:sp>
+      <p:sp>
+        <p:nvSpPr>
+          <p:cNvPr id="28" name="Oval 27"/>
+          <p:cNvSpPr/>
+          <p:nvPr/>
+        </p:nvSpPr>
+        <p:spPr>
+          <a:xfrm>
+            <a:off x="6611112" y="2944368"/>
+            <a:ext cx="457200" cy="457200"/>
+          </a:xfrm>
+          <a:prstGeom prst="ellipse">
+            <a:avLst/>
+          </a:prstGeom>
+          <a:solidFill>
+            <a:srgbClr val="065A82"/>
+          </a:solidFill>
+          <a:ln>
+            <a:noFill/>
+          </a:ln>
+          <a:effectLst/>
+        </p:spPr>
+        <p:style>
+          <a:lnRef idx="1">
+            <a:schemeClr val="accent1"/>
+          </a:lnRef>
+          <a:fillRef idx="3">
+            <a:schemeClr val="accent1"/>
+          </a:fillRef>
+          <a:effectRef idx="2">
+            <a:schemeClr val="accent1"/>
+          </a:effectRef>
+          <a:fontRef idx="minor">
+            <a:schemeClr val="lt1"/>
+          </a:fontRef>
+        </p:style>
+        <p:txBody>
+          <a:bodyPr rtlCol="0" anchor="ctr"/>
+          <a:lstStyle/>
+          <a:p>
+            <a:pPr algn="ctr"/>
+            <a:endParaRPr/>
+          </a:p>
+        </p:txBody>
+      </p:sp>
+      <p:sp>
+        <p:nvSpPr>
+          <p:cNvPr id="29" name="TextBox 28"/>
+          <p:cNvSpPr txBox="1"/>
+          <p:nvPr/>
+        </p:nvSpPr>
+        <p:spPr>
+          <a:xfrm>
+            <a:off x="6611112" y="2990088"/>
+            <a:ext cx="457200" cy="365760"/>
+          </a:xfrm>
+          <a:prstGeom prst="rect">
+            <a:avLst/>
+          </a:prstGeom>
+          <a:noFill/>
+        </p:spPr>
+        <p:txBody>
+          <a:bodyPr wrap="square" lIns="0" tIns="0" rIns="0" bIns="0" anchor="ctr">
+            <a:spAutoFit/>
+          </a:bodyPr>
+          <a:lstStyle/>
+          <a:p>
+            <a:pPr algn="ctr"/>
+            <a:r>
+              <a:rPr sz="1500" b="1" i="0">
+                <a:solidFill>
+                  <a:srgbClr val="FFFFFF"/>
+                </a:solidFill>
+                <a:latin typeface="Calibri"/>
+              </a:rPr>
+              <a:t>4</a:t>
+            </a:r>
+          </a:p>
+        </p:txBody>
+      </p:sp>
+      <p:sp>
+        <p:nvSpPr>
+          <p:cNvPr id="30" name="TextBox 29"/>
+          <p:cNvSpPr txBox="1"/>
+          <p:nvPr/>
+        </p:nvSpPr>
+        <p:spPr>
+          <a:xfrm>
+            <a:off x="7251192" y="2779776"/>
+            <a:ext cx="4553712" cy="329184"/>
+          </a:xfrm>
+          <a:prstGeom prst="rect">
+            <a:avLst/>
+          </a:prstGeom>
+          <a:noFill/>
+        </p:spPr>
+        <p:txBody>
+          <a:bodyPr wrap="square" lIns="0" tIns="0" rIns="0" bIns="0" anchor="t">
+            <a:spAutoFit/>
+          </a:bodyPr>
+          <a:lstStyle/>
+          <a:p>
+            <a:pPr algn="l"/>
+            <a:r>
+              <a:rPr sz="1400" b="1" i="0">
+                <a:solidFill>
+                  <a:srgbClr val="21295C"/>
+                </a:solidFill>
+                <a:latin typeface="Calibri"/>
+              </a:rPr>
+              <a:t>Save / Load Project</a:t>
+            </a:r>
+          </a:p>
+        </p:txBody>
+      </p:sp>
+      <p:sp>
+        <p:nvSpPr>
+          <p:cNvPr id="31" name="TextBox 30"/>
+          <p:cNvSpPr txBox="1"/>
+          <p:nvPr/>
+        </p:nvSpPr>
+        <p:spPr>
+          <a:xfrm>
+            <a:off x="7251192" y="3108960"/>
+            <a:ext cx="4553712" cy="566928"/>
+          </a:xfrm>
+          <a:prstGeom prst="rect">
+            <a:avLst/>
+          </a:prstGeom>
+          <a:noFill/>
+        </p:spPr>
+        <p:txBody>
+          <a:bodyPr wrap="square" lIns="0" tIns="0" rIns="0" bIns="0">
+            <a:spAutoFit/>
+          </a:bodyPr>
+          <a:lstStyle/>
+          <a:p>
+            <a:pPr algn="l">
+              <a:lnSpc>
+                <a:spcPct val="125000"/>
+              </a:lnSpc>
+              <a:spcAft>
+                <a:spcPts val="400"/>
+              </a:spcAft>
+            </a:pPr>
+            <a:r>
+              <a:rPr sz="1100" b="0" i="0">
+                <a:solidFill>
+                  <a:srgbClr val="5C6B82"/>
+                </a:solidFill>
+                <a:latin typeface="Calibri"/>
+              </a:rPr>
+              <a:t>.spiceharvester.json snapshot: folders + model + prompt + režim. Cmd+Shift+S uloží, Cmd+O načte. Server registry zůstává globální (mezi projekty se nemíchá).</a:t>
+            </a:r>
+          </a:p>
+        </p:txBody>
+      </p:sp>
+      <p:sp>
+        <p:nvSpPr>
+          <p:cNvPr id="32" name="Rectangle 31"/>
+          <p:cNvSpPr/>
+          <p:nvPr/>
+        </p:nvSpPr>
+        <p:spPr>
+          <a:xfrm>
+            <a:off x="502920" y="3803904"/>
+            <a:ext cx="5650992" cy="1078992"/>
+          </a:xfrm>
+          <a:prstGeom prst="rect">
+            <a:avLst/>
+          </a:prstGeom>
+          <a:solidFill>
+            <a:srgbClr val="FFFFFF"/>
+          </a:solidFill>
+          <a:ln w="6350">
+            <a:solidFill>
+              <a:srgbClr val="D8E0EA"/>
+            </a:solidFill>
+          </a:ln>
+          <a:effectLst/>
+        </p:spPr>
+        <p:style>
+          <a:lnRef idx="1">
+            <a:schemeClr val="accent1"/>
+          </a:lnRef>
+          <a:fillRef idx="3">
+            <a:schemeClr val="accent1"/>
+          </a:fillRef>
+          <a:effectRef idx="2">
+            <a:schemeClr val="accent1"/>
+          </a:effectRef>
+          <a:fontRef idx="minor">
+            <a:schemeClr val="lt1"/>
+          </a:fontRef>
+        </p:style>
+        <p:txBody>
+          <a:bodyPr rtlCol="0" anchor="ctr"/>
+          <a:lstStyle/>
+          <a:p>
+            <a:pPr algn="ctr"/>
+            <a:endParaRPr/>
+          </a:p>
+        </p:txBody>
+      </p:sp>
+      <p:sp>
+        <p:nvSpPr>
+          <p:cNvPr id="33" name="Rectangle 32"/>
+          <p:cNvSpPr/>
+          <p:nvPr/>
+        </p:nvSpPr>
+        <p:spPr>
+          <a:xfrm>
+            <a:off x="502920" y="3803904"/>
+            <a:ext cx="73152" cy="1078992"/>
+          </a:xfrm>
+          <a:prstGeom prst="rect">
+            <a:avLst/>
+          </a:prstGeom>
+          <a:solidFill>
+            <a:srgbClr val="1C7293"/>
+          </a:solidFill>
+          <a:ln>
+            <a:noFill/>
+          </a:ln>
+          <a:effectLst/>
+        </p:spPr>
+        <p:style>
+          <a:lnRef idx="1">
+            <a:schemeClr val="accent1"/>
+          </a:lnRef>
+          <a:fillRef idx="3">
+            <a:schemeClr val="accent1"/>
+          </a:fillRef>
+          <a:effectRef idx="2">
+            <a:schemeClr val="accent1"/>
+          </a:effectRef>
+          <a:fontRef idx="minor">
+            <a:schemeClr val="lt1"/>
+          </a:fontRef>
+        </p:style>
+        <p:txBody>
+          <a:bodyPr rtlCol="0" anchor="ctr"/>
+          <a:lstStyle/>
+          <a:p>
+            <a:pPr algn="ctr"/>
+            <a:endParaRPr/>
+          </a:p>
+        </p:txBody>
+      </p:sp>
+      <p:sp>
+        <p:nvSpPr>
+          <p:cNvPr id="34" name="Oval 33"/>
+          <p:cNvSpPr/>
+          <p:nvPr/>
+        </p:nvSpPr>
+        <p:spPr>
+          <a:xfrm>
+            <a:off x="822960" y="4114800"/>
+            <a:ext cx="457200" cy="457200"/>
+          </a:xfrm>
+          <a:prstGeom prst="ellipse">
+            <a:avLst/>
+          </a:prstGeom>
+          <a:solidFill>
+            <a:srgbClr val="065A82"/>
+          </a:solidFill>
+          <a:ln>
+            <a:noFill/>
+          </a:ln>
+          <a:effectLst/>
+        </p:spPr>
+        <p:style>
+          <a:lnRef idx="1">
+            <a:schemeClr val="accent1"/>
+          </a:lnRef>
+          <a:fillRef idx="3">
+            <a:schemeClr val="accent1"/>
+          </a:fillRef>
+          <a:effectRef idx="2">
+            <a:schemeClr val="accent1"/>
+          </a:effectRef>
+          <a:fontRef idx="minor">
+            <a:schemeClr val="lt1"/>
+          </a:fontRef>
+        </p:style>
+        <p:txBody>
+          <a:bodyPr rtlCol="0" anchor="ctr"/>
+          <a:lstStyle/>
+          <a:p>
+            <a:pPr algn="ctr"/>
+            <a:endParaRPr/>
+          </a:p>
+        </p:txBody>
+      </p:sp>
+      <p:sp>
+        <p:nvSpPr>
+          <p:cNvPr id="35" name="TextBox 34"/>
+          <p:cNvSpPr txBox="1"/>
+          <p:nvPr/>
+        </p:nvSpPr>
+        <p:spPr>
+          <a:xfrm>
+            <a:off x="822960" y="4160520"/>
+            <a:ext cx="457200" cy="365760"/>
+          </a:xfrm>
+          <a:prstGeom prst="rect">
+            <a:avLst/>
+          </a:prstGeom>
+          <a:noFill/>
+        </p:spPr>
+        <p:txBody>
+          <a:bodyPr wrap="square" lIns="0" tIns="0" rIns="0" bIns="0" anchor="ctr">
+            <a:spAutoFit/>
+          </a:bodyPr>
+          <a:lstStyle/>
+          <a:p>
+            <a:pPr algn="ctr"/>
+            <a:r>
+              <a:rPr sz="1500" b="1" i="0">
+                <a:solidFill>
+                  <a:srgbClr val="FFFFFF"/>
+                </a:solidFill>
+                <a:latin typeface="Calibri"/>
+              </a:rPr>
+              <a:t>5</a:t>
+            </a:r>
+          </a:p>
+        </p:txBody>
+      </p:sp>
+      <p:sp>
+        <p:nvSpPr>
+          <p:cNvPr id="36" name="TextBox 35"/>
+          <p:cNvSpPr txBox="1"/>
+          <p:nvPr/>
+        </p:nvSpPr>
+        <p:spPr>
+          <a:xfrm>
+            <a:off x="1463040" y="3950208"/>
+            <a:ext cx="4553712" cy="329184"/>
+          </a:xfrm>
+          <a:prstGeom prst="rect">
+            <a:avLst/>
+          </a:prstGeom>
+          <a:noFill/>
+        </p:spPr>
+        <p:txBody>
+          <a:bodyPr wrap="square" lIns="0" tIns="0" rIns="0" bIns="0" anchor="t">
+            <a:spAutoFit/>
+          </a:bodyPr>
+          <a:lstStyle/>
+          <a:p>
+            <a:pPr algn="l"/>
+            <a:r>
+              <a:rPr sz="1400" b="1" i="0">
+                <a:solidFill>
+                  <a:srgbClr val="21295C"/>
+                </a:solidFill>
+                <a:latin typeface="Calibri"/>
+              </a:rPr>
+              <a:t>Otevřít nedávné · sandbox-aware</a:t>
+            </a:r>
+          </a:p>
+        </p:txBody>
+      </p:sp>
+      <p:sp>
+        <p:nvSpPr>
+          <p:cNvPr id="37" name="TextBox 36"/>
+          <p:cNvSpPr txBox="1"/>
+          <p:nvPr/>
+        </p:nvSpPr>
+        <p:spPr>
+          <a:xfrm>
+            <a:off x="1463040" y="4279392"/>
+            <a:ext cx="4553712" cy="566928"/>
+          </a:xfrm>
+          <a:prstGeom prst="rect">
+            <a:avLst/>
+          </a:prstGeom>
+          <a:noFill/>
+        </p:spPr>
+        <p:txBody>
+          <a:bodyPr wrap="square" lIns="0" tIns="0" rIns="0" bIns="0">
+            <a:spAutoFit/>
+          </a:bodyPr>
+          <a:lstStyle/>
+          <a:p>
+            <a:pPr algn="l">
+              <a:lnSpc>
+                <a:spcPct val="125000"/>
+              </a:lnSpc>
+              <a:spcAft>
+                <a:spcPts val="400"/>
+              </a:spcAft>
+            </a:pPr>
+            <a:r>
+              <a:rPr sz="1100" b="0" i="0">
+                <a:solidFill>
+                  <a:srgbClr val="5C6B82"/>
+                </a:solidFill>
+                <a:latin typeface="Calibri"/>
+              </a:rPr>
+              <a:t>Posledních 8 projektů s persistentními security-scoped bookmarky — přežijí restart aplikace. Cross-window sync přes NotificationCenter.</a:t>
+            </a:r>
+          </a:p>
+        </p:txBody>
+      </p:sp>
+      <p:sp>
+        <p:nvSpPr>
+          <p:cNvPr id="38" name="Rectangle 37"/>
+          <p:cNvSpPr/>
+          <p:nvPr/>
+        </p:nvSpPr>
+        <p:spPr>
+          <a:xfrm>
+            <a:off x="6291072" y="3803904"/>
+            <a:ext cx="5650992" cy="1078992"/>
+          </a:xfrm>
+          <a:prstGeom prst="rect">
+            <a:avLst/>
+          </a:prstGeom>
+          <a:solidFill>
+            <a:srgbClr val="FFFFFF"/>
+          </a:solidFill>
+          <a:ln w="6350">
+            <a:solidFill>
+              <a:srgbClr val="D8E0EA"/>
+            </a:solidFill>
+          </a:ln>
+          <a:effectLst/>
+        </p:spPr>
+        <p:style>
+          <a:lnRef idx="1">
+            <a:schemeClr val="accent1"/>
+          </a:lnRef>
+          <a:fillRef idx="3">
+            <a:schemeClr val="accent1"/>
+          </a:fillRef>
+          <a:effectRef idx="2">
+            <a:schemeClr val="accent1"/>
+          </a:effectRef>
+          <a:fontRef idx="minor">
+            <a:schemeClr val="lt1"/>
+          </a:fontRef>
+        </p:style>
+        <p:txBody>
+          <a:bodyPr rtlCol="0" anchor="ctr"/>
+          <a:lstStyle/>
+          <a:p>
+            <a:pPr algn="ctr"/>
+            <a:endParaRPr/>
+          </a:p>
+        </p:txBody>
+      </p:sp>
+      <p:sp>
+        <p:nvSpPr>
+          <p:cNvPr id="39" name="Rectangle 38"/>
+          <p:cNvSpPr/>
+          <p:nvPr/>
+        </p:nvSpPr>
+        <p:spPr>
+          <a:xfrm>
+            <a:off x="6291072" y="3803904"/>
+            <a:ext cx="73152" cy="1078992"/>
+          </a:xfrm>
+          <a:prstGeom prst="rect">
+            <a:avLst/>
+          </a:prstGeom>
+          <a:solidFill>
+            <a:srgbClr val="1C7293"/>
+          </a:solidFill>
+          <a:ln>
+            <a:noFill/>
+          </a:ln>
+          <a:effectLst/>
+        </p:spPr>
+        <p:style>
+          <a:lnRef idx="1">
+            <a:schemeClr val="accent1"/>
+          </a:lnRef>
+          <a:fillRef idx="3">
+            <a:schemeClr val="accent1"/>
+          </a:fillRef>
+          <a:effectRef idx="2">
+            <a:schemeClr val="accent1"/>
+          </a:effectRef>
+          <a:fontRef idx="minor">
+            <a:schemeClr val="lt1"/>
+          </a:fontRef>
+        </p:style>
+        <p:txBody>
+          <a:bodyPr rtlCol="0" anchor="ctr"/>
+          <a:lstStyle/>
+          <a:p>
+            <a:pPr algn="ctr"/>
+            <a:endParaRPr/>
+          </a:p>
+        </p:txBody>
+      </p:sp>
+      <p:sp>
+        <p:nvSpPr>
+          <p:cNvPr id="40" name="Oval 39"/>
+          <p:cNvSpPr/>
+          <p:nvPr/>
+        </p:nvSpPr>
+        <p:spPr>
+          <a:xfrm>
+            <a:off x="6611112" y="4114800"/>
+            <a:ext cx="457200" cy="457200"/>
+          </a:xfrm>
+          <a:prstGeom prst="ellipse">
+            <a:avLst/>
+          </a:prstGeom>
+          <a:solidFill>
+            <a:srgbClr val="065A82"/>
+          </a:solidFill>
+          <a:ln>
+            <a:noFill/>
+          </a:ln>
+          <a:effectLst/>
+        </p:spPr>
+        <p:style>
+          <a:lnRef idx="1">
+            <a:schemeClr val="accent1"/>
+          </a:lnRef>
+          <a:fillRef idx="3">
+            <a:schemeClr val="accent1"/>
+          </a:fillRef>
+          <a:effectRef idx="2">
+            <a:schemeClr val="accent1"/>
+          </a:effectRef>
+          <a:fontRef idx="minor">
+            <a:schemeClr val="lt1"/>
+          </a:fontRef>
+        </p:style>
+        <p:txBody>
+          <a:bodyPr rtlCol="0" anchor="ctr"/>
+          <a:lstStyle/>
+          <a:p>
+            <a:pPr algn="ctr"/>
+            <a:endParaRPr/>
+          </a:p>
+        </p:txBody>
+      </p:sp>
+      <p:sp>
+        <p:nvSpPr>
+          <p:cNvPr id="41" name="TextBox 40"/>
+          <p:cNvSpPr txBox="1"/>
+          <p:nvPr/>
+        </p:nvSpPr>
+        <p:spPr>
+          <a:xfrm>
+            <a:off x="6611112" y="4160520"/>
+            <a:ext cx="457200" cy="365760"/>
+          </a:xfrm>
+          <a:prstGeom prst="rect">
+            <a:avLst/>
+          </a:prstGeom>
+          <a:noFill/>
+        </p:spPr>
+        <p:txBody>
+          <a:bodyPr wrap="square" lIns="0" tIns="0" rIns="0" bIns="0" anchor="ctr">
+            <a:spAutoFit/>
+          </a:bodyPr>
+          <a:lstStyle/>
+          <a:p>
+            <a:pPr algn="ctr"/>
+            <a:r>
+              <a:rPr sz="1500" b="1" i="0">
+                <a:solidFill>
+                  <a:srgbClr val="FFFFFF"/>
+                </a:solidFill>
+                <a:latin typeface="Calibri"/>
+              </a:rPr>
+              <a:t>6</a:t>
+            </a:r>
+          </a:p>
+        </p:txBody>
+      </p:sp>
+      <p:sp>
+        <p:nvSpPr>
+          <p:cNvPr id="42" name="TextBox 41"/>
+          <p:cNvSpPr txBox="1"/>
+          <p:nvPr/>
+        </p:nvSpPr>
+        <p:spPr>
+          <a:xfrm>
+            <a:off x="7251192" y="3950208"/>
+            <a:ext cx="4553712" cy="329184"/>
+          </a:xfrm>
+          <a:prstGeom prst="rect">
+            <a:avLst/>
+          </a:prstGeom>
+          <a:noFill/>
+        </p:spPr>
+        <p:txBody>
+          <a:bodyPr wrap="square" lIns="0" tIns="0" rIns="0" bIns="0" anchor="t">
+            <a:spAutoFit/>
+          </a:bodyPr>
+          <a:lstStyle/>
+          <a:p>
+            <a:pPr algn="l"/>
+            <a:r>
+              <a:rPr sz="1400" b="1" i="0">
+                <a:solidFill>
+                  <a:srgbClr val="21295C"/>
+                </a:solidFill>
+                <a:latin typeface="Calibri"/>
+              </a:rPr>
+              <a:t>AppIntents · Siri · Spotlight</a:t>
+            </a:r>
+          </a:p>
+        </p:txBody>
+      </p:sp>
+      <p:sp>
+        <p:nvSpPr>
+          <p:cNvPr id="43" name="TextBox 42"/>
+          <p:cNvSpPr txBox="1"/>
+          <p:nvPr/>
+        </p:nvSpPr>
+        <p:spPr>
+          <a:xfrm>
+            <a:off x="7251192" y="4279392"/>
+            <a:ext cx="4553712" cy="566928"/>
+          </a:xfrm>
+          <a:prstGeom prst="rect">
+            <a:avLst/>
+          </a:prstGeom>
+          <a:noFill/>
+        </p:spPr>
+        <p:txBody>
+          <a:bodyPr wrap="square" lIns="0" tIns="0" rIns="0" bIns="0">
+            <a:spAutoFit/>
+          </a:bodyPr>
+          <a:lstStyle/>
+          <a:p>
+            <a:pPr algn="l">
+              <a:lnSpc>
+                <a:spcPct val="125000"/>
+              </a:lnSpc>
+              <a:spcAft>
+                <a:spcPts val="400"/>
+              </a:spcAft>
+            </a:pPr>
+            <a:r>
+              <a:rPr sz="1100" b="0" i="0">
+                <a:solidFill>
+                  <a:srgbClr val="5C6B82"/>
+                </a:solidFill>
+                <a:latin typeface="Calibri"/>
+              </a:rPr>
+              <a:t>Frází Spusť Spice Harvester / Run Spice Harvester. macOS 14+ vystavuje akce v gallery i Spotlight nabídkách. Strukturovaný ReturnsValue + ProvidesDialog.</a:t>
+            </a:r>
+          </a:p>
+        </p:txBody>
+      </p:sp>
+      <p:sp>
+        <p:nvSpPr>
+          <p:cNvPr id="44" name="Rectangle 43"/>
+          <p:cNvSpPr/>
+          <p:nvPr/>
+        </p:nvSpPr>
+        <p:spPr>
+          <a:xfrm>
+            <a:off x="502920" y="4974336"/>
+            <a:ext cx="5650992" cy="1078992"/>
+          </a:xfrm>
+          <a:prstGeom prst="rect">
+            <a:avLst/>
+          </a:prstGeom>
+          <a:solidFill>
+            <a:srgbClr val="FFFFFF"/>
+          </a:solidFill>
+          <a:ln w="6350">
+            <a:solidFill>
+              <a:srgbClr val="D8E0EA"/>
+            </a:solidFill>
+          </a:ln>
+          <a:effectLst/>
+        </p:spPr>
+        <p:style>
+          <a:lnRef idx="1">
+            <a:schemeClr val="accent1"/>
+          </a:lnRef>
+          <a:fillRef idx="3">
+            <a:schemeClr val="accent1"/>
+          </a:fillRef>
+          <a:effectRef idx="2">
+            <a:schemeClr val="accent1"/>
+          </a:effectRef>
+          <a:fontRef idx="minor">
+            <a:schemeClr val="lt1"/>
+          </a:fontRef>
+        </p:style>
+        <p:txBody>
+          <a:bodyPr rtlCol="0" anchor="ctr"/>
+          <a:lstStyle/>
+          <a:p>
+            <a:pPr algn="ctr"/>
+            <a:endParaRPr/>
+          </a:p>
+        </p:txBody>
+      </p:sp>
+      <p:sp>
+        <p:nvSpPr>
+          <p:cNvPr id="45" name="Rectangle 44"/>
+          <p:cNvSpPr/>
+          <p:nvPr/>
+        </p:nvSpPr>
+        <p:spPr>
+          <a:xfrm>
+            <a:off x="502920" y="4974336"/>
+            <a:ext cx="73152" cy="1078992"/>
+          </a:xfrm>
+          <a:prstGeom prst="rect">
+            <a:avLst/>
+          </a:prstGeom>
+          <a:solidFill>
+            <a:srgbClr val="1C7293"/>
+          </a:solidFill>
+          <a:ln>
+            <a:noFill/>
+          </a:ln>
+          <a:effectLst/>
+        </p:spPr>
+        <p:style>
+          <a:lnRef idx="1">
+            <a:schemeClr val="accent1"/>
+          </a:lnRef>
+          <a:fillRef idx="3">
+            <a:schemeClr val="accent1"/>
+          </a:fillRef>
+          <a:effectRef idx="2">
+            <a:schemeClr val="accent1"/>
+          </a:effectRef>
+          <a:fontRef idx="minor">
+            <a:schemeClr val="lt1"/>
+          </a:fontRef>
+        </p:style>
+        <p:txBody>
+          <a:bodyPr rtlCol="0" anchor="ctr"/>
+          <a:lstStyle/>
+          <a:p>
+            <a:pPr algn="ctr"/>
+            <a:endParaRPr/>
+          </a:p>
+        </p:txBody>
+      </p:sp>
+      <p:sp>
+        <p:nvSpPr>
+          <p:cNvPr id="46" name="Oval 45"/>
+          <p:cNvSpPr/>
+          <p:nvPr/>
+        </p:nvSpPr>
+        <p:spPr>
+          <a:xfrm>
+            <a:off x="822960" y="5285232"/>
+            <a:ext cx="457200" cy="457200"/>
+          </a:xfrm>
+          <a:prstGeom prst="ellipse">
+            <a:avLst/>
+          </a:prstGeom>
+          <a:solidFill>
+            <a:srgbClr val="065A82"/>
+          </a:solidFill>
+          <a:ln>
+            <a:noFill/>
+          </a:ln>
+          <a:effectLst/>
+        </p:spPr>
+        <p:style>
+          <a:lnRef idx="1">
+            <a:schemeClr val="accent1"/>
+          </a:lnRef>
+          <a:fillRef idx="3">
+            <a:schemeClr val="accent1"/>
+          </a:fillRef>
+          <a:effectRef idx="2">
+            <a:schemeClr val="accent1"/>
+          </a:effectRef>
+          <a:fontRef idx="minor">
+            <a:schemeClr val="lt1"/>
+          </a:fontRef>
+        </p:style>
+        <p:txBody>
+          <a:bodyPr rtlCol="0" anchor="ctr"/>
+          <a:lstStyle/>
+          <a:p>
+            <a:pPr algn="ctr"/>
+            <a:endParaRPr/>
+          </a:p>
+        </p:txBody>
+      </p:sp>
+      <p:sp>
+        <p:nvSpPr>
+          <p:cNvPr id="47" name="TextBox 46"/>
+          <p:cNvSpPr txBox="1"/>
+          <p:nvPr/>
+        </p:nvSpPr>
+        <p:spPr>
+          <a:xfrm>
+            <a:off x="822960" y="5330952"/>
+            <a:ext cx="457200" cy="365760"/>
+          </a:xfrm>
+          <a:prstGeom prst="rect">
+            <a:avLst/>
+          </a:prstGeom>
+          <a:noFill/>
+        </p:spPr>
+        <p:txBody>
+          <a:bodyPr wrap="square" lIns="0" tIns="0" rIns="0" bIns="0" anchor="ctr">
+            <a:spAutoFit/>
+          </a:bodyPr>
+          <a:lstStyle/>
+          <a:p>
+            <a:pPr algn="ctr"/>
+            <a:r>
+              <a:rPr sz="1500" b="1" i="0">
+                <a:solidFill>
+                  <a:srgbClr val="FFFFFF"/>
+                </a:solidFill>
+                <a:latin typeface="Calibri"/>
+              </a:rPr>
+              <a:t>7</a:t>
+            </a:r>
+          </a:p>
+        </p:txBody>
+      </p:sp>
+      <p:sp>
+        <p:nvSpPr>
+          <p:cNvPr id="48" name="TextBox 47"/>
+          <p:cNvSpPr txBox="1"/>
+          <p:nvPr/>
+        </p:nvSpPr>
+        <p:spPr>
+          <a:xfrm>
+            <a:off x="1463040" y="5120640"/>
+            <a:ext cx="4553712" cy="329184"/>
+          </a:xfrm>
+          <a:prstGeom prst="rect">
+            <a:avLst/>
+          </a:prstGeom>
+          <a:noFill/>
+        </p:spPr>
+        <p:txBody>
+          <a:bodyPr wrap="square" lIns="0" tIns="0" rIns="0" bIns="0" anchor="t">
+            <a:spAutoFit/>
+          </a:bodyPr>
+          <a:lstStyle/>
+          <a:p>
+            <a:pPr algn="l"/>
+            <a:r>
+              <a:rPr sz="1400" b="1" i="0">
+                <a:solidFill>
+                  <a:srgbClr val="21295C"/>
+                </a:solidFill>
+                <a:latin typeface="Calibri"/>
+              </a:rPr>
+              <a:t>Pipeline menu bar</a:t>
+            </a:r>
+          </a:p>
+        </p:txBody>
+      </p:sp>
+      <p:sp>
+        <p:nvSpPr>
+          <p:cNvPr id="49" name="TextBox 48"/>
+          <p:cNvSpPr txBox="1"/>
+          <p:nvPr/>
+        </p:nvSpPr>
+        <p:spPr>
+          <a:xfrm>
+            <a:off x="1463040" y="5449824"/>
+            <a:ext cx="4553712" cy="566928"/>
+          </a:xfrm>
+          <a:prstGeom prst="rect">
+            <a:avLst/>
+          </a:prstGeom>
+          <a:noFill/>
+        </p:spPr>
+        <p:txBody>
+          <a:bodyPr wrap="square" lIns="0" tIns="0" rIns="0" bIns="0">
+            <a:spAutoFit/>
+          </a:bodyPr>
+          <a:lstStyle/>
+          <a:p>
+            <a:pPr algn="l">
+              <a:lnSpc>
+                <a:spcPct val="125000"/>
+              </a:lnSpc>
+              <a:spcAft>
+                <a:spcPts val="400"/>
+              </a:spcAft>
+            </a:pPr>
+            <a:r>
+              <a:rPr sz="1100" b="0" i="0">
+                <a:solidFill>
+                  <a:srgbClr val="5C6B82"/>
+                </a:solidFill>
+                <a:latin typeface="Calibri"/>
+              </a:rPr>
+              <a:t>Top-level CommandMenu Pipeline: Spustit (Cmd+R), Přerušit (Cmd+.), režim FAST/SEARCH/CONSOLIDATE (Cmd+1/2/3). Konvence Xcode/Logic/Final Cut.</a:t>
+            </a:r>
+          </a:p>
+        </p:txBody>
+      </p:sp>
+      <p:sp>
+        <p:nvSpPr>
+          <p:cNvPr id="50" name="Rectangle 49"/>
+          <p:cNvSpPr/>
+          <p:nvPr/>
+        </p:nvSpPr>
+        <p:spPr>
+          <a:xfrm>
+            <a:off x="6291072" y="4974336"/>
+            <a:ext cx="5650992" cy="1078992"/>
+          </a:xfrm>
+          <a:prstGeom prst="rect">
+            <a:avLst/>
+          </a:prstGeom>
+          <a:solidFill>
+            <a:srgbClr val="FFFFFF"/>
+          </a:solidFill>
+          <a:ln w="6350">
+            <a:solidFill>
+              <a:srgbClr val="D8E0EA"/>
+            </a:solidFill>
+          </a:ln>
+          <a:effectLst/>
+        </p:spPr>
+        <p:style>
+          <a:lnRef idx="1">
+            <a:schemeClr val="accent1"/>
+          </a:lnRef>
+          <a:fillRef idx="3">
+            <a:schemeClr val="accent1"/>
+          </a:fillRef>
+          <a:effectRef idx="2">
+            <a:schemeClr val="accent1"/>
+          </a:effectRef>
+          <a:fontRef idx="minor">
+            <a:schemeClr val="lt1"/>
+          </a:fontRef>
+        </p:style>
+        <p:txBody>
+          <a:bodyPr rtlCol="0" anchor="ctr"/>
+          <a:lstStyle/>
+          <a:p>
+            <a:pPr algn="ctr"/>
+            <a:endParaRPr/>
+          </a:p>
+        </p:txBody>
+      </p:sp>
+      <p:sp>
+        <p:nvSpPr>
+          <p:cNvPr id="51" name="Rectangle 50"/>
+          <p:cNvSpPr/>
+          <p:nvPr/>
+        </p:nvSpPr>
+        <p:spPr>
+          <a:xfrm>
+            <a:off x="6291072" y="4974336"/>
+            <a:ext cx="73152" cy="1078992"/>
+          </a:xfrm>
+          <a:prstGeom prst="rect">
+            <a:avLst/>
+          </a:prstGeom>
+          <a:solidFill>
+            <a:srgbClr val="1C7293"/>
+          </a:solidFill>
+          <a:ln>
+            <a:noFill/>
+          </a:ln>
+          <a:effectLst/>
+        </p:spPr>
+        <p:style>
+          <a:lnRef idx="1">
+            <a:schemeClr val="accent1"/>
+          </a:lnRef>
+          <a:fillRef idx="3">
+            <a:schemeClr val="accent1"/>
+          </a:fillRef>
+          <a:effectRef idx="2">
+            <a:schemeClr val="accent1"/>
+          </a:effectRef>
+          <a:fontRef idx="minor">
+            <a:schemeClr val="lt1"/>
+          </a:fontRef>
+        </p:style>
+        <p:txBody>
+          <a:bodyPr rtlCol="0" anchor="ctr"/>
+          <a:lstStyle/>
+          <a:p>
+            <a:pPr algn="ctr"/>
+            <a:endParaRPr/>
+          </a:p>
+        </p:txBody>
+      </p:sp>
+      <p:sp>
+        <p:nvSpPr>
+          <p:cNvPr id="52" name="Oval 51"/>
+          <p:cNvSpPr/>
+          <p:nvPr/>
+        </p:nvSpPr>
+        <p:spPr>
+          <a:xfrm>
+            <a:off x="6611112" y="5285232"/>
+            <a:ext cx="457200" cy="457200"/>
+          </a:xfrm>
+          <a:prstGeom prst="ellipse">
+            <a:avLst/>
+          </a:prstGeom>
+          <a:solidFill>
+            <a:srgbClr val="065A82"/>
+          </a:solidFill>
+          <a:ln>
+            <a:noFill/>
+          </a:ln>
+          <a:effectLst/>
+        </p:spPr>
+        <p:style>
+          <a:lnRef idx="1">
+            <a:schemeClr val="accent1"/>
+          </a:lnRef>
+          <a:fillRef idx="3">
+            <a:schemeClr val="accent1"/>
+          </a:fillRef>
+          <a:effectRef idx="2">
+            <a:schemeClr val="accent1"/>
+          </a:effectRef>
+          <a:fontRef idx="minor">
+            <a:schemeClr val="lt1"/>
+          </a:fontRef>
+        </p:style>
+        <p:txBody>
+          <a:bodyPr rtlCol="0" anchor="ctr"/>
+          <a:lstStyle/>
+          <a:p>
+            <a:pPr algn="ctr"/>
+            <a:endParaRPr/>
+          </a:p>
+        </p:txBody>
+      </p:sp>
+      <p:sp>
+        <p:nvSpPr>
+          <p:cNvPr id="53" name="TextBox 52"/>
+          <p:cNvSpPr txBox="1"/>
+          <p:nvPr/>
+        </p:nvSpPr>
+        <p:spPr>
+          <a:xfrm>
+            <a:off x="6611112" y="5330952"/>
+            <a:ext cx="457200" cy="365760"/>
+          </a:xfrm>
+          <a:prstGeom prst="rect">
+            <a:avLst/>
+          </a:prstGeom>
+          <a:noFill/>
+        </p:spPr>
+        <p:txBody>
+          <a:bodyPr wrap="square" lIns="0" tIns="0" rIns="0" bIns="0" anchor="ctr">
+            <a:spAutoFit/>
+          </a:bodyPr>
+          <a:lstStyle/>
+          <a:p>
+            <a:pPr algn="ctr"/>
+            <a:r>
+              <a:rPr sz="1500" b="1" i="0">
+                <a:solidFill>
+                  <a:srgbClr val="FFFFFF"/>
+                </a:solidFill>
+                <a:latin typeface="Calibri"/>
+              </a:rPr>
+              <a:t>8</a:t>
+            </a:r>
+          </a:p>
+        </p:txBody>
+      </p:sp>
+      <p:sp>
+        <p:nvSpPr>
+          <p:cNvPr id="54" name="TextBox 53"/>
+          <p:cNvSpPr txBox="1"/>
+          <p:nvPr/>
+        </p:nvSpPr>
+        <p:spPr>
+          <a:xfrm>
+            <a:off x="7251192" y="5120640"/>
+            <a:ext cx="4553712" cy="329184"/>
+          </a:xfrm>
+          <a:prstGeom prst="rect">
+            <a:avLst/>
+          </a:prstGeom>
+          <a:noFill/>
+        </p:spPr>
+        <p:txBody>
+          <a:bodyPr wrap="square" lIns="0" tIns="0" rIns="0" bIns="0" anchor="t">
+            <a:spAutoFit/>
+          </a:bodyPr>
+          <a:lstStyle/>
+          <a:p>
+            <a:pPr algn="l"/>
+            <a:r>
+              <a:rPr sz="1400" b="1" i="0">
+                <a:solidFill>
+                  <a:srgbClr val="21295C"/>
+                </a:solidFill>
+                <a:latin typeface="Calibri"/>
+              </a:rPr>
+              <a:t>Health watcher + manuální recheck</a:t>
+            </a:r>
+          </a:p>
+        </p:txBody>
+      </p:sp>
+      <p:sp>
+        <p:nvSpPr>
+          <p:cNvPr id="55" name="TextBox 54"/>
+          <p:cNvSpPr txBox="1"/>
+          <p:nvPr/>
+        </p:nvSpPr>
+        <p:spPr>
+          <a:xfrm>
+            <a:off x="7251192" y="5449824"/>
+            <a:ext cx="4553712" cy="566928"/>
+          </a:xfrm>
+          <a:prstGeom prst="rect">
+            <a:avLst/>
+          </a:prstGeom>
+          <a:noFill/>
+        </p:spPr>
+        <p:txBody>
+          <a:bodyPr wrap="square" lIns="0" tIns="0" rIns="0" bIns="0">
+            <a:spAutoFit/>
+          </a:bodyPr>
+          <a:lstStyle/>
+          <a:p>
+            <a:pPr algn="l">
+              <a:lnSpc>
+                <a:spcPct val="125000"/>
+              </a:lnSpc>
+              <a:spcAft>
+                <a:spcPts val="400"/>
+              </a:spcAft>
+            </a:pPr>
+            <a:r>
+              <a:rPr sz="1100" b="0" i="0">
+                <a:solidFill>
+                  <a:srgbClr val="5C6B82"/>
+                </a:solidFill>
+                <a:latin typeface="Calibri"/>
+              </a:rPr>
+              <a:t>30 s ambient ping na /v1/models; status pill zčervená při disconnectu. Pipeline → Znovu ověřit zdraví serveru pro okamžitou kontrolu po restartu LM Studia.</a:t>
+            </a:r>
+          </a:p>
+        </p:txBody>
+      </p:sp>
+    </p:spTree>
+  </p:cSld>
+  <p:clrMapOvr>
+    <a:masterClrMapping/>
+  </p:clrMapOvr>
+</p:sld>
+</file>
+
+<file path=ppt/slides/slide17.xml><?xml version="1.0" encoding="utf-8"?>
 <p:sld xmlns:a="http://schemas.openxmlformats.org/drawingml/2006/main" xmlns:r="http://schemas.openxmlformats.org/officeDocument/2006/relationships" xmlns:p="http://schemas.openxmlformats.org/presentationml/2006/main">
   <p:cSld>
     <p:spTree>
@@ -16148,2252 +18394,6 @@
         <p14:creationId xmlns:p14="http://schemas.microsoft.com/office/powerpoint/2010/main" val="1413184550"/>
       </p:ext>
     </p:extLst>
-  </p:cSld>
-  <p:clrMapOvr>
-    <a:masterClrMapping/>
-  </p:clrMapOvr>
-</p:sld>
-</file>
-
-<file path=ppt/slides/slide17.xml><?xml version="1.0" encoding="utf-8"?>
-<p:sld xmlns:a="http://schemas.openxmlformats.org/drawingml/2006/main" xmlns:p="http://schemas.openxmlformats.org/presentationml/2006/main" xmlns:r="http://schemas.openxmlformats.org/officeDocument/2006/relationships">
-  <p:cSld>
-    <p:spTree>
-      <p:nvGrpSpPr>
-        <p:cNvPr id="1" name=""/>
-        <p:cNvGrpSpPr/>
-        <p:nvPr/>
-      </p:nvGrpSpPr>
-      <p:grpSpPr/>
-      <p:sp>
-        <p:nvSpPr>
-          <p:cNvPr id="2" name="Rectangle 1"/>
-          <p:cNvSpPr/>
-          <p:nvPr/>
-        </p:nvSpPr>
-        <p:spPr>
-          <a:xfrm>
-            <a:off x="0" y="0"/>
-            <a:ext cx="12191695" cy="146304"/>
-          </a:xfrm>
-          <a:prstGeom prst="rect">
-            <a:avLst/>
-          </a:prstGeom>
-          <a:solidFill>
-            <a:srgbClr val="065A82"/>
-          </a:solidFill>
-          <a:ln>
-            <a:noFill/>
-          </a:ln>
-          <a:effectLst/>
-        </p:spPr>
-        <p:style>
-          <a:lnRef idx="1">
-            <a:schemeClr val="accent1"/>
-          </a:lnRef>
-          <a:fillRef idx="3">
-            <a:schemeClr val="accent1"/>
-          </a:fillRef>
-          <a:effectRef idx="2">
-            <a:schemeClr val="accent1"/>
-          </a:effectRef>
-          <a:fontRef idx="minor">
-            <a:schemeClr val="lt1"/>
-          </a:fontRef>
-        </p:style>
-        <p:txBody>
-          <a:bodyPr rtlCol="0" anchor="ctr"/>
-          <a:lstStyle/>
-          <a:p>
-            <a:pPr algn="ctr"/>
-            <a:endParaRPr/>
-          </a:p>
-        </p:txBody>
-      </p:sp>
-      <p:sp>
-        <p:nvSpPr>
-          <p:cNvPr id="3" name="Rectangle 2"/>
-          <p:cNvSpPr/>
-          <p:nvPr/>
-        </p:nvSpPr>
-        <p:spPr>
-          <a:xfrm>
-            <a:off x="0" y="146304"/>
-            <a:ext cx="164592" cy="6711696"/>
-          </a:xfrm>
-          <a:prstGeom prst="rect">
-            <a:avLst/>
-          </a:prstGeom>
-          <a:solidFill>
-            <a:srgbClr val="F5B041"/>
-          </a:solidFill>
-          <a:ln>
-            <a:noFill/>
-          </a:ln>
-          <a:effectLst/>
-        </p:spPr>
-        <p:style>
-          <a:lnRef idx="1">
-            <a:schemeClr val="accent1"/>
-          </a:lnRef>
-          <a:fillRef idx="3">
-            <a:schemeClr val="accent1"/>
-          </a:fillRef>
-          <a:effectRef idx="2">
-            <a:schemeClr val="accent1"/>
-          </a:effectRef>
-          <a:fontRef idx="minor">
-            <a:schemeClr val="lt1"/>
-          </a:fontRef>
-        </p:style>
-        <p:txBody>
-          <a:bodyPr rtlCol="0" anchor="ctr"/>
-          <a:lstStyle/>
-          <a:p>
-            <a:pPr algn="ctr"/>
-            <a:endParaRPr/>
-          </a:p>
-        </p:txBody>
-      </p:sp>
-      <p:sp>
-        <p:nvSpPr>
-          <p:cNvPr id="4" name="TextBox 3"/>
-          <p:cNvSpPr txBox="1"/>
-          <p:nvPr/>
-        </p:nvSpPr>
-        <p:spPr>
-          <a:xfrm>
-            <a:off x="502920" y="365760"/>
-            <a:ext cx="10058400" cy="461665"/>
-          </a:xfrm>
-          <a:prstGeom prst="rect">
-            <a:avLst/>
-          </a:prstGeom>
-          <a:noFill/>
-        </p:spPr>
-        <p:txBody>
-          <a:bodyPr wrap="square" lIns="0" tIns="0" rIns="0" bIns="0" anchor="t">
-            <a:spAutoFit/>
-          </a:bodyPr>
-          <a:lstStyle/>
-          <a:p>
-            <a:pPr algn="l"/>
-            <a:r>
-              <a:rPr sz="3000" b="1" i="0" dirty="0" err="1">
-                <a:solidFill>
-                  <a:srgbClr val="21295C"/>
-                </a:solidFill>
-                <a:latin typeface="Calibri"/>
-              </a:rPr>
-              <a:t>Automatizace a integrace s macOS</a:t>
-            </a:r>
-            <a:endParaRPr sz="3000" b="1" i="0" dirty="0">
-              <a:solidFill>
-                <a:srgbClr val="21295C"/>
-              </a:solidFill>
-              <a:latin typeface="Calibri"/>
-            </a:endParaRPr>
-          </a:p>
-        </p:txBody>
-      </p:sp>
-      <p:sp>
-        <p:nvSpPr>
-          <p:cNvPr id="5" name="TextBox 4"/>
-          <p:cNvSpPr txBox="1"/>
-          <p:nvPr/>
-        </p:nvSpPr>
-        <p:spPr>
-          <a:xfrm>
-            <a:off x="502920" y="960120"/>
-            <a:ext cx="10058400" cy="365760"/>
-          </a:xfrm>
-          <a:prstGeom prst="rect">
-            <a:avLst/>
-          </a:prstGeom>
-          <a:noFill/>
-        </p:spPr>
-        <p:txBody>
-          <a:bodyPr wrap="square" lIns="0" tIns="0" rIns="0" bIns="0" anchor="t">
-            <a:spAutoFit/>
-          </a:bodyPr>
-          <a:lstStyle/>
-          <a:p>
-            <a:pPr algn="l"/>
-            <a:r>
-              <a:rPr sz="1400" b="0" i="1">
-                <a:solidFill>
-                  <a:srgbClr val="1C7293"/>
-                </a:solidFill>
-                <a:latin typeface="Calibri"/>
-              </a:rPr>
-              <a:t>Job-ready Shortcuts, multi-window, projekty, native menu</a:t>
-            </a:r>
-          </a:p>
-        </p:txBody>
-      </p:sp>
-      <p:sp>
-        <p:nvSpPr>
-          <p:cNvPr id="6" name="TextBox 5"/>
-          <p:cNvSpPr txBox="1"/>
-          <p:nvPr/>
-        </p:nvSpPr>
-        <p:spPr>
-          <a:xfrm>
-            <a:off x="10789920" y="6446520"/>
-            <a:ext cx="1280160" cy="320040"/>
-          </a:xfrm>
-          <a:prstGeom prst="rect">
-            <a:avLst/>
-          </a:prstGeom>
-          <a:noFill/>
-        </p:spPr>
-        <p:txBody>
-          <a:bodyPr wrap="square" lIns="0" tIns="0" rIns="0" bIns="0" anchor="t">
-            <a:spAutoFit/>
-          </a:bodyPr>
-          <a:lstStyle/>
-          <a:p>
-            <a:pPr algn="r"/>
-            <a:r>
-              <a:rPr sz="1000" b="0" i="0">
-                <a:solidFill>
-                  <a:srgbClr val="5C6B82"/>
-                </a:solidFill>
-                <a:latin typeface="Calibri"/>
-              </a:rPr>
-              <a:t>16 / 16</a:t>
-            </a:r>
-          </a:p>
-        </p:txBody>
-      </p:sp>
-      <p:sp>
-        <p:nvSpPr>
-          <p:cNvPr id="7" name="TextBox 6"/>
-          <p:cNvSpPr txBox="1"/>
-          <p:nvPr/>
-        </p:nvSpPr>
-        <p:spPr>
-          <a:xfrm>
-            <a:off x="502920" y="6446520"/>
-            <a:ext cx="5486400" cy="320040"/>
-          </a:xfrm>
-          <a:prstGeom prst="rect">
-            <a:avLst/>
-          </a:prstGeom>
-          <a:noFill/>
-        </p:spPr>
-        <p:txBody>
-          <a:bodyPr wrap="square" lIns="0" tIns="0" rIns="0" bIns="0" anchor="t">
-            <a:spAutoFit/>
-          </a:bodyPr>
-          <a:lstStyle/>
-          <a:p>
-            <a:pPr algn="l"/>
-            <a:r>
-              <a:rPr sz="1000" b="0" i="0">
-                <a:solidFill>
-                  <a:srgbClr val="5C6B82"/>
-                </a:solidFill>
-                <a:latin typeface="Calibri"/>
-              </a:rPr>
-              <a:t>SpiceHarvester · Lokální dávkové vytěžování PDF přes LLM</a:t>
-            </a:r>
-          </a:p>
-        </p:txBody>
-      </p:sp>
-      <p:sp>
-        <p:nvSpPr>
-          <p:cNvPr id="8" name="Rectangle 7"/>
-          <p:cNvSpPr/>
-          <p:nvPr/>
-        </p:nvSpPr>
-        <p:spPr>
-          <a:xfrm>
-            <a:off x="502920" y="1463040"/>
-            <a:ext cx="5650992" cy="1078992"/>
-          </a:xfrm>
-          <a:prstGeom prst="rect">
-            <a:avLst/>
-          </a:prstGeom>
-          <a:solidFill>
-            <a:srgbClr val="FFFFFF"/>
-          </a:solidFill>
-          <a:ln w="6350">
-            <a:solidFill>
-              <a:srgbClr val="D8E0EA"/>
-            </a:solidFill>
-          </a:ln>
-          <a:effectLst/>
-        </p:spPr>
-        <p:style>
-          <a:lnRef idx="1">
-            <a:schemeClr val="accent1"/>
-          </a:lnRef>
-          <a:fillRef idx="3">
-            <a:schemeClr val="accent1"/>
-          </a:fillRef>
-          <a:effectRef idx="2">
-            <a:schemeClr val="accent1"/>
-          </a:effectRef>
-          <a:fontRef idx="minor">
-            <a:schemeClr val="lt1"/>
-          </a:fontRef>
-        </p:style>
-        <p:txBody>
-          <a:bodyPr rtlCol="0" anchor="ctr"/>
-          <a:lstStyle/>
-          <a:p>
-            <a:pPr algn="ctr"/>
-            <a:endParaRPr/>
-          </a:p>
-        </p:txBody>
-      </p:sp>
-      <p:sp>
-        <p:nvSpPr>
-          <p:cNvPr id="9" name="Rectangle 8"/>
-          <p:cNvSpPr/>
-          <p:nvPr/>
-        </p:nvSpPr>
-        <p:spPr>
-          <a:xfrm>
-            <a:off x="502920" y="1463040"/>
-            <a:ext cx="73152" cy="1078992"/>
-          </a:xfrm>
-          <a:prstGeom prst="rect">
-            <a:avLst/>
-          </a:prstGeom>
-          <a:solidFill>
-            <a:srgbClr val="1C7293"/>
-          </a:solidFill>
-          <a:ln>
-            <a:noFill/>
-          </a:ln>
-          <a:effectLst/>
-        </p:spPr>
-        <p:style>
-          <a:lnRef idx="1">
-            <a:schemeClr val="accent1"/>
-          </a:lnRef>
-          <a:fillRef idx="3">
-            <a:schemeClr val="accent1"/>
-          </a:fillRef>
-          <a:effectRef idx="2">
-            <a:schemeClr val="accent1"/>
-          </a:effectRef>
-          <a:fontRef idx="minor">
-            <a:schemeClr val="lt1"/>
-          </a:fontRef>
-        </p:style>
-        <p:txBody>
-          <a:bodyPr rtlCol="0" anchor="ctr"/>
-          <a:lstStyle/>
-          <a:p>
-            <a:pPr algn="ctr"/>
-            <a:endParaRPr/>
-          </a:p>
-        </p:txBody>
-      </p:sp>
-      <p:sp>
-        <p:nvSpPr>
-          <p:cNvPr id="10" name="Oval 9"/>
-          <p:cNvSpPr/>
-          <p:nvPr/>
-        </p:nvSpPr>
-        <p:spPr>
-          <a:xfrm>
-            <a:off x="822960" y="1773936"/>
-            <a:ext cx="457200" cy="457200"/>
-          </a:xfrm>
-          <a:prstGeom prst="ellipse">
-            <a:avLst/>
-          </a:prstGeom>
-          <a:solidFill>
-            <a:srgbClr val="065A82"/>
-          </a:solidFill>
-          <a:ln>
-            <a:noFill/>
-          </a:ln>
-          <a:effectLst/>
-        </p:spPr>
-        <p:style>
-          <a:lnRef idx="1">
-            <a:schemeClr val="accent1"/>
-          </a:lnRef>
-          <a:fillRef idx="3">
-            <a:schemeClr val="accent1"/>
-          </a:fillRef>
-          <a:effectRef idx="2">
-            <a:schemeClr val="accent1"/>
-          </a:effectRef>
-          <a:fontRef idx="minor">
-            <a:schemeClr val="lt1"/>
-          </a:fontRef>
-        </p:style>
-        <p:txBody>
-          <a:bodyPr rtlCol="0" anchor="ctr"/>
-          <a:lstStyle/>
-          <a:p>
-            <a:pPr algn="ctr"/>
-            <a:endParaRPr/>
-          </a:p>
-        </p:txBody>
-      </p:sp>
-      <p:sp>
-        <p:nvSpPr>
-          <p:cNvPr id="11" name="TextBox 10"/>
-          <p:cNvSpPr txBox="1"/>
-          <p:nvPr/>
-        </p:nvSpPr>
-        <p:spPr>
-          <a:xfrm>
-            <a:off x="822960" y="1819656"/>
-            <a:ext cx="457200" cy="365760"/>
-          </a:xfrm>
-          <a:prstGeom prst="rect">
-            <a:avLst/>
-          </a:prstGeom>
-          <a:noFill/>
-        </p:spPr>
-        <p:txBody>
-          <a:bodyPr wrap="square" lIns="0" tIns="0" rIns="0" bIns="0" anchor="ctr">
-            <a:spAutoFit/>
-          </a:bodyPr>
-          <a:lstStyle/>
-          <a:p>
-            <a:pPr algn="ctr"/>
-            <a:r>
-              <a:rPr sz="1500" b="1" i="0">
-                <a:solidFill>
-                  <a:srgbClr val="FFFFFF"/>
-                </a:solidFill>
-                <a:latin typeface="Calibri"/>
-              </a:rPr>
-              <a:t>1</a:t>
-            </a:r>
-          </a:p>
-        </p:txBody>
-      </p:sp>
-      <p:sp>
-        <p:nvSpPr>
-          <p:cNvPr id="12" name="TextBox 11"/>
-          <p:cNvSpPr txBox="1"/>
-          <p:nvPr/>
-        </p:nvSpPr>
-        <p:spPr>
-          <a:xfrm>
-            <a:off x="1463040" y="1609344"/>
-            <a:ext cx="4553712" cy="329184"/>
-          </a:xfrm>
-          <a:prstGeom prst="rect">
-            <a:avLst/>
-          </a:prstGeom>
-          <a:noFill/>
-        </p:spPr>
-        <p:txBody>
-          <a:bodyPr wrap="square" lIns="0" tIns="0" rIns="0" bIns="0" anchor="t">
-            <a:spAutoFit/>
-          </a:bodyPr>
-          <a:lstStyle/>
-          <a:p>
-            <a:pPr algn="l"/>
-            <a:r>
-              <a:rPr sz="1400" b="1" i="0">
-                <a:solidFill>
-                  <a:srgbClr val="21295C"/>
-                </a:solidFill>
-                <a:latin typeface="Calibri"/>
-              </a:rPr>
-              <a:t>Shortcuts.app jako job</a:t>
-            </a:r>
-          </a:p>
-        </p:txBody>
-      </p:sp>
-      <p:sp>
-        <p:nvSpPr>
-          <p:cNvPr id="13" name="TextBox 12"/>
-          <p:cNvSpPr txBox="1"/>
-          <p:nvPr/>
-        </p:nvSpPr>
-        <p:spPr>
-          <a:xfrm>
-            <a:off x="1463040" y="1938528"/>
-            <a:ext cx="4553712" cy="566928"/>
-          </a:xfrm>
-          <a:prstGeom prst="rect">
-            <a:avLst/>
-          </a:prstGeom>
-          <a:noFill/>
-        </p:spPr>
-        <p:txBody>
-          <a:bodyPr wrap="square" lIns="0" tIns="0" rIns="0" bIns="0">
-            <a:spAutoFit/>
-          </a:bodyPr>
-          <a:lstStyle/>
-          <a:p>
-            <a:pPr algn="l">
-              <a:lnSpc>
-                <a:spcPct val="125000"/>
-              </a:lnSpc>
-              <a:spcAft>
-                <a:spcPts val="400"/>
-              </a:spcAft>
-            </a:pPr>
-            <a:r>
-              <a:rPr sz="1100" b="0" i="0">
-                <a:solidFill>
-                  <a:srgbClr val="5C6B82"/>
-                </a:solidFill>
-                <a:latin typeface="Calibri"/>
-              </a:rPr>
-              <a:t>Akce Spustit extrakci s volitelnými parametry Režim a Název promptu. perform() ČEKÁ na dokončení a vrátí cestu k results.csv pro řetězení dalších kroků.</a:t>
-            </a:r>
-          </a:p>
-        </p:txBody>
-      </p:sp>
-      <p:sp>
-        <p:nvSpPr>
-          <p:cNvPr id="14" name="Rectangle 13"/>
-          <p:cNvSpPr/>
-          <p:nvPr/>
-        </p:nvSpPr>
-        <p:spPr>
-          <a:xfrm>
-            <a:off x="6291072" y="1463040"/>
-            <a:ext cx="5650992" cy="1078992"/>
-          </a:xfrm>
-          <a:prstGeom prst="rect">
-            <a:avLst/>
-          </a:prstGeom>
-          <a:solidFill>
-            <a:srgbClr val="FFFFFF"/>
-          </a:solidFill>
-          <a:ln w="6350">
-            <a:solidFill>
-              <a:srgbClr val="D8E0EA"/>
-            </a:solidFill>
-          </a:ln>
-          <a:effectLst/>
-        </p:spPr>
-        <p:style>
-          <a:lnRef idx="1">
-            <a:schemeClr val="accent1"/>
-          </a:lnRef>
-          <a:fillRef idx="3">
-            <a:schemeClr val="accent1"/>
-          </a:fillRef>
-          <a:effectRef idx="2">
-            <a:schemeClr val="accent1"/>
-          </a:effectRef>
-          <a:fontRef idx="minor">
-            <a:schemeClr val="lt1"/>
-          </a:fontRef>
-        </p:style>
-        <p:txBody>
-          <a:bodyPr rtlCol="0" anchor="ctr"/>
-          <a:lstStyle/>
-          <a:p>
-            <a:pPr algn="ctr"/>
-            <a:endParaRPr/>
-          </a:p>
-        </p:txBody>
-      </p:sp>
-      <p:sp>
-        <p:nvSpPr>
-          <p:cNvPr id="15" name="Rectangle 14"/>
-          <p:cNvSpPr/>
-          <p:nvPr/>
-        </p:nvSpPr>
-        <p:spPr>
-          <a:xfrm>
-            <a:off x="6291072" y="1463040"/>
-            <a:ext cx="73152" cy="1078992"/>
-          </a:xfrm>
-          <a:prstGeom prst="rect">
-            <a:avLst/>
-          </a:prstGeom>
-          <a:solidFill>
-            <a:srgbClr val="1C7293"/>
-          </a:solidFill>
-          <a:ln>
-            <a:noFill/>
-          </a:ln>
-          <a:effectLst/>
-        </p:spPr>
-        <p:style>
-          <a:lnRef idx="1">
-            <a:schemeClr val="accent1"/>
-          </a:lnRef>
-          <a:fillRef idx="3">
-            <a:schemeClr val="accent1"/>
-          </a:fillRef>
-          <a:effectRef idx="2">
-            <a:schemeClr val="accent1"/>
-          </a:effectRef>
-          <a:fontRef idx="minor">
-            <a:schemeClr val="lt1"/>
-          </a:fontRef>
-        </p:style>
-        <p:txBody>
-          <a:bodyPr rtlCol="0" anchor="ctr"/>
-          <a:lstStyle/>
-          <a:p>
-            <a:pPr algn="ctr"/>
-            <a:endParaRPr/>
-          </a:p>
-        </p:txBody>
-      </p:sp>
-      <p:sp>
-        <p:nvSpPr>
-          <p:cNvPr id="16" name="Oval 15"/>
-          <p:cNvSpPr/>
-          <p:nvPr/>
-        </p:nvSpPr>
-        <p:spPr>
-          <a:xfrm>
-            <a:off x="6611112" y="1773936"/>
-            <a:ext cx="457200" cy="457200"/>
-          </a:xfrm>
-          <a:prstGeom prst="ellipse">
-            <a:avLst/>
-          </a:prstGeom>
-          <a:solidFill>
-            <a:srgbClr val="065A82"/>
-          </a:solidFill>
-          <a:ln>
-            <a:noFill/>
-          </a:ln>
-          <a:effectLst/>
-        </p:spPr>
-        <p:style>
-          <a:lnRef idx="1">
-            <a:schemeClr val="accent1"/>
-          </a:lnRef>
-          <a:fillRef idx="3">
-            <a:schemeClr val="accent1"/>
-          </a:fillRef>
-          <a:effectRef idx="2">
-            <a:schemeClr val="accent1"/>
-          </a:effectRef>
-          <a:fontRef idx="minor">
-            <a:schemeClr val="lt1"/>
-          </a:fontRef>
-        </p:style>
-        <p:txBody>
-          <a:bodyPr rtlCol="0" anchor="ctr"/>
-          <a:lstStyle/>
-          <a:p>
-            <a:pPr algn="ctr"/>
-            <a:endParaRPr/>
-          </a:p>
-        </p:txBody>
-      </p:sp>
-      <p:sp>
-        <p:nvSpPr>
-          <p:cNvPr id="17" name="TextBox 16"/>
-          <p:cNvSpPr txBox="1"/>
-          <p:nvPr/>
-        </p:nvSpPr>
-        <p:spPr>
-          <a:xfrm>
-            <a:off x="6611112" y="1819656"/>
-            <a:ext cx="457200" cy="365760"/>
-          </a:xfrm>
-          <a:prstGeom prst="rect">
-            <a:avLst/>
-          </a:prstGeom>
-          <a:noFill/>
-        </p:spPr>
-        <p:txBody>
-          <a:bodyPr wrap="square" lIns="0" tIns="0" rIns="0" bIns="0" anchor="ctr">
-            <a:spAutoFit/>
-          </a:bodyPr>
-          <a:lstStyle/>
-          <a:p>
-            <a:pPr algn="ctr"/>
-            <a:r>
-              <a:rPr sz="1500" b="1" i="0">
-                <a:solidFill>
-                  <a:srgbClr val="FFFFFF"/>
-                </a:solidFill>
-                <a:latin typeface="Calibri"/>
-              </a:rPr>
-              <a:t>2</a:t>
-            </a:r>
-          </a:p>
-        </p:txBody>
-      </p:sp>
-      <p:sp>
-        <p:nvSpPr>
-          <p:cNvPr id="18" name="TextBox 17"/>
-          <p:cNvSpPr txBox="1"/>
-          <p:nvPr/>
-        </p:nvSpPr>
-        <p:spPr>
-          <a:xfrm>
-            <a:off x="7251192" y="1609344"/>
-            <a:ext cx="4553712" cy="329184"/>
-          </a:xfrm>
-          <a:prstGeom prst="rect">
-            <a:avLst/>
-          </a:prstGeom>
-          <a:noFill/>
-        </p:spPr>
-        <p:txBody>
-          <a:bodyPr wrap="square" lIns="0" tIns="0" rIns="0" bIns="0" anchor="t">
-            <a:spAutoFit/>
-          </a:bodyPr>
-          <a:lstStyle/>
-          <a:p>
-            <a:pPr algn="l"/>
-            <a:r>
-              <a:rPr sz="1400" b="1" i="0">
-                <a:solidFill>
-                  <a:srgbClr val="21295C"/>
-                </a:solidFill>
-                <a:latin typeface="Calibri"/>
-              </a:rPr>
-              <a:t>Plánované běhy (cron-like)</a:t>
-            </a:r>
-          </a:p>
-        </p:txBody>
-      </p:sp>
-      <p:sp>
-        <p:nvSpPr>
-          <p:cNvPr id="19" name="TextBox 18"/>
-          <p:cNvSpPr txBox="1"/>
-          <p:nvPr/>
-        </p:nvSpPr>
-        <p:spPr>
-          <a:xfrm>
-            <a:off x="7251192" y="1938528"/>
-            <a:ext cx="4553712" cy="566928"/>
-          </a:xfrm>
-          <a:prstGeom prst="rect">
-            <a:avLst/>
-          </a:prstGeom>
-          <a:noFill/>
-        </p:spPr>
-        <p:txBody>
-          <a:bodyPr wrap="square" lIns="0" tIns="0" rIns="0" bIns="0">
-            <a:spAutoFit/>
-          </a:bodyPr>
-          <a:lstStyle/>
-          <a:p>
-            <a:pPr algn="l">
-              <a:lnSpc>
-                <a:spcPct val="125000"/>
-              </a:lnSpc>
-              <a:spcAft>
-                <a:spcPts val="400"/>
-              </a:spcAft>
-            </a:pPr>
-            <a:r>
-              <a:rPr sz="1100" b="0" i="0">
-                <a:solidFill>
-                  <a:srgbClr val="5C6B82"/>
-                </a:solidFill>
-                <a:latin typeface="Calibri"/>
-              </a:rPr>
-              <a:t>Zkratky.app → Automatizace → Time of Day. Denní extrakce v 8:00, navazující akce: poslat CSV na mail, push do gitu, notify na Slack. Bez Ask Before Running tichý běh.</a:t>
-            </a:r>
-          </a:p>
-        </p:txBody>
-      </p:sp>
-      <p:sp>
-        <p:nvSpPr>
-          <p:cNvPr id="20" name="Rectangle 19"/>
-          <p:cNvSpPr/>
-          <p:nvPr/>
-        </p:nvSpPr>
-        <p:spPr>
-          <a:xfrm>
-            <a:off x="502920" y="2633472"/>
-            <a:ext cx="5650992" cy="1078992"/>
-          </a:xfrm>
-          <a:prstGeom prst="rect">
-            <a:avLst/>
-          </a:prstGeom>
-          <a:solidFill>
-            <a:srgbClr val="FFFFFF"/>
-          </a:solidFill>
-          <a:ln w="6350">
-            <a:solidFill>
-              <a:srgbClr val="D8E0EA"/>
-            </a:solidFill>
-          </a:ln>
-          <a:effectLst/>
-        </p:spPr>
-        <p:style>
-          <a:lnRef idx="1">
-            <a:schemeClr val="accent1"/>
-          </a:lnRef>
-          <a:fillRef idx="3">
-            <a:schemeClr val="accent1"/>
-          </a:fillRef>
-          <a:effectRef idx="2">
-            <a:schemeClr val="accent1"/>
-          </a:effectRef>
-          <a:fontRef idx="minor">
-            <a:schemeClr val="lt1"/>
-          </a:fontRef>
-        </p:style>
-        <p:txBody>
-          <a:bodyPr rtlCol="0" anchor="ctr"/>
-          <a:lstStyle/>
-          <a:p>
-            <a:pPr algn="ctr"/>
-            <a:endParaRPr/>
-          </a:p>
-        </p:txBody>
-      </p:sp>
-      <p:sp>
-        <p:nvSpPr>
-          <p:cNvPr id="21" name="Rectangle 20"/>
-          <p:cNvSpPr/>
-          <p:nvPr/>
-        </p:nvSpPr>
-        <p:spPr>
-          <a:xfrm>
-            <a:off x="502920" y="2633472"/>
-            <a:ext cx="73152" cy="1078992"/>
-          </a:xfrm>
-          <a:prstGeom prst="rect">
-            <a:avLst/>
-          </a:prstGeom>
-          <a:solidFill>
-            <a:srgbClr val="1C7293"/>
-          </a:solidFill>
-          <a:ln>
-            <a:noFill/>
-          </a:ln>
-          <a:effectLst/>
-        </p:spPr>
-        <p:style>
-          <a:lnRef idx="1">
-            <a:schemeClr val="accent1"/>
-          </a:lnRef>
-          <a:fillRef idx="3">
-            <a:schemeClr val="accent1"/>
-          </a:fillRef>
-          <a:effectRef idx="2">
-            <a:schemeClr val="accent1"/>
-          </a:effectRef>
-          <a:fontRef idx="minor">
-            <a:schemeClr val="lt1"/>
-          </a:fontRef>
-        </p:style>
-        <p:txBody>
-          <a:bodyPr rtlCol="0" anchor="ctr"/>
-          <a:lstStyle/>
-          <a:p>
-            <a:pPr algn="ctr"/>
-            <a:endParaRPr/>
-          </a:p>
-        </p:txBody>
-      </p:sp>
-      <p:sp>
-        <p:nvSpPr>
-          <p:cNvPr id="22" name="Oval 21"/>
-          <p:cNvSpPr/>
-          <p:nvPr/>
-        </p:nvSpPr>
-        <p:spPr>
-          <a:xfrm>
-            <a:off x="822960" y="2944368"/>
-            <a:ext cx="457200" cy="457200"/>
-          </a:xfrm>
-          <a:prstGeom prst="ellipse">
-            <a:avLst/>
-          </a:prstGeom>
-          <a:solidFill>
-            <a:srgbClr val="065A82"/>
-          </a:solidFill>
-          <a:ln>
-            <a:noFill/>
-          </a:ln>
-          <a:effectLst/>
-        </p:spPr>
-        <p:style>
-          <a:lnRef idx="1">
-            <a:schemeClr val="accent1"/>
-          </a:lnRef>
-          <a:fillRef idx="3">
-            <a:schemeClr val="accent1"/>
-          </a:fillRef>
-          <a:effectRef idx="2">
-            <a:schemeClr val="accent1"/>
-          </a:effectRef>
-          <a:fontRef idx="minor">
-            <a:schemeClr val="lt1"/>
-          </a:fontRef>
-        </p:style>
-        <p:txBody>
-          <a:bodyPr rtlCol="0" anchor="ctr"/>
-          <a:lstStyle/>
-          <a:p>
-            <a:pPr algn="ctr"/>
-            <a:endParaRPr/>
-          </a:p>
-        </p:txBody>
-      </p:sp>
-      <p:sp>
-        <p:nvSpPr>
-          <p:cNvPr id="23" name="TextBox 22"/>
-          <p:cNvSpPr txBox="1"/>
-          <p:nvPr/>
-        </p:nvSpPr>
-        <p:spPr>
-          <a:xfrm>
-            <a:off x="822960" y="2990088"/>
-            <a:ext cx="457200" cy="365760"/>
-          </a:xfrm>
-          <a:prstGeom prst="rect">
-            <a:avLst/>
-          </a:prstGeom>
-          <a:noFill/>
-        </p:spPr>
-        <p:txBody>
-          <a:bodyPr wrap="square" lIns="0" tIns="0" rIns="0" bIns="0" anchor="ctr">
-            <a:spAutoFit/>
-          </a:bodyPr>
-          <a:lstStyle/>
-          <a:p>
-            <a:pPr algn="ctr"/>
-            <a:r>
-              <a:rPr sz="1500" b="1" i="0">
-                <a:solidFill>
-                  <a:srgbClr val="FFFFFF"/>
-                </a:solidFill>
-                <a:latin typeface="Calibri"/>
-              </a:rPr>
-              <a:t>3</a:t>
-            </a:r>
-          </a:p>
-        </p:txBody>
-      </p:sp>
-      <p:sp>
-        <p:nvSpPr>
-          <p:cNvPr id="24" name="TextBox 23"/>
-          <p:cNvSpPr txBox="1"/>
-          <p:nvPr/>
-        </p:nvSpPr>
-        <p:spPr>
-          <a:xfrm>
-            <a:off x="1463040" y="2779776"/>
-            <a:ext cx="4553712" cy="329184"/>
-          </a:xfrm>
-          <a:prstGeom prst="rect">
-            <a:avLst/>
-          </a:prstGeom>
-          <a:noFill/>
-        </p:spPr>
-        <p:txBody>
-          <a:bodyPr wrap="square" lIns="0" tIns="0" rIns="0" bIns="0" anchor="t">
-            <a:spAutoFit/>
-          </a:bodyPr>
-          <a:lstStyle/>
-          <a:p>
-            <a:pPr algn="l"/>
-            <a:r>
-              <a:rPr sz="1400" b="1" i="0">
-                <a:solidFill>
-                  <a:srgbClr val="21295C"/>
-                </a:solidFill>
-                <a:latin typeface="Calibri"/>
-              </a:rPr>
-              <a:t>Multi-window architektura</a:t>
-            </a:r>
-          </a:p>
-        </p:txBody>
-      </p:sp>
-      <p:sp>
-        <p:nvSpPr>
-          <p:cNvPr id="25" name="TextBox 24"/>
-          <p:cNvSpPr txBox="1"/>
-          <p:nvPr/>
-        </p:nvSpPr>
-        <p:spPr>
-          <a:xfrm>
-            <a:off x="1463040" y="3108960"/>
-            <a:ext cx="4553712" cy="566928"/>
-          </a:xfrm>
-          <a:prstGeom prst="rect">
-            <a:avLst/>
-          </a:prstGeom>
-          <a:noFill/>
-        </p:spPr>
-        <p:txBody>
-          <a:bodyPr wrap="square" lIns="0" tIns="0" rIns="0" bIns="0">
-            <a:spAutoFit/>
-          </a:bodyPr>
-          <a:lstStyle/>
-          <a:p>
-            <a:pPr algn="l">
-              <a:lnSpc>
-                <a:spcPct val="125000"/>
-              </a:lnSpc>
-              <a:spcAft>
-                <a:spcPts val="400"/>
-              </a:spcAft>
-            </a:pPr>
-            <a:r>
-              <a:rPr sz="1100" b="0" i="0">
-                <a:solidFill>
-                  <a:srgbClr val="5C6B82"/>
-                </a:solidFill>
-                <a:latin typeface="Calibri"/>
-              </a:rPr>
-              <a:t>Primary okno persistuje config; scratch okna (Cmd+Shift+N) mají izolovaný stav. Per-window PersistenceMode chrání primary's UserDefaults před experimenty.</a:t>
-            </a:r>
-          </a:p>
-        </p:txBody>
-      </p:sp>
-      <p:sp>
-        <p:nvSpPr>
-          <p:cNvPr id="26" name="Rectangle 25"/>
-          <p:cNvSpPr/>
-          <p:nvPr/>
-        </p:nvSpPr>
-        <p:spPr>
-          <a:xfrm>
-            <a:off x="6291072" y="2633472"/>
-            <a:ext cx="5650992" cy="1078992"/>
-          </a:xfrm>
-          <a:prstGeom prst="rect">
-            <a:avLst/>
-          </a:prstGeom>
-          <a:solidFill>
-            <a:srgbClr val="FFFFFF"/>
-          </a:solidFill>
-          <a:ln w="6350">
-            <a:solidFill>
-              <a:srgbClr val="D8E0EA"/>
-            </a:solidFill>
-          </a:ln>
-          <a:effectLst/>
-        </p:spPr>
-        <p:style>
-          <a:lnRef idx="1">
-            <a:schemeClr val="accent1"/>
-          </a:lnRef>
-          <a:fillRef idx="3">
-            <a:schemeClr val="accent1"/>
-          </a:fillRef>
-          <a:effectRef idx="2">
-            <a:schemeClr val="accent1"/>
-          </a:effectRef>
-          <a:fontRef idx="minor">
-            <a:schemeClr val="lt1"/>
-          </a:fontRef>
-        </p:style>
-        <p:txBody>
-          <a:bodyPr rtlCol="0" anchor="ctr"/>
-          <a:lstStyle/>
-          <a:p>
-            <a:pPr algn="ctr"/>
-            <a:endParaRPr/>
-          </a:p>
-        </p:txBody>
-      </p:sp>
-      <p:sp>
-        <p:nvSpPr>
-          <p:cNvPr id="27" name="Rectangle 26"/>
-          <p:cNvSpPr/>
-          <p:nvPr/>
-        </p:nvSpPr>
-        <p:spPr>
-          <a:xfrm>
-            <a:off x="6291072" y="2633472"/>
-            <a:ext cx="73152" cy="1078992"/>
-          </a:xfrm>
-          <a:prstGeom prst="rect">
-            <a:avLst/>
-          </a:prstGeom>
-          <a:solidFill>
-            <a:srgbClr val="1C7293"/>
-          </a:solidFill>
-          <a:ln>
-            <a:noFill/>
-          </a:ln>
-          <a:effectLst/>
-        </p:spPr>
-        <p:style>
-          <a:lnRef idx="1">
-            <a:schemeClr val="accent1"/>
-          </a:lnRef>
-          <a:fillRef idx="3">
-            <a:schemeClr val="accent1"/>
-          </a:fillRef>
-          <a:effectRef idx="2">
-            <a:schemeClr val="accent1"/>
-          </a:effectRef>
-          <a:fontRef idx="minor">
-            <a:schemeClr val="lt1"/>
-          </a:fontRef>
-        </p:style>
-        <p:txBody>
-          <a:bodyPr rtlCol="0" anchor="ctr"/>
-          <a:lstStyle/>
-          <a:p>
-            <a:pPr algn="ctr"/>
-            <a:endParaRPr/>
-          </a:p>
-        </p:txBody>
-      </p:sp>
-      <p:sp>
-        <p:nvSpPr>
-          <p:cNvPr id="28" name="Oval 27"/>
-          <p:cNvSpPr/>
-          <p:nvPr/>
-        </p:nvSpPr>
-        <p:spPr>
-          <a:xfrm>
-            <a:off x="6611112" y="2944368"/>
-            <a:ext cx="457200" cy="457200"/>
-          </a:xfrm>
-          <a:prstGeom prst="ellipse">
-            <a:avLst/>
-          </a:prstGeom>
-          <a:solidFill>
-            <a:srgbClr val="065A82"/>
-          </a:solidFill>
-          <a:ln>
-            <a:noFill/>
-          </a:ln>
-          <a:effectLst/>
-        </p:spPr>
-        <p:style>
-          <a:lnRef idx="1">
-            <a:schemeClr val="accent1"/>
-          </a:lnRef>
-          <a:fillRef idx="3">
-            <a:schemeClr val="accent1"/>
-          </a:fillRef>
-          <a:effectRef idx="2">
-            <a:schemeClr val="accent1"/>
-          </a:effectRef>
-          <a:fontRef idx="minor">
-            <a:schemeClr val="lt1"/>
-          </a:fontRef>
-        </p:style>
-        <p:txBody>
-          <a:bodyPr rtlCol="0" anchor="ctr"/>
-          <a:lstStyle/>
-          <a:p>
-            <a:pPr algn="ctr"/>
-            <a:endParaRPr/>
-          </a:p>
-        </p:txBody>
-      </p:sp>
-      <p:sp>
-        <p:nvSpPr>
-          <p:cNvPr id="29" name="TextBox 28"/>
-          <p:cNvSpPr txBox="1"/>
-          <p:nvPr/>
-        </p:nvSpPr>
-        <p:spPr>
-          <a:xfrm>
-            <a:off x="6611112" y="2990088"/>
-            <a:ext cx="457200" cy="365760"/>
-          </a:xfrm>
-          <a:prstGeom prst="rect">
-            <a:avLst/>
-          </a:prstGeom>
-          <a:noFill/>
-        </p:spPr>
-        <p:txBody>
-          <a:bodyPr wrap="square" lIns="0" tIns="0" rIns="0" bIns="0" anchor="ctr">
-            <a:spAutoFit/>
-          </a:bodyPr>
-          <a:lstStyle/>
-          <a:p>
-            <a:pPr algn="ctr"/>
-            <a:r>
-              <a:rPr sz="1500" b="1" i="0">
-                <a:solidFill>
-                  <a:srgbClr val="FFFFFF"/>
-                </a:solidFill>
-                <a:latin typeface="Calibri"/>
-              </a:rPr>
-              <a:t>4</a:t>
-            </a:r>
-          </a:p>
-        </p:txBody>
-      </p:sp>
-      <p:sp>
-        <p:nvSpPr>
-          <p:cNvPr id="30" name="TextBox 29"/>
-          <p:cNvSpPr txBox="1"/>
-          <p:nvPr/>
-        </p:nvSpPr>
-        <p:spPr>
-          <a:xfrm>
-            <a:off x="7251192" y="2779776"/>
-            <a:ext cx="4553712" cy="329184"/>
-          </a:xfrm>
-          <a:prstGeom prst="rect">
-            <a:avLst/>
-          </a:prstGeom>
-          <a:noFill/>
-        </p:spPr>
-        <p:txBody>
-          <a:bodyPr wrap="square" lIns="0" tIns="0" rIns="0" bIns="0" anchor="t">
-            <a:spAutoFit/>
-          </a:bodyPr>
-          <a:lstStyle/>
-          <a:p>
-            <a:pPr algn="l"/>
-            <a:r>
-              <a:rPr sz="1400" b="1" i="0">
-                <a:solidFill>
-                  <a:srgbClr val="21295C"/>
-                </a:solidFill>
-                <a:latin typeface="Calibri"/>
-              </a:rPr>
-              <a:t>Save / Load Project</a:t>
-            </a:r>
-          </a:p>
-        </p:txBody>
-      </p:sp>
-      <p:sp>
-        <p:nvSpPr>
-          <p:cNvPr id="31" name="TextBox 30"/>
-          <p:cNvSpPr txBox="1"/>
-          <p:nvPr/>
-        </p:nvSpPr>
-        <p:spPr>
-          <a:xfrm>
-            <a:off x="7251192" y="3108960"/>
-            <a:ext cx="4553712" cy="566928"/>
-          </a:xfrm>
-          <a:prstGeom prst="rect">
-            <a:avLst/>
-          </a:prstGeom>
-          <a:noFill/>
-        </p:spPr>
-        <p:txBody>
-          <a:bodyPr wrap="square" lIns="0" tIns="0" rIns="0" bIns="0">
-            <a:spAutoFit/>
-          </a:bodyPr>
-          <a:lstStyle/>
-          <a:p>
-            <a:pPr algn="l">
-              <a:lnSpc>
-                <a:spcPct val="125000"/>
-              </a:lnSpc>
-              <a:spcAft>
-                <a:spcPts val="400"/>
-              </a:spcAft>
-            </a:pPr>
-            <a:r>
-              <a:rPr sz="1100" b="0" i="0">
-                <a:solidFill>
-                  <a:srgbClr val="5C6B82"/>
-                </a:solidFill>
-                <a:latin typeface="Calibri"/>
-              </a:rPr>
-              <a:t>.spiceharvester.json snapshot: folders + model + prompt + režim. Cmd+Shift+S uloží, Cmd+O načte. Server registry zůstává globální (mezi projekty se nemíchá).</a:t>
-            </a:r>
-          </a:p>
-        </p:txBody>
-      </p:sp>
-      <p:sp>
-        <p:nvSpPr>
-          <p:cNvPr id="32" name="Rectangle 31"/>
-          <p:cNvSpPr/>
-          <p:nvPr/>
-        </p:nvSpPr>
-        <p:spPr>
-          <a:xfrm>
-            <a:off x="502920" y="3803904"/>
-            <a:ext cx="5650992" cy="1078992"/>
-          </a:xfrm>
-          <a:prstGeom prst="rect">
-            <a:avLst/>
-          </a:prstGeom>
-          <a:solidFill>
-            <a:srgbClr val="FFFFFF"/>
-          </a:solidFill>
-          <a:ln w="6350">
-            <a:solidFill>
-              <a:srgbClr val="D8E0EA"/>
-            </a:solidFill>
-          </a:ln>
-          <a:effectLst/>
-        </p:spPr>
-        <p:style>
-          <a:lnRef idx="1">
-            <a:schemeClr val="accent1"/>
-          </a:lnRef>
-          <a:fillRef idx="3">
-            <a:schemeClr val="accent1"/>
-          </a:fillRef>
-          <a:effectRef idx="2">
-            <a:schemeClr val="accent1"/>
-          </a:effectRef>
-          <a:fontRef idx="minor">
-            <a:schemeClr val="lt1"/>
-          </a:fontRef>
-        </p:style>
-        <p:txBody>
-          <a:bodyPr rtlCol="0" anchor="ctr"/>
-          <a:lstStyle/>
-          <a:p>
-            <a:pPr algn="ctr"/>
-            <a:endParaRPr/>
-          </a:p>
-        </p:txBody>
-      </p:sp>
-      <p:sp>
-        <p:nvSpPr>
-          <p:cNvPr id="33" name="Rectangle 32"/>
-          <p:cNvSpPr/>
-          <p:nvPr/>
-        </p:nvSpPr>
-        <p:spPr>
-          <a:xfrm>
-            <a:off x="502920" y="3803904"/>
-            <a:ext cx="73152" cy="1078992"/>
-          </a:xfrm>
-          <a:prstGeom prst="rect">
-            <a:avLst/>
-          </a:prstGeom>
-          <a:solidFill>
-            <a:srgbClr val="1C7293"/>
-          </a:solidFill>
-          <a:ln>
-            <a:noFill/>
-          </a:ln>
-          <a:effectLst/>
-        </p:spPr>
-        <p:style>
-          <a:lnRef idx="1">
-            <a:schemeClr val="accent1"/>
-          </a:lnRef>
-          <a:fillRef idx="3">
-            <a:schemeClr val="accent1"/>
-          </a:fillRef>
-          <a:effectRef idx="2">
-            <a:schemeClr val="accent1"/>
-          </a:effectRef>
-          <a:fontRef idx="minor">
-            <a:schemeClr val="lt1"/>
-          </a:fontRef>
-        </p:style>
-        <p:txBody>
-          <a:bodyPr rtlCol="0" anchor="ctr"/>
-          <a:lstStyle/>
-          <a:p>
-            <a:pPr algn="ctr"/>
-            <a:endParaRPr/>
-          </a:p>
-        </p:txBody>
-      </p:sp>
-      <p:sp>
-        <p:nvSpPr>
-          <p:cNvPr id="34" name="Oval 33"/>
-          <p:cNvSpPr/>
-          <p:nvPr/>
-        </p:nvSpPr>
-        <p:spPr>
-          <a:xfrm>
-            <a:off x="822960" y="4114800"/>
-            <a:ext cx="457200" cy="457200"/>
-          </a:xfrm>
-          <a:prstGeom prst="ellipse">
-            <a:avLst/>
-          </a:prstGeom>
-          <a:solidFill>
-            <a:srgbClr val="065A82"/>
-          </a:solidFill>
-          <a:ln>
-            <a:noFill/>
-          </a:ln>
-          <a:effectLst/>
-        </p:spPr>
-        <p:style>
-          <a:lnRef idx="1">
-            <a:schemeClr val="accent1"/>
-          </a:lnRef>
-          <a:fillRef idx="3">
-            <a:schemeClr val="accent1"/>
-          </a:fillRef>
-          <a:effectRef idx="2">
-            <a:schemeClr val="accent1"/>
-          </a:effectRef>
-          <a:fontRef idx="minor">
-            <a:schemeClr val="lt1"/>
-          </a:fontRef>
-        </p:style>
-        <p:txBody>
-          <a:bodyPr rtlCol="0" anchor="ctr"/>
-          <a:lstStyle/>
-          <a:p>
-            <a:pPr algn="ctr"/>
-            <a:endParaRPr/>
-          </a:p>
-        </p:txBody>
-      </p:sp>
-      <p:sp>
-        <p:nvSpPr>
-          <p:cNvPr id="35" name="TextBox 34"/>
-          <p:cNvSpPr txBox="1"/>
-          <p:nvPr/>
-        </p:nvSpPr>
-        <p:spPr>
-          <a:xfrm>
-            <a:off x="822960" y="4160520"/>
-            <a:ext cx="457200" cy="365760"/>
-          </a:xfrm>
-          <a:prstGeom prst="rect">
-            <a:avLst/>
-          </a:prstGeom>
-          <a:noFill/>
-        </p:spPr>
-        <p:txBody>
-          <a:bodyPr wrap="square" lIns="0" tIns="0" rIns="0" bIns="0" anchor="ctr">
-            <a:spAutoFit/>
-          </a:bodyPr>
-          <a:lstStyle/>
-          <a:p>
-            <a:pPr algn="ctr"/>
-            <a:r>
-              <a:rPr sz="1500" b="1" i="0">
-                <a:solidFill>
-                  <a:srgbClr val="FFFFFF"/>
-                </a:solidFill>
-                <a:latin typeface="Calibri"/>
-              </a:rPr>
-              <a:t>5</a:t>
-            </a:r>
-          </a:p>
-        </p:txBody>
-      </p:sp>
-      <p:sp>
-        <p:nvSpPr>
-          <p:cNvPr id="36" name="TextBox 35"/>
-          <p:cNvSpPr txBox="1"/>
-          <p:nvPr/>
-        </p:nvSpPr>
-        <p:spPr>
-          <a:xfrm>
-            <a:off x="1463040" y="3950208"/>
-            <a:ext cx="4553712" cy="329184"/>
-          </a:xfrm>
-          <a:prstGeom prst="rect">
-            <a:avLst/>
-          </a:prstGeom>
-          <a:noFill/>
-        </p:spPr>
-        <p:txBody>
-          <a:bodyPr wrap="square" lIns="0" tIns="0" rIns="0" bIns="0" anchor="t">
-            <a:spAutoFit/>
-          </a:bodyPr>
-          <a:lstStyle/>
-          <a:p>
-            <a:pPr algn="l"/>
-            <a:r>
-              <a:rPr sz="1400" b="1" i="0">
-                <a:solidFill>
-                  <a:srgbClr val="21295C"/>
-                </a:solidFill>
-                <a:latin typeface="Calibri"/>
-              </a:rPr>
-              <a:t>Otevřít nedávné · sandbox-aware</a:t>
-            </a:r>
-          </a:p>
-        </p:txBody>
-      </p:sp>
-      <p:sp>
-        <p:nvSpPr>
-          <p:cNvPr id="37" name="TextBox 36"/>
-          <p:cNvSpPr txBox="1"/>
-          <p:nvPr/>
-        </p:nvSpPr>
-        <p:spPr>
-          <a:xfrm>
-            <a:off x="1463040" y="4279392"/>
-            <a:ext cx="4553712" cy="566928"/>
-          </a:xfrm>
-          <a:prstGeom prst="rect">
-            <a:avLst/>
-          </a:prstGeom>
-          <a:noFill/>
-        </p:spPr>
-        <p:txBody>
-          <a:bodyPr wrap="square" lIns="0" tIns="0" rIns="0" bIns="0">
-            <a:spAutoFit/>
-          </a:bodyPr>
-          <a:lstStyle/>
-          <a:p>
-            <a:pPr algn="l">
-              <a:lnSpc>
-                <a:spcPct val="125000"/>
-              </a:lnSpc>
-              <a:spcAft>
-                <a:spcPts val="400"/>
-              </a:spcAft>
-            </a:pPr>
-            <a:r>
-              <a:rPr sz="1100" b="0" i="0">
-                <a:solidFill>
-                  <a:srgbClr val="5C6B82"/>
-                </a:solidFill>
-                <a:latin typeface="Calibri"/>
-              </a:rPr>
-              <a:t>Posledních 8 projektů s persistentními security-scoped bookmarky — přežijí restart aplikace. Cross-window sync přes NotificationCenter.</a:t>
-            </a:r>
-          </a:p>
-        </p:txBody>
-      </p:sp>
-      <p:sp>
-        <p:nvSpPr>
-          <p:cNvPr id="38" name="Rectangle 37"/>
-          <p:cNvSpPr/>
-          <p:nvPr/>
-        </p:nvSpPr>
-        <p:spPr>
-          <a:xfrm>
-            <a:off x="6291072" y="3803904"/>
-            <a:ext cx="5650992" cy="1078992"/>
-          </a:xfrm>
-          <a:prstGeom prst="rect">
-            <a:avLst/>
-          </a:prstGeom>
-          <a:solidFill>
-            <a:srgbClr val="FFFFFF"/>
-          </a:solidFill>
-          <a:ln w="6350">
-            <a:solidFill>
-              <a:srgbClr val="D8E0EA"/>
-            </a:solidFill>
-          </a:ln>
-          <a:effectLst/>
-        </p:spPr>
-        <p:style>
-          <a:lnRef idx="1">
-            <a:schemeClr val="accent1"/>
-          </a:lnRef>
-          <a:fillRef idx="3">
-            <a:schemeClr val="accent1"/>
-          </a:fillRef>
-          <a:effectRef idx="2">
-            <a:schemeClr val="accent1"/>
-          </a:effectRef>
-          <a:fontRef idx="minor">
-            <a:schemeClr val="lt1"/>
-          </a:fontRef>
-        </p:style>
-        <p:txBody>
-          <a:bodyPr rtlCol="0" anchor="ctr"/>
-          <a:lstStyle/>
-          <a:p>
-            <a:pPr algn="ctr"/>
-            <a:endParaRPr/>
-          </a:p>
-        </p:txBody>
-      </p:sp>
-      <p:sp>
-        <p:nvSpPr>
-          <p:cNvPr id="39" name="Rectangle 38"/>
-          <p:cNvSpPr/>
-          <p:nvPr/>
-        </p:nvSpPr>
-        <p:spPr>
-          <a:xfrm>
-            <a:off x="6291072" y="3803904"/>
-            <a:ext cx="73152" cy="1078992"/>
-          </a:xfrm>
-          <a:prstGeom prst="rect">
-            <a:avLst/>
-          </a:prstGeom>
-          <a:solidFill>
-            <a:srgbClr val="1C7293"/>
-          </a:solidFill>
-          <a:ln>
-            <a:noFill/>
-          </a:ln>
-          <a:effectLst/>
-        </p:spPr>
-        <p:style>
-          <a:lnRef idx="1">
-            <a:schemeClr val="accent1"/>
-          </a:lnRef>
-          <a:fillRef idx="3">
-            <a:schemeClr val="accent1"/>
-          </a:fillRef>
-          <a:effectRef idx="2">
-            <a:schemeClr val="accent1"/>
-          </a:effectRef>
-          <a:fontRef idx="minor">
-            <a:schemeClr val="lt1"/>
-          </a:fontRef>
-        </p:style>
-        <p:txBody>
-          <a:bodyPr rtlCol="0" anchor="ctr"/>
-          <a:lstStyle/>
-          <a:p>
-            <a:pPr algn="ctr"/>
-            <a:endParaRPr/>
-          </a:p>
-        </p:txBody>
-      </p:sp>
-      <p:sp>
-        <p:nvSpPr>
-          <p:cNvPr id="40" name="Oval 39"/>
-          <p:cNvSpPr/>
-          <p:nvPr/>
-        </p:nvSpPr>
-        <p:spPr>
-          <a:xfrm>
-            <a:off x="6611112" y="4114800"/>
-            <a:ext cx="457200" cy="457200"/>
-          </a:xfrm>
-          <a:prstGeom prst="ellipse">
-            <a:avLst/>
-          </a:prstGeom>
-          <a:solidFill>
-            <a:srgbClr val="065A82"/>
-          </a:solidFill>
-          <a:ln>
-            <a:noFill/>
-          </a:ln>
-          <a:effectLst/>
-        </p:spPr>
-        <p:style>
-          <a:lnRef idx="1">
-            <a:schemeClr val="accent1"/>
-          </a:lnRef>
-          <a:fillRef idx="3">
-            <a:schemeClr val="accent1"/>
-          </a:fillRef>
-          <a:effectRef idx="2">
-            <a:schemeClr val="accent1"/>
-          </a:effectRef>
-          <a:fontRef idx="minor">
-            <a:schemeClr val="lt1"/>
-          </a:fontRef>
-        </p:style>
-        <p:txBody>
-          <a:bodyPr rtlCol="0" anchor="ctr"/>
-          <a:lstStyle/>
-          <a:p>
-            <a:pPr algn="ctr"/>
-            <a:endParaRPr/>
-          </a:p>
-        </p:txBody>
-      </p:sp>
-      <p:sp>
-        <p:nvSpPr>
-          <p:cNvPr id="41" name="TextBox 40"/>
-          <p:cNvSpPr txBox="1"/>
-          <p:nvPr/>
-        </p:nvSpPr>
-        <p:spPr>
-          <a:xfrm>
-            <a:off x="6611112" y="4160520"/>
-            <a:ext cx="457200" cy="365760"/>
-          </a:xfrm>
-          <a:prstGeom prst="rect">
-            <a:avLst/>
-          </a:prstGeom>
-          <a:noFill/>
-        </p:spPr>
-        <p:txBody>
-          <a:bodyPr wrap="square" lIns="0" tIns="0" rIns="0" bIns="0" anchor="ctr">
-            <a:spAutoFit/>
-          </a:bodyPr>
-          <a:lstStyle/>
-          <a:p>
-            <a:pPr algn="ctr"/>
-            <a:r>
-              <a:rPr sz="1500" b="1" i="0">
-                <a:solidFill>
-                  <a:srgbClr val="FFFFFF"/>
-                </a:solidFill>
-                <a:latin typeface="Calibri"/>
-              </a:rPr>
-              <a:t>6</a:t>
-            </a:r>
-          </a:p>
-        </p:txBody>
-      </p:sp>
-      <p:sp>
-        <p:nvSpPr>
-          <p:cNvPr id="42" name="TextBox 41"/>
-          <p:cNvSpPr txBox="1"/>
-          <p:nvPr/>
-        </p:nvSpPr>
-        <p:spPr>
-          <a:xfrm>
-            <a:off x="7251192" y="3950208"/>
-            <a:ext cx="4553712" cy="329184"/>
-          </a:xfrm>
-          <a:prstGeom prst="rect">
-            <a:avLst/>
-          </a:prstGeom>
-          <a:noFill/>
-        </p:spPr>
-        <p:txBody>
-          <a:bodyPr wrap="square" lIns="0" tIns="0" rIns="0" bIns="0" anchor="t">
-            <a:spAutoFit/>
-          </a:bodyPr>
-          <a:lstStyle/>
-          <a:p>
-            <a:pPr algn="l"/>
-            <a:r>
-              <a:rPr sz="1400" b="1" i="0">
-                <a:solidFill>
-                  <a:srgbClr val="21295C"/>
-                </a:solidFill>
-                <a:latin typeface="Calibri"/>
-              </a:rPr>
-              <a:t>AppIntents · Siri · Spotlight</a:t>
-            </a:r>
-          </a:p>
-        </p:txBody>
-      </p:sp>
-      <p:sp>
-        <p:nvSpPr>
-          <p:cNvPr id="43" name="TextBox 42"/>
-          <p:cNvSpPr txBox="1"/>
-          <p:nvPr/>
-        </p:nvSpPr>
-        <p:spPr>
-          <a:xfrm>
-            <a:off x="7251192" y="4279392"/>
-            <a:ext cx="4553712" cy="566928"/>
-          </a:xfrm>
-          <a:prstGeom prst="rect">
-            <a:avLst/>
-          </a:prstGeom>
-          <a:noFill/>
-        </p:spPr>
-        <p:txBody>
-          <a:bodyPr wrap="square" lIns="0" tIns="0" rIns="0" bIns="0">
-            <a:spAutoFit/>
-          </a:bodyPr>
-          <a:lstStyle/>
-          <a:p>
-            <a:pPr algn="l">
-              <a:lnSpc>
-                <a:spcPct val="125000"/>
-              </a:lnSpc>
-              <a:spcAft>
-                <a:spcPts val="400"/>
-              </a:spcAft>
-            </a:pPr>
-            <a:r>
-              <a:rPr sz="1100" b="0" i="0">
-                <a:solidFill>
-                  <a:srgbClr val="5C6B82"/>
-                </a:solidFill>
-                <a:latin typeface="Calibri"/>
-              </a:rPr>
-              <a:t>Frází Spusť Spice Harvester / Run Spice Harvester. macOS 14+ vystavuje akce v gallery i Spotlight nabídkách. Strukturovaný ReturnsValue + ProvidesDialog.</a:t>
-            </a:r>
-          </a:p>
-        </p:txBody>
-      </p:sp>
-      <p:sp>
-        <p:nvSpPr>
-          <p:cNvPr id="44" name="Rectangle 43"/>
-          <p:cNvSpPr/>
-          <p:nvPr/>
-        </p:nvSpPr>
-        <p:spPr>
-          <a:xfrm>
-            <a:off x="502920" y="4974336"/>
-            <a:ext cx="5650992" cy="1078992"/>
-          </a:xfrm>
-          <a:prstGeom prst="rect">
-            <a:avLst/>
-          </a:prstGeom>
-          <a:solidFill>
-            <a:srgbClr val="FFFFFF"/>
-          </a:solidFill>
-          <a:ln w="6350">
-            <a:solidFill>
-              <a:srgbClr val="D8E0EA"/>
-            </a:solidFill>
-          </a:ln>
-          <a:effectLst/>
-        </p:spPr>
-        <p:style>
-          <a:lnRef idx="1">
-            <a:schemeClr val="accent1"/>
-          </a:lnRef>
-          <a:fillRef idx="3">
-            <a:schemeClr val="accent1"/>
-          </a:fillRef>
-          <a:effectRef idx="2">
-            <a:schemeClr val="accent1"/>
-          </a:effectRef>
-          <a:fontRef idx="minor">
-            <a:schemeClr val="lt1"/>
-          </a:fontRef>
-        </p:style>
-        <p:txBody>
-          <a:bodyPr rtlCol="0" anchor="ctr"/>
-          <a:lstStyle/>
-          <a:p>
-            <a:pPr algn="ctr"/>
-            <a:endParaRPr/>
-          </a:p>
-        </p:txBody>
-      </p:sp>
-      <p:sp>
-        <p:nvSpPr>
-          <p:cNvPr id="45" name="Rectangle 44"/>
-          <p:cNvSpPr/>
-          <p:nvPr/>
-        </p:nvSpPr>
-        <p:spPr>
-          <a:xfrm>
-            <a:off x="502920" y="4974336"/>
-            <a:ext cx="73152" cy="1078992"/>
-          </a:xfrm>
-          <a:prstGeom prst="rect">
-            <a:avLst/>
-          </a:prstGeom>
-          <a:solidFill>
-            <a:srgbClr val="1C7293"/>
-          </a:solidFill>
-          <a:ln>
-            <a:noFill/>
-          </a:ln>
-          <a:effectLst/>
-        </p:spPr>
-        <p:style>
-          <a:lnRef idx="1">
-            <a:schemeClr val="accent1"/>
-          </a:lnRef>
-          <a:fillRef idx="3">
-            <a:schemeClr val="accent1"/>
-          </a:fillRef>
-          <a:effectRef idx="2">
-            <a:schemeClr val="accent1"/>
-          </a:effectRef>
-          <a:fontRef idx="minor">
-            <a:schemeClr val="lt1"/>
-          </a:fontRef>
-        </p:style>
-        <p:txBody>
-          <a:bodyPr rtlCol="0" anchor="ctr"/>
-          <a:lstStyle/>
-          <a:p>
-            <a:pPr algn="ctr"/>
-            <a:endParaRPr/>
-          </a:p>
-        </p:txBody>
-      </p:sp>
-      <p:sp>
-        <p:nvSpPr>
-          <p:cNvPr id="46" name="Oval 45"/>
-          <p:cNvSpPr/>
-          <p:nvPr/>
-        </p:nvSpPr>
-        <p:spPr>
-          <a:xfrm>
-            <a:off x="822960" y="5285232"/>
-            <a:ext cx="457200" cy="457200"/>
-          </a:xfrm>
-          <a:prstGeom prst="ellipse">
-            <a:avLst/>
-          </a:prstGeom>
-          <a:solidFill>
-            <a:srgbClr val="065A82"/>
-          </a:solidFill>
-          <a:ln>
-            <a:noFill/>
-          </a:ln>
-          <a:effectLst/>
-        </p:spPr>
-        <p:style>
-          <a:lnRef idx="1">
-            <a:schemeClr val="accent1"/>
-          </a:lnRef>
-          <a:fillRef idx="3">
-            <a:schemeClr val="accent1"/>
-          </a:fillRef>
-          <a:effectRef idx="2">
-            <a:schemeClr val="accent1"/>
-          </a:effectRef>
-          <a:fontRef idx="minor">
-            <a:schemeClr val="lt1"/>
-          </a:fontRef>
-        </p:style>
-        <p:txBody>
-          <a:bodyPr rtlCol="0" anchor="ctr"/>
-          <a:lstStyle/>
-          <a:p>
-            <a:pPr algn="ctr"/>
-            <a:endParaRPr/>
-          </a:p>
-        </p:txBody>
-      </p:sp>
-      <p:sp>
-        <p:nvSpPr>
-          <p:cNvPr id="47" name="TextBox 46"/>
-          <p:cNvSpPr txBox="1"/>
-          <p:nvPr/>
-        </p:nvSpPr>
-        <p:spPr>
-          <a:xfrm>
-            <a:off x="822960" y="5330952"/>
-            <a:ext cx="457200" cy="365760"/>
-          </a:xfrm>
-          <a:prstGeom prst="rect">
-            <a:avLst/>
-          </a:prstGeom>
-          <a:noFill/>
-        </p:spPr>
-        <p:txBody>
-          <a:bodyPr wrap="square" lIns="0" tIns="0" rIns="0" bIns="0" anchor="ctr">
-            <a:spAutoFit/>
-          </a:bodyPr>
-          <a:lstStyle/>
-          <a:p>
-            <a:pPr algn="ctr"/>
-            <a:r>
-              <a:rPr sz="1500" b="1" i="0">
-                <a:solidFill>
-                  <a:srgbClr val="FFFFFF"/>
-                </a:solidFill>
-                <a:latin typeface="Calibri"/>
-              </a:rPr>
-              <a:t>7</a:t>
-            </a:r>
-          </a:p>
-        </p:txBody>
-      </p:sp>
-      <p:sp>
-        <p:nvSpPr>
-          <p:cNvPr id="48" name="TextBox 47"/>
-          <p:cNvSpPr txBox="1"/>
-          <p:nvPr/>
-        </p:nvSpPr>
-        <p:spPr>
-          <a:xfrm>
-            <a:off x="1463040" y="5120640"/>
-            <a:ext cx="4553712" cy="329184"/>
-          </a:xfrm>
-          <a:prstGeom prst="rect">
-            <a:avLst/>
-          </a:prstGeom>
-          <a:noFill/>
-        </p:spPr>
-        <p:txBody>
-          <a:bodyPr wrap="square" lIns="0" tIns="0" rIns="0" bIns="0" anchor="t">
-            <a:spAutoFit/>
-          </a:bodyPr>
-          <a:lstStyle/>
-          <a:p>
-            <a:pPr algn="l"/>
-            <a:r>
-              <a:rPr sz="1400" b="1" i="0">
-                <a:solidFill>
-                  <a:srgbClr val="21295C"/>
-                </a:solidFill>
-                <a:latin typeface="Calibri"/>
-              </a:rPr>
-              <a:t>Pipeline menu bar</a:t>
-            </a:r>
-          </a:p>
-        </p:txBody>
-      </p:sp>
-      <p:sp>
-        <p:nvSpPr>
-          <p:cNvPr id="49" name="TextBox 48"/>
-          <p:cNvSpPr txBox="1"/>
-          <p:nvPr/>
-        </p:nvSpPr>
-        <p:spPr>
-          <a:xfrm>
-            <a:off x="1463040" y="5449824"/>
-            <a:ext cx="4553712" cy="566928"/>
-          </a:xfrm>
-          <a:prstGeom prst="rect">
-            <a:avLst/>
-          </a:prstGeom>
-          <a:noFill/>
-        </p:spPr>
-        <p:txBody>
-          <a:bodyPr wrap="square" lIns="0" tIns="0" rIns="0" bIns="0">
-            <a:spAutoFit/>
-          </a:bodyPr>
-          <a:lstStyle/>
-          <a:p>
-            <a:pPr algn="l">
-              <a:lnSpc>
-                <a:spcPct val="125000"/>
-              </a:lnSpc>
-              <a:spcAft>
-                <a:spcPts val="400"/>
-              </a:spcAft>
-            </a:pPr>
-            <a:r>
-              <a:rPr sz="1100" b="0" i="0">
-                <a:solidFill>
-                  <a:srgbClr val="5C6B82"/>
-                </a:solidFill>
-                <a:latin typeface="Calibri"/>
-              </a:rPr>
-              <a:t>Top-level CommandMenu Pipeline: Spustit (Cmd+R), Přerušit (Cmd+.), režim FAST/SEARCH/CONSOLIDATE (Cmd+1/2/3). Konvence Xcode/Logic/Final Cut.</a:t>
-            </a:r>
-          </a:p>
-        </p:txBody>
-      </p:sp>
-      <p:sp>
-        <p:nvSpPr>
-          <p:cNvPr id="50" name="Rectangle 49"/>
-          <p:cNvSpPr/>
-          <p:nvPr/>
-        </p:nvSpPr>
-        <p:spPr>
-          <a:xfrm>
-            <a:off x="6291072" y="4974336"/>
-            <a:ext cx="5650992" cy="1078992"/>
-          </a:xfrm>
-          <a:prstGeom prst="rect">
-            <a:avLst/>
-          </a:prstGeom>
-          <a:solidFill>
-            <a:srgbClr val="FFFFFF"/>
-          </a:solidFill>
-          <a:ln w="6350">
-            <a:solidFill>
-              <a:srgbClr val="D8E0EA"/>
-            </a:solidFill>
-          </a:ln>
-          <a:effectLst/>
-        </p:spPr>
-        <p:style>
-          <a:lnRef idx="1">
-            <a:schemeClr val="accent1"/>
-          </a:lnRef>
-          <a:fillRef idx="3">
-            <a:schemeClr val="accent1"/>
-          </a:fillRef>
-          <a:effectRef idx="2">
-            <a:schemeClr val="accent1"/>
-          </a:effectRef>
-          <a:fontRef idx="minor">
-            <a:schemeClr val="lt1"/>
-          </a:fontRef>
-        </p:style>
-        <p:txBody>
-          <a:bodyPr rtlCol="0" anchor="ctr"/>
-          <a:lstStyle/>
-          <a:p>
-            <a:pPr algn="ctr"/>
-            <a:endParaRPr/>
-          </a:p>
-        </p:txBody>
-      </p:sp>
-      <p:sp>
-        <p:nvSpPr>
-          <p:cNvPr id="51" name="Rectangle 50"/>
-          <p:cNvSpPr/>
-          <p:nvPr/>
-        </p:nvSpPr>
-        <p:spPr>
-          <a:xfrm>
-            <a:off x="6291072" y="4974336"/>
-            <a:ext cx="73152" cy="1078992"/>
-          </a:xfrm>
-          <a:prstGeom prst="rect">
-            <a:avLst/>
-          </a:prstGeom>
-          <a:solidFill>
-            <a:srgbClr val="1C7293"/>
-          </a:solidFill>
-          <a:ln>
-            <a:noFill/>
-          </a:ln>
-          <a:effectLst/>
-        </p:spPr>
-        <p:style>
-          <a:lnRef idx="1">
-            <a:schemeClr val="accent1"/>
-          </a:lnRef>
-          <a:fillRef idx="3">
-            <a:schemeClr val="accent1"/>
-          </a:fillRef>
-          <a:effectRef idx="2">
-            <a:schemeClr val="accent1"/>
-          </a:effectRef>
-          <a:fontRef idx="minor">
-            <a:schemeClr val="lt1"/>
-          </a:fontRef>
-        </p:style>
-        <p:txBody>
-          <a:bodyPr rtlCol="0" anchor="ctr"/>
-          <a:lstStyle/>
-          <a:p>
-            <a:pPr algn="ctr"/>
-            <a:endParaRPr/>
-          </a:p>
-        </p:txBody>
-      </p:sp>
-      <p:sp>
-        <p:nvSpPr>
-          <p:cNvPr id="52" name="Oval 51"/>
-          <p:cNvSpPr/>
-          <p:nvPr/>
-        </p:nvSpPr>
-        <p:spPr>
-          <a:xfrm>
-            <a:off x="6611112" y="5285232"/>
-            <a:ext cx="457200" cy="457200"/>
-          </a:xfrm>
-          <a:prstGeom prst="ellipse">
-            <a:avLst/>
-          </a:prstGeom>
-          <a:solidFill>
-            <a:srgbClr val="065A82"/>
-          </a:solidFill>
-          <a:ln>
-            <a:noFill/>
-          </a:ln>
-          <a:effectLst/>
-        </p:spPr>
-        <p:style>
-          <a:lnRef idx="1">
-            <a:schemeClr val="accent1"/>
-          </a:lnRef>
-          <a:fillRef idx="3">
-            <a:schemeClr val="accent1"/>
-          </a:fillRef>
-          <a:effectRef idx="2">
-            <a:schemeClr val="accent1"/>
-          </a:effectRef>
-          <a:fontRef idx="minor">
-            <a:schemeClr val="lt1"/>
-          </a:fontRef>
-        </p:style>
-        <p:txBody>
-          <a:bodyPr rtlCol="0" anchor="ctr"/>
-          <a:lstStyle/>
-          <a:p>
-            <a:pPr algn="ctr"/>
-            <a:endParaRPr/>
-          </a:p>
-        </p:txBody>
-      </p:sp>
-      <p:sp>
-        <p:nvSpPr>
-          <p:cNvPr id="53" name="TextBox 52"/>
-          <p:cNvSpPr txBox="1"/>
-          <p:nvPr/>
-        </p:nvSpPr>
-        <p:spPr>
-          <a:xfrm>
-            <a:off x="6611112" y="5330952"/>
-            <a:ext cx="457200" cy="365760"/>
-          </a:xfrm>
-          <a:prstGeom prst="rect">
-            <a:avLst/>
-          </a:prstGeom>
-          <a:noFill/>
-        </p:spPr>
-        <p:txBody>
-          <a:bodyPr wrap="square" lIns="0" tIns="0" rIns="0" bIns="0" anchor="ctr">
-            <a:spAutoFit/>
-          </a:bodyPr>
-          <a:lstStyle/>
-          <a:p>
-            <a:pPr algn="ctr"/>
-            <a:r>
-              <a:rPr sz="1500" b="1" i="0">
-                <a:solidFill>
-                  <a:srgbClr val="FFFFFF"/>
-                </a:solidFill>
-                <a:latin typeface="Calibri"/>
-              </a:rPr>
-              <a:t>8</a:t>
-            </a:r>
-          </a:p>
-        </p:txBody>
-      </p:sp>
-      <p:sp>
-        <p:nvSpPr>
-          <p:cNvPr id="54" name="TextBox 53"/>
-          <p:cNvSpPr txBox="1"/>
-          <p:nvPr/>
-        </p:nvSpPr>
-        <p:spPr>
-          <a:xfrm>
-            <a:off x="7251192" y="5120640"/>
-            <a:ext cx="4553712" cy="329184"/>
-          </a:xfrm>
-          <a:prstGeom prst="rect">
-            <a:avLst/>
-          </a:prstGeom>
-          <a:noFill/>
-        </p:spPr>
-        <p:txBody>
-          <a:bodyPr wrap="square" lIns="0" tIns="0" rIns="0" bIns="0" anchor="t">
-            <a:spAutoFit/>
-          </a:bodyPr>
-          <a:lstStyle/>
-          <a:p>
-            <a:pPr algn="l"/>
-            <a:r>
-              <a:rPr sz="1400" b="1" i="0">
-                <a:solidFill>
-                  <a:srgbClr val="21295C"/>
-                </a:solidFill>
-                <a:latin typeface="Calibri"/>
-              </a:rPr>
-              <a:t>Health watcher + manuální recheck</a:t>
-            </a:r>
-          </a:p>
-        </p:txBody>
-      </p:sp>
-      <p:sp>
-        <p:nvSpPr>
-          <p:cNvPr id="55" name="TextBox 54"/>
-          <p:cNvSpPr txBox="1"/>
-          <p:nvPr/>
-        </p:nvSpPr>
-        <p:spPr>
-          <a:xfrm>
-            <a:off x="7251192" y="5449824"/>
-            <a:ext cx="4553712" cy="566928"/>
-          </a:xfrm>
-          <a:prstGeom prst="rect">
-            <a:avLst/>
-          </a:prstGeom>
-          <a:noFill/>
-        </p:spPr>
-        <p:txBody>
-          <a:bodyPr wrap="square" lIns="0" tIns="0" rIns="0" bIns="0">
-            <a:spAutoFit/>
-          </a:bodyPr>
-          <a:lstStyle/>
-          <a:p>
-            <a:pPr algn="l">
-              <a:lnSpc>
-                <a:spcPct val="125000"/>
-              </a:lnSpc>
-              <a:spcAft>
-                <a:spcPts val="400"/>
-              </a:spcAft>
-            </a:pPr>
-            <a:r>
-              <a:rPr sz="1100" b="0" i="0">
-                <a:solidFill>
-                  <a:srgbClr val="5C6B82"/>
-                </a:solidFill>
-                <a:latin typeface="Calibri"/>
-              </a:rPr>
-              <a:t>30 s ambient ping na /v1/models; status pill zčervená při disconnectu. Pipeline → Znovu ověřit zdraví serveru pro okamžitou kontrolu po restartu LM Studia.</a:t>
-            </a:r>
-          </a:p>
-        </p:txBody>
-      </p:sp>
-    </p:spTree>
   </p:cSld>
   <p:clrMapOvr>
     <a:masterClrMapping/>

</xml_diff>

<commit_message>
Prezentace: slide 5 wireframe podle současného UI
- Toolbar buttons: anglické Help/Output → české Nápověda/Výstup
- Status pill: generické Připraveno → konkrétní Server dostupný
  (reflektuje health watcher)
- Složky: 4. cesta Prompty doplněna
- Server a model: rozděleno na Server · Modely · Režim (zachycuje
  split na 2 karty v reálném UI), Base URL místo Server, Ověřit ✓
- Prompt: dopln Fullscreen ⛶ toggle
- Průběh: doplněno granulární Naposledy: <file> · ✓ Xms a live
  throughput X dok/min · ⌀ Y s/dok místo statického Avg / ETA
- Subtitle: VSplitView v pravém sloupci
- Footer: Pipeline menu bar (Cmd+R/.), VSplitView dělítka,
  multi-window (Cmd+Shift+N), Otevřít nedávné (Cmd+O)
</commit_message>
<xml_diff>
--- a/docs/SpiceHarvester_Prezentace.pptx
+++ b/docs/SpiceHarvester_Prezentace.pptx
@@ -5,7 +5,7 @@
     <p:sldMasterId id="2147483648" r:id="rId1"/>
   </p:sldMasterIdLst>
   <p:handoutMasterIdLst>
-    <p:handoutMasterId r:id="rId18"/>
+    <p:handoutMasterId r:id="rId19"/>
   </p:handoutMasterIdLst>
   <p:sldIdLst>
     <p:sldId id="256" r:id="rId2"/>
@@ -23,8 +23,8 @@
     <p:sldId id="268" r:id="rId14"/>
     <p:sldId id="269" r:id="rId15"/>
     <p:sldId id="270" r:id="rId16"/>
-    <p:sldId id="275" r:id="rId23"/>
-    <p:sldId id="274" r:id="rId17"/>
+    <p:sldId id="275" r:id="rId17"/>
+    <p:sldId id="274" r:id="rId18"/>
   </p:sldIdLst>
   <p:sldSz cx="12192000" cy="6858000"/>
   <p:notesSz cx="6858000" cy="9144000"/>
@@ -239,7 +239,7 @@
           <a:p>
             <a:fld id="{56CF4932-E4B7-F94D-8B24-1930869AC884}" type="datetimeFigureOut">
               <a:rPr lang="cs-CZ" smtClean="0"/>
-              <a:t>03.05.2026</a:t>
+              <a:t>11.05.2026</a:t>
             </a:fld>
             <a:endParaRPr lang="cs-CZ"/>
           </a:p>
@@ -513,7 +513,7 @@
           <a:p>
             <a:fld id="{5BCAD085-E8A6-8845-BD4E-CB4CCA059FC4}" type="datetimeFigureOut">
               <a:rPr lang="en-US" smtClean="0"/>
-              <a:t>5/1/26</a:t>
+              <a:t>5/11/26</a:t>
             </a:fld>
             <a:endParaRPr lang="en-US"/>
           </a:p>
@@ -681,7 +681,7 @@
           <a:p>
             <a:fld id="{5BCAD085-E8A6-8845-BD4E-CB4CCA059FC4}" type="datetimeFigureOut">
               <a:rPr lang="en-US" smtClean="0"/>
-              <a:t>5/1/26</a:t>
+              <a:t>5/11/26</a:t>
             </a:fld>
             <a:endParaRPr lang="en-US"/>
           </a:p>
@@ -859,7 +859,7 @@
           <a:p>
             <a:fld id="{5BCAD085-E8A6-8845-BD4E-CB4CCA059FC4}" type="datetimeFigureOut">
               <a:rPr lang="en-US" smtClean="0"/>
-              <a:t>5/1/26</a:t>
+              <a:t>5/11/26</a:t>
             </a:fld>
             <a:endParaRPr lang="en-US"/>
           </a:p>
@@ -1027,7 +1027,7 @@
           <a:p>
             <a:fld id="{5BCAD085-E8A6-8845-BD4E-CB4CCA059FC4}" type="datetimeFigureOut">
               <a:rPr lang="en-US" smtClean="0"/>
-              <a:t>5/1/26</a:t>
+              <a:t>5/11/26</a:t>
             </a:fld>
             <a:endParaRPr lang="en-US"/>
           </a:p>
@@ -1272,7 +1272,7 @@
           <a:p>
             <a:fld id="{5BCAD085-E8A6-8845-BD4E-CB4CCA059FC4}" type="datetimeFigureOut">
               <a:rPr lang="en-US" smtClean="0"/>
-              <a:t>5/1/26</a:t>
+              <a:t>5/11/26</a:t>
             </a:fld>
             <a:endParaRPr lang="en-US"/>
           </a:p>
@@ -1557,7 +1557,7 @@
           <a:p>
             <a:fld id="{5BCAD085-E8A6-8845-BD4E-CB4CCA059FC4}" type="datetimeFigureOut">
               <a:rPr lang="en-US" smtClean="0"/>
-              <a:t>5/1/26</a:t>
+              <a:t>5/11/26</a:t>
             </a:fld>
             <a:endParaRPr lang="en-US"/>
           </a:p>
@@ -1976,7 +1976,7 @@
           <a:p>
             <a:fld id="{5BCAD085-E8A6-8845-BD4E-CB4CCA059FC4}" type="datetimeFigureOut">
               <a:rPr lang="en-US" smtClean="0"/>
-              <a:t>5/1/26</a:t>
+              <a:t>5/11/26</a:t>
             </a:fld>
             <a:endParaRPr lang="en-US"/>
           </a:p>
@@ -2093,7 +2093,7 @@
           <a:p>
             <a:fld id="{5BCAD085-E8A6-8845-BD4E-CB4CCA059FC4}" type="datetimeFigureOut">
               <a:rPr lang="en-US" smtClean="0"/>
-              <a:t>5/1/26</a:t>
+              <a:t>5/11/26</a:t>
             </a:fld>
             <a:endParaRPr lang="en-US"/>
           </a:p>
@@ -2188,7 +2188,7 @@
           <a:p>
             <a:fld id="{5BCAD085-E8A6-8845-BD4E-CB4CCA059FC4}" type="datetimeFigureOut">
               <a:rPr lang="en-US" smtClean="0"/>
-              <a:t>5/1/26</a:t>
+              <a:t>5/11/26</a:t>
             </a:fld>
             <a:endParaRPr lang="en-US"/>
           </a:p>
@@ -2655,7 +2655,7 @@
           <a:p>
             <a:fld id="{5BCAD085-E8A6-8845-BD4E-CB4CCA059FC4}" type="datetimeFigureOut">
               <a:rPr lang="en-US" smtClean="0"/>
-              <a:t>5/1/26</a:t>
+              <a:t>5/11/26</a:t>
             </a:fld>
             <a:endParaRPr lang="en-US"/>
           </a:p>
@@ -2907,7 +2907,7 @@
           <a:p>
             <a:fld id="{5BCAD085-E8A6-8845-BD4E-CB4CCA059FC4}" type="datetimeFigureOut">
               <a:rPr lang="en-US" smtClean="0"/>
-              <a:t>5/1/26</a:t>
+              <a:t>5/11/26</a:t>
             </a:fld>
             <a:endParaRPr lang="en-US"/>
           </a:p>
@@ -3118,7 +3118,7 @@
           <a:p>
             <a:fld id="{5BCAD085-E8A6-8845-BD4E-CB4CCA059FC4}" type="datetimeFigureOut">
               <a:rPr lang="en-US" smtClean="0"/>
-              <a:t>5/1/26</a:t>
+              <a:t>5/11/26</a:t>
             </a:fld>
             <a:endParaRPr lang="en-US"/>
           </a:p>
@@ -3542,7 +3542,7 @@
           <a:lstStyle/>
           <a:p>
             <a:pPr algn="ctr"/>
-            <a:endParaRPr/>
+            <a:endParaRPr lang="cs-CZ" dirty="0"/>
           </a:p>
         </p:txBody>
       </p:sp>
@@ -3587,7 +3587,7 @@
           <a:lstStyle/>
           <a:p>
             <a:pPr algn="ctr"/>
-            <a:endParaRPr/>
+            <a:endParaRPr lang="cs-CZ" dirty="0"/>
           </a:p>
         </p:txBody>
       </p:sp>
@@ -3632,7 +3632,7 @@
           <a:lstStyle/>
           <a:p>
             <a:pPr algn="ctr"/>
-            <a:endParaRPr/>
+            <a:endParaRPr lang="cs-CZ" dirty="0"/>
           </a:p>
         </p:txBody>
       </p:sp>
@@ -3684,7 +3684,7 @@
           <a:p>
             <a:pPr algn="l"/>
             <a:r>
-              <a:rPr sz="1400" b="1" i="0" dirty="0">
+              <a:rPr lang="cs-CZ" sz="1400" b="1" i="0" dirty="0">
                 <a:solidFill>
                   <a:srgbClr val="F5B041"/>
                 </a:solidFill>
@@ -3719,7 +3719,7 @@
           <a:p>
             <a:pPr algn="l"/>
             <a:r>
-              <a:rPr sz="7200" b="1" i="0" dirty="0" err="1">
+              <a:rPr lang="cs-CZ" sz="7200" b="1" i="0" dirty="0" err="1">
                 <a:solidFill>
                   <a:srgbClr val="FFFFFF"/>
                 </a:solidFill>
@@ -3727,7 +3727,7 @@
               </a:rPr>
               <a:t>SpiceHarvester</a:t>
             </a:r>
-            <a:endParaRPr sz="7200" b="1" i="0" dirty="0">
+            <a:endParaRPr lang="cs-CZ" sz="7200" b="1" i="0">
               <a:solidFill>
                 <a:srgbClr val="FFFFFF"/>
               </a:solidFill>
@@ -3760,7 +3760,7 @@
           <a:p>
             <a:pPr algn="l"/>
             <a:r>
-              <a:rPr sz="2400" b="0" i="0">
+              <a:rPr lang="cs-CZ" sz="2400" b="0" i="0" dirty="0">
                 <a:solidFill>
                   <a:srgbClr val="FFFFFF"/>
                 </a:solidFill>
@@ -3813,7 +3813,7 @@
           <a:lstStyle/>
           <a:p>
             <a:pPr algn="ctr"/>
-            <a:endParaRPr/>
+            <a:endParaRPr lang="cs-CZ" dirty="0"/>
           </a:p>
         </p:txBody>
       </p:sp>
@@ -3826,7 +3826,7 @@
         <p:spPr>
           <a:xfrm>
             <a:off x="1097280" y="5349240"/>
-            <a:ext cx="6858000" cy="822960"/>
+            <a:ext cx="6858000" cy="547201"/>
           </a:xfrm>
           <a:prstGeom prst="rect">
             <a:avLst/>
@@ -3848,13 +3848,13 @@
               </a:spcAft>
             </a:pPr>
             <a:r>
-              <a:rPr sz="1600" b="1" i="0">
+              <a:rPr lang="cs-CZ" sz="1600" b="1" i="0" dirty="0">
                 <a:solidFill>
                   <a:srgbClr val="FFFFFF"/>
                 </a:solidFill>
                 <a:latin typeface="Calibri"/>
               </a:rPr>
-              <a:t>Analýza kódu a přehled funkcí</a:t>
+              <a:t>Přehled funkcí aplikace</a:t>
             </a:r>
           </a:p>
           <a:p>
@@ -3867,13 +3867,13 @@
               </a:spcAft>
             </a:pPr>
             <a:r>
-              <a:rPr sz="1200" b="0" i="0">
+              <a:rPr lang="cs-CZ" sz="1200" b="0" i="0" dirty="0">
                 <a:solidFill>
                   <a:srgbClr val="B8C8E0"/>
                 </a:solidFill>
                 <a:latin typeface="Calibri"/>
               </a:rPr>
-              <a:t>David Mašín · 2026</a:t>
+              <a:t>David Mašín · květen 2026</a:t>
             </a:r>
           </a:p>
         </p:txBody>
@@ -5939,8 +5939,8 @@
         </p:nvSpPr>
         <p:spPr>
           <a:xfrm>
-            <a:off x="685800" y="5897880"/>
-            <a:ext cx="10789920" cy="457200"/>
+            <a:off x="685800" y="6041841"/>
+            <a:ext cx="10789920" cy="169277"/>
           </a:xfrm>
           <a:prstGeom prst="rect">
             <a:avLst/>
@@ -5961,7 +5961,259 @@
                 </a:solidFill>
                 <a:latin typeface="Calibri"/>
               </a:rPr>
-              <a:t>Tip:  prompty se ukládají jako .md soubory — verzujete je v Gitu, sdílíte v týmu, a s novým modelem často stačí stejný prompt pro lepší výsledky.</a:t>
+              <a:t>Tip:  </a:t>
+            </a:r>
+            <a:r>
+              <a:rPr sz="1100" b="0" i="1" err="1">
+                <a:solidFill>
+                  <a:srgbClr val="21295C"/>
+                </a:solidFill>
+                <a:latin typeface="Calibri"/>
+              </a:rPr>
+              <a:t>prompty</a:t>
+            </a:r>
+            <a:r>
+              <a:rPr sz="1100" b="0" i="1">
+                <a:solidFill>
+                  <a:srgbClr val="21295C"/>
+                </a:solidFill>
+                <a:latin typeface="Calibri"/>
+              </a:rPr>
+              <a:t> se </a:t>
+            </a:r>
+            <a:r>
+              <a:rPr sz="1100" b="0" i="1" err="1">
+                <a:solidFill>
+                  <a:srgbClr val="21295C"/>
+                </a:solidFill>
+                <a:latin typeface="Calibri"/>
+              </a:rPr>
+              <a:t>ukládají</a:t>
+            </a:r>
+            <a:r>
+              <a:rPr sz="1100" b="0" i="1">
+                <a:solidFill>
+                  <a:srgbClr val="21295C"/>
+                </a:solidFill>
+                <a:latin typeface="Calibri"/>
+              </a:rPr>
+              <a:t> </a:t>
+            </a:r>
+            <a:r>
+              <a:rPr sz="1100" b="0" i="1" err="1">
+                <a:solidFill>
+                  <a:srgbClr val="21295C"/>
+                </a:solidFill>
+                <a:latin typeface="Calibri"/>
+              </a:rPr>
+              <a:t>jako</a:t>
+            </a:r>
+            <a:r>
+              <a:rPr sz="1100" b="0" i="1">
+                <a:solidFill>
+                  <a:srgbClr val="21295C"/>
+                </a:solidFill>
+                <a:latin typeface="Calibri"/>
+              </a:rPr>
+              <a:t> .md </a:t>
+            </a:r>
+            <a:r>
+              <a:rPr sz="1100" b="0" i="1" err="1">
+                <a:solidFill>
+                  <a:srgbClr val="21295C"/>
+                </a:solidFill>
+                <a:latin typeface="Calibri"/>
+              </a:rPr>
+              <a:t>soubory</a:t>
+            </a:r>
+            <a:r>
+              <a:rPr sz="1100" b="0" i="1">
+                <a:solidFill>
+                  <a:srgbClr val="21295C"/>
+                </a:solidFill>
+                <a:latin typeface="Calibri"/>
+              </a:rPr>
+              <a:t> — </a:t>
+            </a:r>
+            <a:r>
+              <a:rPr sz="1100" b="0" i="1" err="1">
+                <a:solidFill>
+                  <a:srgbClr val="21295C"/>
+                </a:solidFill>
+                <a:latin typeface="Calibri"/>
+              </a:rPr>
+              <a:t>verzujete</a:t>
+            </a:r>
+            <a:r>
+              <a:rPr sz="1100" b="0" i="1">
+                <a:solidFill>
+                  <a:srgbClr val="21295C"/>
+                </a:solidFill>
+                <a:latin typeface="Calibri"/>
+              </a:rPr>
+              <a:t> je v Gitu, </a:t>
+            </a:r>
+            <a:r>
+              <a:rPr sz="1100" b="0" i="1" err="1">
+                <a:solidFill>
+                  <a:srgbClr val="21295C"/>
+                </a:solidFill>
+                <a:latin typeface="Calibri"/>
+              </a:rPr>
+              <a:t>sdílíte</a:t>
+            </a:r>
+            <a:r>
+              <a:rPr sz="1100" b="0" i="1">
+                <a:solidFill>
+                  <a:srgbClr val="21295C"/>
+                </a:solidFill>
+                <a:latin typeface="Calibri"/>
+              </a:rPr>
+              <a:t> v </a:t>
+            </a:r>
+            <a:r>
+              <a:rPr sz="1100" b="0" i="1" err="1">
+                <a:solidFill>
+                  <a:srgbClr val="21295C"/>
+                </a:solidFill>
+                <a:latin typeface="Calibri"/>
+              </a:rPr>
+              <a:t>týmu</a:t>
+            </a:r>
+            <a:r>
+              <a:rPr sz="1100" b="0" i="1">
+                <a:solidFill>
+                  <a:srgbClr val="21295C"/>
+                </a:solidFill>
+                <a:latin typeface="Calibri"/>
+              </a:rPr>
+              <a:t>, a s </a:t>
+            </a:r>
+            <a:r>
+              <a:rPr sz="1100" b="0" i="1" err="1">
+                <a:solidFill>
+                  <a:srgbClr val="21295C"/>
+                </a:solidFill>
+                <a:latin typeface="Calibri"/>
+              </a:rPr>
+              <a:t>novým</a:t>
+            </a:r>
+            <a:r>
+              <a:rPr sz="1100" b="0" i="1">
+                <a:solidFill>
+                  <a:srgbClr val="21295C"/>
+                </a:solidFill>
+                <a:latin typeface="Calibri"/>
+              </a:rPr>
+              <a:t> </a:t>
+            </a:r>
+            <a:r>
+              <a:rPr sz="1100" b="0" i="1" err="1">
+                <a:solidFill>
+                  <a:srgbClr val="21295C"/>
+                </a:solidFill>
+                <a:latin typeface="Calibri"/>
+              </a:rPr>
+              <a:t>modelem</a:t>
+            </a:r>
+            <a:r>
+              <a:rPr sz="1100" b="0" i="1">
+                <a:solidFill>
+                  <a:srgbClr val="21295C"/>
+                </a:solidFill>
+                <a:latin typeface="Calibri"/>
+              </a:rPr>
+              <a:t> </a:t>
+            </a:r>
+            <a:r>
+              <a:rPr sz="1100" b="0" i="1" err="1">
+                <a:solidFill>
+                  <a:srgbClr val="21295C"/>
+                </a:solidFill>
+                <a:latin typeface="Calibri"/>
+              </a:rPr>
+              <a:t>často</a:t>
+            </a:r>
+            <a:r>
+              <a:rPr sz="1100" b="0" i="1">
+                <a:solidFill>
+                  <a:srgbClr val="21295C"/>
+                </a:solidFill>
+                <a:latin typeface="Calibri"/>
+              </a:rPr>
+              <a:t> </a:t>
+            </a:r>
+            <a:r>
+              <a:rPr sz="1100" b="0" i="1" err="1">
+                <a:solidFill>
+                  <a:srgbClr val="21295C"/>
+                </a:solidFill>
+                <a:latin typeface="Calibri"/>
+              </a:rPr>
+              <a:t>stačí</a:t>
+            </a:r>
+            <a:r>
+              <a:rPr sz="1100" b="0" i="1">
+                <a:solidFill>
+                  <a:srgbClr val="21295C"/>
+                </a:solidFill>
+                <a:latin typeface="Calibri"/>
+              </a:rPr>
+              <a:t> </a:t>
+            </a:r>
+            <a:r>
+              <a:rPr sz="1100" b="0" i="1" err="1">
+                <a:solidFill>
+                  <a:srgbClr val="21295C"/>
+                </a:solidFill>
+                <a:latin typeface="Calibri"/>
+              </a:rPr>
+              <a:t>stejný</a:t>
+            </a:r>
+            <a:r>
+              <a:rPr sz="1100" b="0" i="1">
+                <a:solidFill>
+                  <a:srgbClr val="21295C"/>
+                </a:solidFill>
+                <a:latin typeface="Calibri"/>
+              </a:rPr>
+              <a:t> prompt pro </a:t>
+            </a:r>
+            <a:r>
+              <a:rPr sz="1100" b="0" i="1" err="1">
+                <a:solidFill>
+                  <a:srgbClr val="21295C"/>
+                </a:solidFill>
+                <a:latin typeface="Calibri"/>
+              </a:rPr>
+              <a:t>lepší</a:t>
+            </a:r>
+            <a:r>
+              <a:rPr sz="1100" b="0" i="1">
+                <a:solidFill>
+                  <a:srgbClr val="21295C"/>
+                </a:solidFill>
+                <a:latin typeface="Calibri"/>
+              </a:rPr>
+              <a:t> </a:t>
+            </a:r>
+            <a:r>
+              <a:rPr sz="1100" b="0" i="1" err="1">
+                <a:solidFill>
+                  <a:srgbClr val="21295C"/>
+                </a:solidFill>
+                <a:latin typeface="Calibri"/>
+              </a:rPr>
+              <a:t>výsledky</a:t>
+            </a:r>
+            <a:r>
+              <a:rPr sz="1100" b="0" i="1">
+                <a:solidFill>
+                  <a:srgbClr val="21295C"/>
+                </a:solidFill>
+                <a:latin typeface="Calibri"/>
+              </a:rPr>
+              <a:t>.</a:t>
             </a:r>
           </a:p>
         </p:txBody>
@@ -8714,7 +8966,7 @@
         </p:nvSpPr>
         <p:spPr>
           <a:xfrm>
-            <a:off x="822960" y="6126480"/>
+            <a:off x="822960" y="6379535"/>
             <a:ext cx="10058400" cy="320040"/>
           </a:xfrm>
           <a:prstGeom prst="rect">
@@ -8730,14 +8982,56 @@
           <a:p>
             <a:pPr algn="l"/>
             <a:r>
+              <a:rPr sz="1100" b="0" i="1" err="1">
+                <a:solidFill>
+                  <a:srgbClr val="B8C8E0"/>
+                </a:solidFill>
+                <a:latin typeface="Calibri"/>
+              </a:rPr>
+              <a:t>github.com</a:t>
+            </a:r>
+            <a:r>
               <a:rPr sz="1100" b="0" i="1">
                 <a:solidFill>
                   <a:srgbClr val="B8C8E0"/>
                 </a:solidFill>
                 <a:latin typeface="Calibri"/>
               </a:rPr>
-              <a:t>github.com/davidmasinzprahy · davidmasinzprahy</a:t>
-            </a:r>
+              <a:t>/</a:t>
+            </a:r>
+            <a:r>
+              <a:rPr sz="1100" b="0" i="1" err="1">
+                <a:solidFill>
+                  <a:srgbClr val="B8C8E0"/>
+                </a:solidFill>
+                <a:latin typeface="Calibri"/>
+              </a:rPr>
+              <a:t>davidmasinzprahy</a:t>
+            </a:r>
+            <a:r>
+              <a:rPr sz="1100" b="0" i="1">
+                <a:solidFill>
+                  <a:srgbClr val="B8C8E0"/>
+                </a:solidFill>
+                <a:latin typeface="Calibri"/>
+              </a:rPr>
+              <a:t> · </a:t>
+            </a:r>
+            <a:r>
+              <a:rPr sz="1100" b="0" i="1" err="1">
+                <a:solidFill>
+                  <a:srgbClr val="B8C8E0"/>
+                </a:solidFill>
+                <a:latin typeface="Calibri"/>
+              </a:rPr>
+              <a:t>davidmasinzprahy</a:t>
+            </a:r>
+            <a:endParaRPr sz="1100" b="0" i="1">
+              <a:solidFill>
+                <a:srgbClr val="B8C8E0"/>
+              </a:solidFill>
+              <a:latin typeface="Calibri"/>
+            </a:endParaRPr>
           </a:p>
         </p:txBody>
       </p:sp>
@@ -8749,7 +9043,7 @@
         </p:nvSpPr>
         <p:spPr>
           <a:xfrm>
-            <a:off x="10789920" y="6126480"/>
+            <a:off x="10728960" y="6379535"/>
             <a:ext cx="1280160" cy="320040"/>
           </a:xfrm>
           <a:prstGeom prst="rect">
@@ -13934,7 +14228,7 @@
           <a:p>
             <a:pPr algn="l"/>
             <a:r>
-              <a:rPr sz="3000" b="1" i="0" dirty="0" err="1">
+              <a:rPr sz="3000" b="1" i="0" err="1">
                 <a:solidFill>
                   <a:srgbClr val="21295C"/>
                 </a:solidFill>
@@ -13943,7 +14237,7 @@
               <a:t>Klíčové</a:t>
             </a:r>
             <a:r>
-              <a:rPr sz="3000" b="1" i="0" dirty="0">
+              <a:rPr sz="3000" b="1" i="0">
                 <a:solidFill>
                   <a:srgbClr val="21295C"/>
                 </a:solidFill>
@@ -13952,7 +14246,7 @@
               <a:t> </a:t>
             </a:r>
             <a:r>
-              <a:rPr lang="cs-CZ" sz="3000" b="1" i="0" dirty="0">
+              <a:rPr lang="cs-CZ" sz="3000" b="1" i="0">
                 <a:solidFill>
                   <a:srgbClr val="21295C"/>
                 </a:solidFill>
@@ -13961,7 +14255,7 @@
               <a:t>aplikační </a:t>
             </a:r>
             <a:r>
-              <a:rPr sz="3000" b="1" i="0" dirty="0" err="1">
+              <a:rPr sz="3000" b="1" i="0" err="1">
                 <a:solidFill>
                   <a:srgbClr val="21295C"/>
                 </a:solidFill>
@@ -13969,7 +14263,7 @@
               </a:rPr>
               <a:t>funkce</a:t>
             </a:r>
-            <a:endParaRPr sz="3000" b="1" i="0" dirty="0">
+            <a:endParaRPr sz="3000" b="1" i="0">
               <a:solidFill>
                 <a:srgbClr val="21295C"/>
               </a:solidFill>
@@ -16084,7 +16378,7 @@
 </file>
 
 <file path=ppt/slides/slide16.xml><?xml version="1.0" encoding="utf-8"?>
-<p:sld xmlns:a="http://schemas.openxmlformats.org/drawingml/2006/main" xmlns:p="http://schemas.openxmlformats.org/presentationml/2006/main" xmlns:r="http://schemas.openxmlformats.org/officeDocument/2006/relationships">
+<p:sld xmlns:a="http://schemas.openxmlformats.org/drawingml/2006/main" xmlns:r="http://schemas.openxmlformats.org/officeDocument/2006/relationships" xmlns:p="http://schemas.openxmlformats.org/presentationml/2006/main">
   <p:cSld>
     <p:spTree>
       <p:nvGrpSpPr>
@@ -16092,7 +16386,14 @@
         <p:cNvGrpSpPr/>
         <p:nvPr/>
       </p:nvGrpSpPr>
-      <p:grpSpPr/>
+      <p:grpSpPr>
+        <a:xfrm>
+          <a:off x="0" y="0"/>
+          <a:ext cx="0" cy="0"/>
+          <a:chOff x="0" y="0"/>
+          <a:chExt cx="0" cy="0"/>
+        </a:xfrm>
+      </p:grpSpPr>
       <p:sp>
         <p:nvSpPr>
           <p:cNvPr id="2" name="Rectangle 1"/>
@@ -16207,7 +16508,7 @@
           <a:p>
             <a:pPr algn="l"/>
             <a:r>
-              <a:rPr sz="3000" b="1" i="0" dirty="0" err="1">
+              <a:rPr sz="3000" b="1" i="0" err="1">
                 <a:solidFill>
                   <a:srgbClr val="21295C"/>
                 </a:solidFill>
@@ -16215,7 +16516,7 @@
               </a:rPr>
               <a:t>Automatizace a integrace s macOS</a:t>
             </a:r>
-            <a:endParaRPr sz="3000" b="1" i="0" dirty="0">
+            <a:endParaRPr sz="3000" b="1" i="0">
               <a:solidFill>
                 <a:srgbClr val="21295C"/>
               </a:solidFill>
@@ -18382,7 +18683,7 @@
           <a:p>
             <a:pPr algn="ctr"/>
             <a:r>
-              <a:rPr lang="cs-CZ" sz="4800" b="1" dirty="0"/>
+              <a:rPr lang="cs-CZ" sz="4800" b="1"/>
               <a:t>Děkuji za pozornost</a:t>
             </a:r>
           </a:p>
@@ -18467,7 +18768,7 @@
           <a:lstStyle/>
           <a:p>
             <a:pPr algn="ctr"/>
-            <a:endParaRPr/>
+            <a:endParaRPr lang="cs-CZ" noProof="1"/>
           </a:p>
         </p:txBody>
       </p:sp>
@@ -18512,7 +18813,7 @@
           <a:lstStyle/>
           <a:p>
             <a:pPr algn="ctr"/>
-            <a:endParaRPr/>
+            <a:endParaRPr lang="cs-CZ" noProof="1"/>
           </a:p>
         </p:txBody>
       </p:sp>
@@ -18540,7 +18841,7 @@
           <a:p>
             <a:pPr algn="l"/>
             <a:r>
-              <a:rPr sz="3000" b="1" i="0">
+              <a:rPr lang="cs-CZ" sz="3000" b="1" i="0" noProof="1">
                 <a:solidFill>
                   <a:srgbClr val="21295C"/>
                 </a:solidFill>
@@ -18575,7 +18876,7 @@
           <a:p>
             <a:pPr algn="l"/>
             <a:r>
-              <a:rPr sz="1400" b="0" i="1">
+              <a:rPr lang="cs-CZ" sz="1400" b="0" i="1" noProof="1">
                 <a:solidFill>
                   <a:srgbClr val="1C7293"/>
                 </a:solidFill>
@@ -18610,7 +18911,7 @@
           <a:p>
             <a:pPr algn="r"/>
             <a:r>
-              <a:rPr sz="1000" b="0" i="0">
+              <a:rPr lang="cs-CZ" sz="1000" b="0" i="0" noProof="1">
                 <a:solidFill>
                   <a:srgbClr val="5C6B82"/>
                 </a:solidFill>
@@ -18645,7 +18946,7 @@
           <a:p>
             <a:pPr algn="l"/>
             <a:r>
-              <a:rPr sz="1000" b="0" i="0">
+              <a:rPr lang="cs-CZ" sz="1000" b="0" i="0" noProof="1">
                 <a:solidFill>
                   <a:srgbClr val="5C6B82"/>
                 </a:solidFill>
@@ -18687,7 +18988,7 @@
               </a:spcAft>
             </a:pPr>
             <a:r>
-              <a:rPr sz="1600" b="0" i="0">
+              <a:rPr lang="cs-CZ" sz="1600" b="0" i="0" noProof="1">
                 <a:solidFill>
                   <a:srgbClr val="1B223A"/>
                 </a:solidFill>
@@ -18706,7 +19007,7 @@
               </a:spcAft>
             </a:pPr>
             <a:r>
-              <a:rPr sz="1600" b="0" i="0">
+              <a:rPr lang="cs-CZ" sz="1600" b="0" i="0" noProof="1">
                 <a:solidFill>
                   <a:srgbClr val="1B223A"/>
                 </a:solidFill>
@@ -18758,7 +19059,7 @@
           <a:lstStyle/>
           <a:p>
             <a:pPr algn="ctr"/>
-            <a:endParaRPr/>
+            <a:endParaRPr lang="cs-CZ" noProof="1"/>
           </a:p>
         </p:txBody>
       </p:sp>
@@ -18803,7 +19104,7 @@
           <a:lstStyle/>
           <a:p>
             <a:pPr algn="ctr"/>
-            <a:endParaRPr/>
+            <a:endParaRPr lang="cs-CZ" noProof="1"/>
           </a:p>
         </p:txBody>
       </p:sp>
@@ -18848,7 +19149,7 @@
           <a:lstStyle/>
           <a:p>
             <a:pPr algn="ctr"/>
-            <a:endParaRPr/>
+            <a:endParaRPr lang="cs-CZ" noProof="1"/>
           </a:p>
         </p:txBody>
       </p:sp>
@@ -18876,7 +19177,7 @@
           <a:p>
             <a:pPr algn="ctr"/>
             <a:r>
-              <a:rPr sz="2200" b="1" i="0">
+              <a:rPr lang="cs-CZ" sz="2200" b="1" i="0" noProof="1">
                 <a:solidFill>
                   <a:srgbClr val="FFFFFF"/>
                 </a:solidFill>
@@ -18911,7 +19212,7 @@
           <a:p>
             <a:pPr algn="l"/>
             <a:r>
-              <a:rPr sz="1700" b="1" i="0">
+              <a:rPr lang="cs-CZ" sz="1700" b="1" i="0" noProof="1">
                 <a:solidFill>
                   <a:srgbClr val="21295C"/>
                 </a:solidFill>
@@ -18953,7 +19254,7 @@
               </a:spcAft>
             </a:pPr>
             <a:r>
-              <a:rPr sz="1200" b="0" i="0">
+              <a:rPr lang="cs-CZ" sz="1200" b="0" i="0" noProof="1">
                 <a:solidFill>
                   <a:srgbClr val="5C6B82"/>
                 </a:solidFill>
@@ -19005,7 +19306,7 @@
           <a:lstStyle/>
           <a:p>
             <a:pPr algn="ctr"/>
-            <a:endParaRPr/>
+            <a:endParaRPr lang="cs-CZ" noProof="1"/>
           </a:p>
         </p:txBody>
       </p:sp>
@@ -19050,7 +19351,7 @@
           <a:lstStyle/>
           <a:p>
             <a:pPr algn="ctr"/>
-            <a:endParaRPr/>
+            <a:endParaRPr lang="cs-CZ" noProof="1"/>
           </a:p>
         </p:txBody>
       </p:sp>
@@ -19095,7 +19396,7 @@
           <a:lstStyle/>
           <a:p>
             <a:pPr algn="ctr"/>
-            <a:endParaRPr/>
+            <a:endParaRPr lang="cs-CZ" noProof="1"/>
           </a:p>
         </p:txBody>
       </p:sp>
@@ -19123,7 +19424,7 @@
           <a:p>
             <a:pPr algn="ctr"/>
             <a:r>
-              <a:rPr sz="2200" b="1" i="0">
+              <a:rPr lang="cs-CZ" sz="2200" b="1" i="0" noProof="1">
                 <a:solidFill>
                   <a:srgbClr val="FFFFFF"/>
                 </a:solidFill>
@@ -19158,7 +19459,7 @@
           <a:p>
             <a:pPr algn="l"/>
             <a:r>
-              <a:rPr sz="1700" b="1" i="0">
+              <a:rPr lang="cs-CZ" sz="1700" b="1" i="0" noProof="1">
                 <a:solidFill>
                   <a:srgbClr val="21295C"/>
                 </a:solidFill>
@@ -19200,7 +19501,7 @@
               </a:spcAft>
             </a:pPr>
             <a:r>
-              <a:rPr sz="1200" b="0" i="0">
+              <a:rPr lang="cs-CZ" sz="1200" b="0" i="0" noProof="1">
                 <a:solidFill>
                   <a:srgbClr val="5C6B82"/>
                 </a:solidFill>
@@ -19252,7 +19553,7 @@
           <a:lstStyle/>
           <a:p>
             <a:pPr algn="ctr"/>
-            <a:endParaRPr/>
+            <a:endParaRPr lang="cs-CZ" noProof="1"/>
           </a:p>
         </p:txBody>
       </p:sp>
@@ -19297,7 +19598,7 @@
           <a:lstStyle/>
           <a:p>
             <a:pPr algn="ctr"/>
-            <a:endParaRPr/>
+            <a:endParaRPr lang="cs-CZ" noProof="1"/>
           </a:p>
         </p:txBody>
       </p:sp>
@@ -19342,7 +19643,7 @@
           <a:lstStyle/>
           <a:p>
             <a:pPr algn="ctr"/>
-            <a:endParaRPr/>
+            <a:endParaRPr lang="cs-CZ" noProof="1"/>
           </a:p>
         </p:txBody>
       </p:sp>
@@ -19370,7 +19671,7 @@
           <a:p>
             <a:pPr algn="ctr"/>
             <a:r>
-              <a:rPr sz="2200" b="1" i="0">
+              <a:rPr lang="cs-CZ" sz="2200" b="1" i="0" noProof="1">
                 <a:solidFill>
                   <a:srgbClr val="FFFFFF"/>
                 </a:solidFill>
@@ -19405,7 +19706,7 @@
           <a:p>
             <a:pPr algn="l"/>
             <a:r>
-              <a:rPr sz="1700" b="1" i="0">
+              <a:rPr lang="cs-CZ" sz="1700" b="1" i="0" noProof="1">
                 <a:solidFill>
                   <a:srgbClr val="21295C"/>
                 </a:solidFill>
@@ -19447,7 +19748,7 @@
               </a:spcAft>
             </a:pPr>
             <a:r>
-              <a:rPr sz="1200" b="0" i="0">
+              <a:rPr lang="cs-CZ" sz="1200" b="0" i="0" noProof="1">
                 <a:solidFill>
                   <a:srgbClr val="5C6B82"/>
                 </a:solidFill>
@@ -20625,7 +20926,7 @@
           <a:p>
             <a:pPr algn="ctr"/>
             <a:r>
-              <a:rPr sz="1100" b="1" i="0" dirty="0">
+              <a:rPr sz="1100" b="1" i="0">
                 <a:solidFill>
                   <a:srgbClr val="FFFFFF"/>
                 </a:solidFill>
@@ -20634,7 +20935,7 @@
               <a:t>✗  </a:t>
             </a:r>
             <a:r>
-              <a:rPr sz="1100" b="1" i="0" dirty="0" err="1">
+              <a:rPr sz="1100" b="1" i="0" err="1">
                 <a:solidFill>
                   <a:srgbClr val="FFFFFF"/>
                 </a:solidFill>
@@ -20643,7 +20944,7 @@
               <a:t>žádný</a:t>
             </a:r>
             <a:r>
-              <a:rPr sz="1100" b="1" i="0" dirty="0">
+              <a:rPr sz="1100" b="1" i="0">
                 <a:solidFill>
                   <a:srgbClr val="FFFFFF"/>
                 </a:solidFill>
@@ -20652,7 +20953,7 @@
               <a:t> </a:t>
             </a:r>
             <a:r>
-              <a:rPr sz="1100" b="1" i="0" dirty="0" err="1">
+              <a:rPr sz="1100" b="1" i="0" err="1">
                 <a:solidFill>
                   <a:srgbClr val="FFFFFF"/>
                 </a:solidFill>
@@ -20661,7 +20962,7 @@
               <a:t>měsíční</a:t>
             </a:r>
             <a:r>
-              <a:rPr sz="1100" b="1" i="0" dirty="0">
+              <a:rPr sz="1100" b="1" i="0">
                 <a:solidFill>
                   <a:srgbClr val="FFFFFF"/>
                 </a:solidFill>
@@ -20670,7 +20971,7 @@
               <a:t> </a:t>
             </a:r>
             <a:r>
-              <a:rPr sz="1100" b="1" i="0" dirty="0" err="1">
+              <a:rPr sz="1100" b="1" i="0" err="1">
                 <a:solidFill>
                   <a:srgbClr val="FFFFFF"/>
                 </a:solidFill>
@@ -20678,7 +20979,7 @@
               </a:rPr>
               <a:t>poplatek</a:t>
             </a:r>
-            <a:endParaRPr sz="1100" b="1" i="0" dirty="0">
+            <a:endParaRPr sz="1100" b="1" i="0">
               <a:solidFill>
                 <a:srgbClr val="FFFFFF"/>
               </a:solidFill>
@@ -20696,7 +20997,7 @@
         <p:spPr>
           <a:xfrm>
             <a:off x="822960" y="6446520"/>
-            <a:ext cx="10058400" cy="320040"/>
+            <a:ext cx="10058400" cy="169277"/>
           </a:xfrm>
           <a:prstGeom prst="rect">
             <a:avLst/>
@@ -20711,13 +21012,13 @@
           <a:p>
             <a:pPr algn="l"/>
             <a:r>
-              <a:rPr sz="1100" b="0" i="1">
+              <a:rPr lang="cs-CZ" sz="1100" b="0" i="1" noProof="1">
                 <a:solidFill>
                   <a:srgbClr val="B8C8E0"/>
                 </a:solidFill>
                 <a:latin typeface="Calibri"/>
               </a:rPr>
-              <a:t>Pacientská, právní i finanční data se nikdy nedostanou ven z počítače.</a:t>
+              <a:t>Pacientská, právní i finanční data se nikdy nedostanou ven z počítače nebo z lokální sítě uživatele.</a:t>
             </a:r>
           </a:p>
         </p:txBody>
@@ -22090,8 +22391,8 @@
         </p:nvSpPr>
         <p:spPr>
           <a:xfrm>
-            <a:off x="1417320" y="5852160"/>
-            <a:ext cx="4937760" cy="320040"/>
+            <a:off x="1417320" y="5927541"/>
+            <a:ext cx="4937760" cy="169277"/>
           </a:xfrm>
           <a:prstGeom prst="rect">
             <a:avLst/>
@@ -22106,13 +22407,157 @@
           <a:p>
             <a:pPr algn="l"/>
             <a:r>
+              <a:rPr sz="1100" b="0" i="0" err="1">
+                <a:solidFill>
+                  <a:srgbClr val="FFFFFF"/>
+                </a:solidFill>
+                <a:latin typeface="Calibri"/>
+              </a:rPr>
+              <a:t>Výkonnější</a:t>
+            </a:r>
+            <a:r>
               <a:rPr sz="1100" b="0" i="0">
                 <a:solidFill>
                   <a:srgbClr val="FFFFFF"/>
                 </a:solidFill>
                 <a:latin typeface="Calibri"/>
               </a:rPr>
-              <a:t>Výkonnější Mac (Mac Studio M2/M3 Ultra) — větší RAM = větší modely (70B+).</a:t>
+              <a:t> Mac (Mac</a:t>
+            </a:r>
+            <a:r>
+              <a:rPr lang="cs-CZ" sz="1100" b="0" i="0" err="1">
+                <a:solidFill>
+                  <a:srgbClr val="FFFFFF"/>
+                </a:solidFill>
+                <a:latin typeface="Calibri"/>
+              </a:rPr>
+              <a:t>Book</a:t>
+            </a:r>
+            <a:r>
+              <a:rPr lang="cs-CZ" sz="1100" b="0" i="0">
+                <a:solidFill>
+                  <a:srgbClr val="FFFFFF"/>
+                </a:solidFill>
+                <a:latin typeface="Calibri"/>
+              </a:rPr>
+              <a:t> </a:t>
+            </a:r>
+            <a:r>
+              <a:rPr sz="1100" b="0" i="0">
+                <a:solidFill>
+                  <a:srgbClr val="FFFFFF"/>
+                </a:solidFill>
+                <a:latin typeface="Calibri"/>
+              </a:rPr>
+              <a:t>M</a:t>
+            </a:r>
+            <a:r>
+              <a:rPr lang="cs-CZ" sz="1100" b="0" i="0">
+                <a:solidFill>
+                  <a:srgbClr val="FFFFFF"/>
+                </a:solidFill>
+                <a:latin typeface="Calibri"/>
+              </a:rPr>
+              <a:t>4 Pro  </a:t>
+            </a:r>
+            <a:r>
+              <a:rPr sz="1100" b="0" i="0">
+                <a:solidFill>
+                  <a:srgbClr val="FFFFFF"/>
+                </a:solidFill>
+                <a:latin typeface="Calibri"/>
+              </a:rPr>
+              <a:t>/M</a:t>
+            </a:r>
+            <a:r>
+              <a:rPr lang="cs-CZ" sz="1100" b="0" i="0">
+                <a:solidFill>
+                  <a:srgbClr val="FFFFFF"/>
+                </a:solidFill>
+                <a:latin typeface="Calibri"/>
+              </a:rPr>
+              <a:t>5</a:t>
+            </a:r>
+            <a:r>
+              <a:rPr sz="1100" b="0" i="0">
+                <a:solidFill>
+                  <a:srgbClr val="FFFFFF"/>
+                </a:solidFill>
+                <a:latin typeface="Calibri"/>
+              </a:rPr>
+              <a:t> </a:t>
+            </a:r>
+            <a:r>
+              <a:rPr lang="cs-CZ" sz="1100" b="0" i="0">
+                <a:solidFill>
+                  <a:srgbClr val="FFFFFF"/>
+                </a:solidFill>
+                <a:latin typeface="Calibri"/>
+              </a:rPr>
+              <a:t>Max</a:t>
+            </a:r>
+            <a:r>
+              <a:rPr sz="1100" b="0" i="0">
+                <a:solidFill>
+                  <a:srgbClr val="FFFFFF"/>
+                </a:solidFill>
+                <a:latin typeface="Calibri"/>
+              </a:rPr>
+              <a:t>) — </a:t>
+            </a:r>
+            <a:r>
+              <a:rPr sz="1100" b="0" i="0" err="1">
+                <a:solidFill>
+                  <a:srgbClr val="FFFFFF"/>
+                </a:solidFill>
+                <a:latin typeface="Calibri"/>
+              </a:rPr>
+              <a:t>větší</a:t>
+            </a:r>
+            <a:r>
+              <a:rPr sz="1100" b="0" i="0">
+                <a:solidFill>
+                  <a:srgbClr val="FFFFFF"/>
+                </a:solidFill>
+                <a:latin typeface="Calibri"/>
+              </a:rPr>
+              <a:t> RAM = </a:t>
+            </a:r>
+            <a:r>
+              <a:rPr sz="1100" b="0" i="0" err="1">
+                <a:solidFill>
+                  <a:srgbClr val="FFFFFF"/>
+                </a:solidFill>
+                <a:latin typeface="Calibri"/>
+              </a:rPr>
+              <a:t>větší</a:t>
+            </a:r>
+            <a:r>
+              <a:rPr sz="1100" b="0" i="0">
+                <a:solidFill>
+                  <a:srgbClr val="FFFFFF"/>
+                </a:solidFill>
+                <a:latin typeface="Calibri"/>
+              </a:rPr>
+              <a:t> </a:t>
+            </a:r>
+            <a:r>
+              <a:rPr sz="1100" b="0" i="0" err="1">
+                <a:solidFill>
+                  <a:srgbClr val="FFFFFF"/>
+                </a:solidFill>
+                <a:latin typeface="Calibri"/>
+              </a:rPr>
+              <a:t>modely</a:t>
+            </a:r>
+            <a:r>
+              <a:rPr sz="1100" b="0" i="0">
+                <a:solidFill>
+                  <a:srgbClr val="FFFFFF"/>
+                </a:solidFill>
+                <a:latin typeface="Calibri"/>
+              </a:rPr>
+              <a:t> (70B+).</a:t>
             </a:r>
           </a:p>
         </p:txBody>
@@ -22455,7 +22900,7 @@
                 </a:solidFill>
                 <a:latin typeface="Calibri"/>
               </a:rPr>
-              <a:t>Dvousloupcový HSplitView · konfigurace vlevo, runtime vpravo</a:t>
+              <a:t>Dvousloupcový HSplitView · vlevo konfigurace + Spustit, vpravo VSplitView Prompt / Průběh / Log</a:t>
             </a:r>
           </a:p>
         </p:txBody>
@@ -22869,7 +23314,7 @@
                 </a:solidFill>
                 <a:latin typeface="Calibri"/>
               </a:rPr>
-              <a:t>Help</a:t>
+              <a:t>Nápověda</a:t>
             </a:r>
           </a:p>
         </p:txBody>
@@ -22951,7 +23396,7 @@
                 </a:solidFill>
                 <a:latin typeface="Calibri"/>
               </a:rPr>
-              <a:t>Output</a:t>
+              <a:t>Výstup</a:t>
             </a:r>
           </a:p>
         </p:txBody>
@@ -23113,7 +23558,7 @@
                 </a:solidFill>
                 <a:latin typeface="Calibri"/>
               </a:rPr>
-              <a:t>Připraveno</a:t>
+              <a:t>Server dostupný</a:t>
             </a:r>
           </a:p>
         </p:txBody>
@@ -23303,6 +23748,11 @@
               <a:t>Cache:  ~/Library/Caches/SH</a:t>
             </a:r>
           </a:p>
+          <a:p>
+            <a:r>
+              <a:t>Prompty:  ~/Documents/SH/Prompty</a:t>
+            </a:r>
+          </a:p>
         </p:txBody>
       </p:sp>
       <p:sp>
@@ -23382,7 +23832,7 @@
                 </a:solidFill>
                 <a:latin typeface="Calibri"/>
               </a:rPr>
-              <a:t>Server a model</a:t>
+              <a:t>Server · Modely · Režim</a:t>
             </a:r>
           </a:p>
         </p:txBody>
@@ -23417,7 +23867,7 @@
                 </a:solidFill>
                 <a:latin typeface="Calibri"/>
               </a:rPr>
-              <a:t>Server:  http://localhost:1234/v1   [Ověřit]</a:t>
+              <a:t>Base URL:  http://localhost:1234/v1   [Ověřit ✓]</a:t>
             </a:r>
           </a:p>
         </p:txBody>
@@ -23569,7 +24019,7 @@
                 </a:solidFill>
                 <a:latin typeface="Calibri"/>
               </a:rPr>
-              <a:t>Prompt   [ Načíst .md ]</a:t>
+              <a:t>Prompt   [ Načíst .md ]   [ ⛶ Fullscreen ]</a:t>
             </a:r>
           </a:p>
         </p:txBody>
@@ -23861,7 +24311,7 @@
                 </a:solidFill>
                 <a:latin typeface="Calibri"/>
               </a:rPr>
-              <a:t>Cache: 38× hit  ·  9× miss</a:t>
+              <a:t>Naposledy: zprava_2024_03_11.pdf · ✓ 1 180 ms</a:t>
             </a:r>
           </a:p>
         </p:txBody>
@@ -23896,7 +24346,7 @@
                 </a:solidFill>
                 <a:latin typeface="Calibri"/>
               </a:rPr>
-              <a:t>ETA: ~ 4 min 20 s</a:t>
+              <a:t>Cache: 38× hit · 9× miss</a:t>
             </a:r>
           </a:p>
         </p:txBody>
@@ -23931,7 +24381,7 @@
                 </a:solidFill>
                 <a:latin typeface="Calibri"/>
               </a:rPr>
-              <a:t>Avg: 1 240 ms / dokument</a:t>
+              <a:t>12,3 dok/min · ⌀ 4,8 s/dok · ETA ~ 4 min 20 s</a:t>
             </a:r>
           </a:p>
         </p:txBody>
@@ -24428,7 +24878,7 @@
                 </a:solidFill>
                 <a:latin typeface="Calibri"/>
               </a:rPr>
-              <a:t>Schematický náhled — skutečné UI používá .regularMaterial glass cards a nativní macOS toolbar.</a:t>
+              <a:t>Schematický náhled — skutečné UI: glass cards, Pipeline menu bar (Cmd+R/.), tažitelná dělítka VSplitView, multi-window (Cmd+Shift+N), Otevřít nedávné (Cmd+O).</a:t>
             </a:r>
           </a:p>
         </p:txBody>
@@ -29887,13 +30337,112 @@
               </a:spcAft>
             </a:pPr>
             <a:r>
+              <a:rPr sz="1100" b="0" i="0" err="1">
+                <a:solidFill>
+                  <a:srgbClr val="1B223A"/>
+                </a:solidFill>
+                <a:latin typeface="Calibri"/>
+              </a:rPr>
+              <a:t>Vstup</a:t>
+            </a:r>
+            <a:r>
               <a:rPr sz="1100" b="0" i="0">
                 <a:solidFill>
                   <a:srgbClr val="1B223A"/>
                 </a:solidFill>
                 <a:latin typeface="Calibri"/>
               </a:rPr>
-              <a:t>Vstup: ambulantní a propouštěcí zprávy stovek pacientů.</a:t>
+              <a:t>: </a:t>
+            </a:r>
+            <a:r>
+              <a:rPr sz="1100" b="0" i="0" err="1">
+                <a:solidFill>
+                  <a:srgbClr val="1B223A"/>
+                </a:solidFill>
+                <a:latin typeface="Calibri"/>
+              </a:rPr>
+              <a:t>ambulantní</a:t>
+            </a:r>
+            <a:r>
+              <a:rPr sz="1100" b="0" i="0">
+                <a:solidFill>
+                  <a:srgbClr val="1B223A"/>
+                </a:solidFill>
+                <a:latin typeface="Calibri"/>
+              </a:rPr>
+              <a:t> a </a:t>
+            </a:r>
+            <a:r>
+              <a:rPr sz="1100" b="0" i="0" err="1">
+                <a:solidFill>
+                  <a:srgbClr val="1B223A"/>
+                </a:solidFill>
+                <a:latin typeface="Calibri"/>
+              </a:rPr>
+              <a:t>propouštěcí</a:t>
+            </a:r>
+            <a:r>
+              <a:rPr sz="1100" b="0" i="0">
+                <a:solidFill>
+                  <a:srgbClr val="1B223A"/>
+                </a:solidFill>
+                <a:latin typeface="Calibri"/>
+              </a:rPr>
+              <a:t> </a:t>
+            </a:r>
+            <a:r>
+              <a:rPr sz="1100" b="0" i="0" err="1">
+                <a:solidFill>
+                  <a:srgbClr val="1B223A"/>
+                </a:solidFill>
+                <a:latin typeface="Calibri"/>
+              </a:rPr>
+              <a:t>zprávy</a:t>
+            </a:r>
+            <a:r>
+              <a:rPr sz="1100" b="0" i="0">
+                <a:solidFill>
+                  <a:srgbClr val="1B223A"/>
+                </a:solidFill>
+                <a:latin typeface="Calibri"/>
+              </a:rPr>
+              <a:t> </a:t>
+            </a:r>
+            <a:r>
+              <a:rPr sz="1100" b="0" i="0" err="1">
+                <a:solidFill>
+                  <a:srgbClr val="1B223A"/>
+                </a:solidFill>
+                <a:latin typeface="Calibri"/>
+              </a:rPr>
+              <a:t>stovek</a:t>
+            </a:r>
+            <a:r>
+              <a:rPr sz="1100" b="0" i="0">
+                <a:solidFill>
+                  <a:srgbClr val="1B223A"/>
+                </a:solidFill>
+                <a:latin typeface="Calibri"/>
+              </a:rPr>
+              <a:t> </a:t>
+            </a:r>
+            <a:r>
+              <a:rPr sz="1100" b="0" i="0" err="1">
+                <a:solidFill>
+                  <a:srgbClr val="1B223A"/>
+                </a:solidFill>
+                <a:latin typeface="Calibri"/>
+              </a:rPr>
+              <a:t>pacientů</a:t>
+            </a:r>
+            <a:r>
+              <a:rPr sz="1100" b="0" i="0">
+                <a:solidFill>
+                  <a:srgbClr val="1B223A"/>
+                </a:solidFill>
+                <a:latin typeface="Calibri"/>
+              </a:rPr>
+              <a:t>.</a:t>
             </a:r>
           </a:p>
           <a:p>
@@ -29912,7 +30461,187 @@
                 </a:solidFill>
                 <a:latin typeface="Calibri"/>
               </a:rPr>
-              <a:t>Prompt: extrahuj diagnózy (ICD-10), lab. hodnoty, datumy, medikaci — a místo jména/RČ vrať pseudo-ID tvaru P-{hash(rodné_číslo)[:8]}.</a:t>
+              <a:t>Prompt: </a:t>
+            </a:r>
+            <a:r>
+              <a:rPr sz="1100" b="0" i="0" err="1">
+                <a:solidFill>
+                  <a:srgbClr val="1B223A"/>
+                </a:solidFill>
+                <a:latin typeface="Calibri"/>
+              </a:rPr>
+              <a:t>extrahuj</a:t>
+            </a:r>
+            <a:r>
+              <a:rPr sz="1100" b="0" i="0">
+                <a:solidFill>
+                  <a:srgbClr val="1B223A"/>
+                </a:solidFill>
+                <a:latin typeface="Calibri"/>
+              </a:rPr>
+              <a:t> </a:t>
+            </a:r>
+            <a:r>
+              <a:rPr sz="1100" b="0" i="0" err="1">
+                <a:solidFill>
+                  <a:srgbClr val="1B223A"/>
+                </a:solidFill>
+                <a:latin typeface="Calibri"/>
+              </a:rPr>
+              <a:t>diagnózy</a:t>
+            </a:r>
+            <a:r>
+              <a:rPr sz="1100" b="0" i="0">
+                <a:solidFill>
+                  <a:srgbClr val="1B223A"/>
+                </a:solidFill>
+                <a:latin typeface="Calibri"/>
+              </a:rPr>
+              <a:t> (ICD-10), lab. </a:t>
+            </a:r>
+            <a:r>
+              <a:rPr sz="1100" b="0" i="0" err="1">
+                <a:solidFill>
+                  <a:srgbClr val="1B223A"/>
+                </a:solidFill>
+                <a:latin typeface="Calibri"/>
+              </a:rPr>
+              <a:t>hodnoty</a:t>
+            </a:r>
+            <a:r>
+              <a:rPr sz="1100" b="0" i="0">
+                <a:solidFill>
+                  <a:srgbClr val="1B223A"/>
+                </a:solidFill>
+                <a:latin typeface="Calibri"/>
+              </a:rPr>
+              <a:t>, </a:t>
+            </a:r>
+            <a:r>
+              <a:rPr sz="1100" b="0" i="0" err="1">
+                <a:solidFill>
+                  <a:srgbClr val="1B223A"/>
+                </a:solidFill>
+                <a:latin typeface="Calibri"/>
+              </a:rPr>
+              <a:t>datumy</a:t>
+            </a:r>
+            <a:r>
+              <a:rPr sz="1100" b="0" i="0">
+                <a:solidFill>
+                  <a:srgbClr val="1B223A"/>
+                </a:solidFill>
+                <a:latin typeface="Calibri"/>
+              </a:rPr>
+              <a:t>, </a:t>
+            </a:r>
+            <a:r>
+              <a:rPr sz="1100" b="0" i="0" err="1">
+                <a:solidFill>
+                  <a:srgbClr val="1B223A"/>
+                </a:solidFill>
+                <a:latin typeface="Calibri"/>
+              </a:rPr>
+              <a:t>medikaci</a:t>
+            </a:r>
+            <a:r>
+              <a:rPr sz="1100" b="0" i="0">
+                <a:solidFill>
+                  <a:srgbClr val="1B223A"/>
+                </a:solidFill>
+                <a:latin typeface="Calibri"/>
+              </a:rPr>
+              <a:t> — a </a:t>
+            </a:r>
+            <a:r>
+              <a:rPr sz="1100" b="0" i="0" err="1">
+                <a:solidFill>
+                  <a:srgbClr val="1B223A"/>
+                </a:solidFill>
+                <a:latin typeface="Calibri"/>
+              </a:rPr>
+              <a:t>místo</a:t>
+            </a:r>
+            <a:r>
+              <a:rPr sz="1100" b="0" i="0">
+                <a:solidFill>
+                  <a:srgbClr val="1B223A"/>
+                </a:solidFill>
+                <a:latin typeface="Calibri"/>
+              </a:rPr>
+              <a:t> </a:t>
+            </a:r>
+            <a:r>
+              <a:rPr sz="1100" b="0" i="0" err="1">
+                <a:solidFill>
+                  <a:srgbClr val="1B223A"/>
+                </a:solidFill>
+                <a:latin typeface="Calibri"/>
+              </a:rPr>
+              <a:t>jména</a:t>
+            </a:r>
+            <a:r>
+              <a:rPr sz="1100" b="0" i="0">
+                <a:solidFill>
+                  <a:srgbClr val="1B223A"/>
+                </a:solidFill>
+                <a:latin typeface="Calibri"/>
+              </a:rPr>
+              <a:t>/RČ </a:t>
+            </a:r>
+            <a:r>
+              <a:rPr sz="1100" b="0" i="0" err="1">
+                <a:solidFill>
+                  <a:srgbClr val="1B223A"/>
+                </a:solidFill>
+                <a:latin typeface="Calibri"/>
+              </a:rPr>
+              <a:t>vrať</a:t>
+            </a:r>
+            <a:r>
+              <a:rPr sz="1100" b="0" i="0">
+                <a:solidFill>
+                  <a:srgbClr val="1B223A"/>
+                </a:solidFill>
+                <a:latin typeface="Calibri"/>
+              </a:rPr>
+              <a:t> pseudo-ID </a:t>
+            </a:r>
+            <a:r>
+              <a:rPr sz="1100" b="0" i="0" err="1">
+                <a:solidFill>
+                  <a:srgbClr val="1B223A"/>
+                </a:solidFill>
+                <a:latin typeface="Calibri"/>
+              </a:rPr>
+              <a:t>tvaru</a:t>
+            </a:r>
+            <a:r>
+              <a:rPr sz="1100" b="0" i="0">
+                <a:solidFill>
+                  <a:srgbClr val="1B223A"/>
+                </a:solidFill>
+                <a:latin typeface="Calibri"/>
+              </a:rPr>
+              <a:t> P-{hash(</a:t>
+            </a:r>
+            <a:r>
+              <a:rPr sz="1100" b="0" i="0" err="1">
+                <a:solidFill>
+                  <a:srgbClr val="1B223A"/>
+                </a:solidFill>
+                <a:latin typeface="Calibri"/>
+              </a:rPr>
+              <a:t>rodné_číslo</a:t>
+            </a:r>
+            <a:r>
+              <a:rPr sz="1100" b="0" i="0">
+                <a:solidFill>
+                  <a:srgbClr val="1B223A"/>
+                </a:solidFill>
+                <a:latin typeface="Calibri"/>
+              </a:rPr>
+              <a:t>)[:8]}.</a:t>
             </a:r>
           </a:p>
           <a:p>
@@ -29925,13 +30654,148 @@
               </a:spcAft>
             </a:pPr>
             <a:r>
+              <a:rPr sz="1100" b="0" i="0" err="1">
+                <a:solidFill>
+                  <a:srgbClr val="1B223A"/>
+                </a:solidFill>
+                <a:latin typeface="Calibri"/>
+              </a:rPr>
+              <a:t>Druhá</a:t>
+            </a:r>
+            <a:r>
               <a:rPr sz="1100" b="0" i="0">
                 <a:solidFill>
                   <a:srgbClr val="1B223A"/>
                 </a:solidFill>
                 <a:latin typeface="Calibri"/>
               </a:rPr>
-              <a:t>Druhá fáze: CONSOLIDATE napříč všemi pacienty pro kontrolu duplikátů přes pseudo-ID.</a:t>
+              <a:t> </a:t>
+            </a:r>
+            <a:r>
+              <a:rPr sz="1100" b="0" i="0" err="1">
+                <a:solidFill>
+                  <a:srgbClr val="1B223A"/>
+                </a:solidFill>
+                <a:latin typeface="Calibri"/>
+              </a:rPr>
+              <a:t>fáze</a:t>
+            </a:r>
+            <a:r>
+              <a:rPr sz="1100" b="0" i="0">
+                <a:solidFill>
+                  <a:srgbClr val="1B223A"/>
+                </a:solidFill>
+                <a:latin typeface="Calibri"/>
+              </a:rPr>
+              <a:t>: CONSOLIDATE </a:t>
+            </a:r>
+            <a:r>
+              <a:rPr sz="1100" b="0" i="0" err="1">
+                <a:solidFill>
+                  <a:srgbClr val="1B223A"/>
+                </a:solidFill>
+                <a:latin typeface="Calibri"/>
+              </a:rPr>
+              <a:t>napříč</a:t>
+            </a:r>
+            <a:r>
+              <a:rPr sz="1100" b="0" i="0">
+                <a:solidFill>
+                  <a:srgbClr val="1B223A"/>
+                </a:solidFill>
+                <a:latin typeface="Calibri"/>
+              </a:rPr>
+              <a:t> </a:t>
+            </a:r>
+            <a:r>
+              <a:rPr sz="1100" b="0" i="0" err="1">
+                <a:solidFill>
+                  <a:srgbClr val="1B223A"/>
+                </a:solidFill>
+                <a:latin typeface="Calibri"/>
+              </a:rPr>
+              <a:t>všemi</a:t>
+            </a:r>
+            <a:r>
+              <a:rPr sz="1100" b="0" i="0">
+                <a:solidFill>
+                  <a:srgbClr val="1B223A"/>
+                </a:solidFill>
+                <a:latin typeface="Calibri"/>
+              </a:rPr>
+              <a:t> </a:t>
+            </a:r>
+            <a:r>
+              <a:rPr sz="1100" b="0" i="0" err="1">
+                <a:solidFill>
+                  <a:srgbClr val="1B223A"/>
+                </a:solidFill>
+                <a:latin typeface="Calibri"/>
+              </a:rPr>
+              <a:t>pacienty</a:t>
+            </a:r>
+            <a:r>
+              <a:rPr sz="1100" b="0" i="0">
+                <a:solidFill>
+                  <a:srgbClr val="1B223A"/>
+                </a:solidFill>
+                <a:latin typeface="Calibri"/>
+              </a:rPr>
+              <a:t> pro </a:t>
+            </a:r>
+            <a:r>
+              <a:rPr sz="1100" b="0" i="0" err="1">
+                <a:solidFill>
+                  <a:srgbClr val="1B223A"/>
+                </a:solidFill>
+                <a:latin typeface="Calibri"/>
+              </a:rPr>
+              <a:t>kontrolu</a:t>
+            </a:r>
+            <a:r>
+              <a:rPr sz="1100" b="0" i="0">
+                <a:solidFill>
+                  <a:srgbClr val="1B223A"/>
+                </a:solidFill>
+                <a:latin typeface="Calibri"/>
+              </a:rPr>
+              <a:t> </a:t>
+            </a:r>
+            <a:r>
+              <a:rPr sz="1100" b="0" i="0" err="1">
+                <a:solidFill>
+                  <a:srgbClr val="1B223A"/>
+                </a:solidFill>
+                <a:latin typeface="Calibri"/>
+              </a:rPr>
+              <a:t>duplikátů</a:t>
+            </a:r>
+            <a:r>
+              <a:rPr sz="1100" b="0" i="0">
+                <a:solidFill>
+                  <a:srgbClr val="1B223A"/>
+                </a:solidFill>
+                <a:latin typeface="Calibri"/>
+              </a:rPr>
+              <a:t> </a:t>
+            </a:r>
+            <a:r>
+              <a:rPr sz="1100" b="0" i="0" err="1">
+                <a:solidFill>
+                  <a:srgbClr val="1B223A"/>
+                </a:solidFill>
+                <a:latin typeface="Calibri"/>
+              </a:rPr>
+              <a:t>přes</a:t>
+            </a:r>
+            <a:r>
+              <a:rPr sz="1100" b="0" i="0">
+                <a:solidFill>
+                  <a:srgbClr val="1B223A"/>
+                </a:solidFill>
+                <a:latin typeface="Calibri"/>
+              </a:rPr>
+              <a:t> pseudo-ID.</a:t>
             </a:r>
           </a:p>
         </p:txBody>
@@ -30872,7 +31736,7 @@
           <a:lstStyle/>
           <a:p>
             <a:pPr algn="ctr"/>
-            <a:endParaRPr/>
+            <a:endParaRPr lang="cs-CZ" noProof="1"/>
           </a:p>
         </p:txBody>
       </p:sp>
@@ -30917,7 +31781,7 @@
           <a:lstStyle/>
           <a:p>
             <a:pPr algn="ctr"/>
-            <a:endParaRPr/>
+            <a:endParaRPr lang="cs-CZ" noProof="1"/>
           </a:p>
         </p:txBody>
       </p:sp>
@@ -30945,7 +31809,7 @@
           <a:p>
             <a:pPr algn="l"/>
             <a:r>
-              <a:rPr sz="3000" b="1" i="0">
+              <a:rPr lang="cs-CZ" sz="3000" b="1" i="0" noProof="1">
                 <a:solidFill>
                   <a:srgbClr val="21295C"/>
                 </a:solidFill>
@@ -30980,7 +31844,7 @@
           <a:p>
             <a:pPr algn="l"/>
             <a:r>
-              <a:rPr sz="1400" b="0" i="1">
+              <a:rPr lang="cs-CZ" sz="1400" b="0" i="1" noProof="1">
                 <a:solidFill>
                   <a:srgbClr val="1C7293"/>
                 </a:solidFill>
@@ -31015,7 +31879,7 @@
           <a:p>
             <a:pPr algn="r"/>
             <a:r>
-              <a:rPr sz="1000" b="0" i="0">
+              <a:rPr lang="cs-CZ" sz="1000" b="0" i="0" noProof="1">
                 <a:solidFill>
                   <a:srgbClr val="5C6B82"/>
                 </a:solidFill>
@@ -31050,7 +31914,7 @@
           <a:p>
             <a:pPr algn="l"/>
             <a:r>
-              <a:rPr sz="1000" b="0" i="0">
+              <a:rPr lang="cs-CZ" sz="1000" b="0" i="0" noProof="1">
                 <a:solidFill>
                   <a:srgbClr val="5C6B82"/>
                 </a:solidFill>
@@ -31104,7 +31968,7 @@
           <a:lstStyle/>
           <a:p>
             <a:pPr algn="ctr"/>
-            <a:endParaRPr/>
+            <a:endParaRPr lang="cs-CZ" noProof="1"/>
           </a:p>
         </p:txBody>
       </p:sp>
@@ -31132,7 +31996,7 @@
           <a:p>
             <a:pPr algn="l"/>
             <a:r>
-              <a:rPr sz="4200" b="1" i="0">
+              <a:rPr lang="cs-CZ" sz="4200" b="1" i="0" noProof="1">
                 <a:solidFill>
                   <a:srgbClr val="106E55"/>
                 </a:solidFill>
@@ -31167,7 +32031,7 @@
           <a:p>
             <a:pPr algn="l"/>
             <a:r>
-              <a:rPr sz="1800" b="1" i="0">
+              <a:rPr lang="cs-CZ" sz="1800" b="1" i="0" noProof="1">
                 <a:solidFill>
                   <a:srgbClr val="21295C"/>
                 </a:solidFill>
@@ -31219,7 +32083,7 @@
           <a:lstStyle/>
           <a:p>
             <a:pPr algn="ctr"/>
-            <a:endParaRPr/>
+            <a:endParaRPr lang="cs-CZ" noProof="1"/>
           </a:p>
         </p:txBody>
       </p:sp>
@@ -31254,7 +32118,7 @@
               </a:spcAft>
             </a:pPr>
             <a:r>
-              <a:rPr sz="1200" b="0" i="0">
+              <a:rPr lang="cs-CZ" sz="1200" b="0" i="0" noProof="1">
                 <a:solidFill>
                   <a:srgbClr val="1B223A"/>
                 </a:solidFill>
@@ -31308,7 +32172,7 @@
           <a:lstStyle/>
           <a:p>
             <a:pPr algn="ctr"/>
-            <a:endParaRPr/>
+            <a:endParaRPr lang="cs-CZ" noProof="1"/>
           </a:p>
         </p:txBody>
       </p:sp>
@@ -31336,7 +32200,7 @@
           <a:p>
             <a:pPr algn="l"/>
             <a:r>
-              <a:rPr sz="4200" b="1" i="0">
+              <a:rPr lang="cs-CZ" sz="4200" b="1" i="0" noProof="1">
                 <a:solidFill>
                   <a:srgbClr val="9C4A1B"/>
                 </a:solidFill>
@@ -31371,7 +32235,7 @@
           <a:p>
             <a:pPr algn="l"/>
             <a:r>
-              <a:rPr sz="1800" b="1" i="0">
+              <a:rPr lang="cs-CZ" sz="1800" b="1" i="0" noProof="1">
                 <a:solidFill>
                   <a:srgbClr val="21295C"/>
                 </a:solidFill>
@@ -31423,7 +32287,7 @@
           <a:lstStyle/>
           <a:p>
             <a:pPr algn="ctr"/>
-            <a:endParaRPr/>
+            <a:endParaRPr lang="cs-CZ" noProof="1"/>
           </a:p>
         </p:txBody>
       </p:sp>
@@ -31458,7 +32322,7 @@
               </a:spcAft>
             </a:pPr>
             <a:r>
-              <a:rPr sz="1200" b="0" i="0">
+              <a:rPr lang="cs-CZ" sz="1200" b="0" i="0" noProof="1">
                 <a:solidFill>
                   <a:srgbClr val="1B223A"/>
                 </a:solidFill>
@@ -31512,7 +32376,7 @@
           <a:lstStyle/>
           <a:p>
             <a:pPr algn="ctr"/>
-            <a:endParaRPr/>
+            <a:endParaRPr lang="cs-CZ" noProof="1"/>
           </a:p>
         </p:txBody>
       </p:sp>
@@ -31540,7 +32404,7 @@
           <a:p>
             <a:pPr algn="l"/>
             <a:r>
-              <a:rPr sz="4200" b="1" i="0">
+              <a:rPr lang="cs-CZ" sz="4200" b="1" i="0" noProof="1">
                 <a:solidFill>
                   <a:srgbClr val="065A82"/>
                 </a:solidFill>
@@ -31575,7 +32439,7 @@
           <a:p>
             <a:pPr algn="l"/>
             <a:r>
-              <a:rPr sz="1800" b="1" i="0">
+              <a:rPr lang="cs-CZ" sz="1800" b="1" i="0" noProof="1">
                 <a:solidFill>
                   <a:srgbClr val="21295C"/>
                 </a:solidFill>
@@ -31627,7 +32491,7 @@
           <a:lstStyle/>
           <a:p>
             <a:pPr algn="ctr"/>
-            <a:endParaRPr/>
+            <a:endParaRPr lang="cs-CZ" noProof="1"/>
           </a:p>
         </p:txBody>
       </p:sp>
@@ -31662,7 +32526,7 @@
               </a:spcAft>
             </a:pPr>
             <a:r>
-              <a:rPr sz="1200" b="0" i="0">
+              <a:rPr lang="cs-CZ" sz="1200" b="0" i="0" noProof="1">
                 <a:solidFill>
                   <a:srgbClr val="1B223A"/>
                 </a:solidFill>
@@ -31716,7 +32580,7 @@
           <a:lstStyle/>
           <a:p>
             <a:pPr algn="ctr"/>
-            <a:endParaRPr/>
+            <a:endParaRPr lang="cs-CZ" noProof="1"/>
           </a:p>
         </p:txBody>
       </p:sp>
@@ -31744,7 +32608,7 @@
           <a:p>
             <a:pPr algn="l"/>
             <a:r>
-              <a:rPr sz="4200" b="1" i="0">
+              <a:rPr lang="cs-CZ" sz="4200" b="1" i="0" noProof="1">
                 <a:solidFill>
                   <a:srgbClr val="1C7293"/>
                 </a:solidFill>
@@ -31779,7 +32643,7 @@
           <a:p>
             <a:pPr algn="l"/>
             <a:r>
-              <a:rPr sz="1800" b="1" i="0">
+              <a:rPr lang="cs-CZ" sz="1800" b="1" i="0" noProof="1">
                 <a:solidFill>
                   <a:srgbClr val="21295C"/>
                 </a:solidFill>
@@ -31831,7 +32695,7 @@
           <a:lstStyle/>
           <a:p>
             <a:pPr algn="ctr"/>
-            <a:endParaRPr/>
+            <a:endParaRPr lang="cs-CZ" noProof="1"/>
           </a:p>
         </p:txBody>
       </p:sp>
@@ -31866,7 +32730,7 @@
               </a:spcAft>
             </a:pPr>
             <a:r>
-              <a:rPr sz="1200" b="0" i="0">
+              <a:rPr lang="cs-CZ" sz="1200" b="0" i="0" noProof="1">
                 <a:solidFill>
                   <a:srgbClr val="1B223A"/>
                 </a:solidFill>
@@ -31920,7 +32784,7 @@
           <a:lstStyle/>
           <a:p>
             <a:pPr algn="ctr"/>
-            <a:endParaRPr/>
+            <a:endParaRPr lang="cs-CZ" noProof="1"/>
           </a:p>
         </p:txBody>
       </p:sp>
@@ -31948,7 +32812,7 @@
           <a:p>
             <a:pPr algn="l"/>
             <a:r>
-              <a:rPr sz="4200" b="1" i="0">
+              <a:rPr lang="cs-CZ" sz="4200" b="1" i="0" noProof="1">
                 <a:solidFill>
                   <a:srgbClr val="6E3A6B"/>
                 </a:solidFill>
@@ -31983,7 +32847,7 @@
           <a:p>
             <a:pPr algn="l"/>
             <a:r>
-              <a:rPr sz="1800" b="1" i="0">
+              <a:rPr lang="cs-CZ" sz="1800" b="1" i="0" noProof="1">
                 <a:solidFill>
                   <a:srgbClr val="21295C"/>
                 </a:solidFill>
@@ -32035,7 +32899,7 @@
           <a:lstStyle/>
           <a:p>
             <a:pPr algn="ctr"/>
-            <a:endParaRPr/>
+            <a:endParaRPr lang="cs-CZ" noProof="1"/>
           </a:p>
         </p:txBody>
       </p:sp>
@@ -32048,7 +32912,7 @@
         <p:spPr>
           <a:xfrm>
             <a:off x="4599432" y="5532120"/>
-            <a:ext cx="3246120" cy="640080"/>
+            <a:ext cx="3246120" cy="751616"/>
           </a:xfrm>
           <a:prstGeom prst="rect">
             <a:avLst/>
@@ -32070,13 +32934,13 @@
               </a:spcAft>
             </a:pPr>
             <a:r>
-              <a:rPr sz="1200" b="0" i="0">
+              <a:rPr lang="cs-CZ" sz="1200" b="0" i="0" noProof="1">
                 <a:solidFill>
                   <a:srgbClr val="1B223A"/>
                 </a:solidFill>
                 <a:latin typeface="Calibri"/>
               </a:rPr>
-              <a:t>OpenAI-kompatibilní API: lze přepnout mezi LM Studio, MLX, v budoucnu vlastní backend. Promptu zůstávají stejné.</a:t>
+              <a:t>OpenAI-kompatibilní API: lze přepnout mezi LM Studio, MLX, v budoucnu vlastní backend. Prompty zůstávají stejné.</a:t>
             </a:r>
           </a:p>
         </p:txBody>
@@ -32124,7 +32988,7 @@
           <a:lstStyle/>
           <a:p>
             <a:pPr algn="ctr"/>
-            <a:endParaRPr/>
+            <a:endParaRPr lang="cs-CZ" noProof="1"/>
           </a:p>
         </p:txBody>
       </p:sp>
@@ -32152,7 +33016,7 @@
           <a:p>
             <a:pPr algn="l"/>
             <a:r>
-              <a:rPr sz="4200" b="1" i="0">
+              <a:rPr lang="cs-CZ" sz="4200" b="1" i="0" noProof="1">
                 <a:solidFill>
                   <a:srgbClr val="1F4F7A"/>
                 </a:solidFill>
@@ -32187,7 +33051,7 @@
           <a:p>
             <a:pPr algn="l"/>
             <a:r>
-              <a:rPr sz="1800" b="1" i="0">
+              <a:rPr lang="cs-CZ" sz="1800" b="1" i="0" noProof="1">
                 <a:solidFill>
                   <a:srgbClr val="21295C"/>
                 </a:solidFill>
@@ -32239,7 +33103,7 @@
           <a:lstStyle/>
           <a:p>
             <a:pPr algn="ctr"/>
-            <a:endParaRPr/>
+            <a:endParaRPr lang="cs-CZ" noProof="1"/>
           </a:p>
         </p:txBody>
       </p:sp>
@@ -32274,7 +33138,7 @@
               </a:spcAft>
             </a:pPr>
             <a:r>
-              <a:rPr sz="1200" b="0" i="0">
+              <a:rPr lang="cs-CZ" sz="1200" b="0" i="0" noProof="1">
                 <a:solidFill>
                   <a:srgbClr val="1B223A"/>
                 </a:solidFill>

</xml_diff>